<commit_message>
Align final PMDD poster with the approved APHA abstract
Uses the abstract's full-text-reviewed study flow (1,943 records, 325
duplicates, 1,618 screened, 64 full text, 44 included), outcome counts
and LMIC figures on the earlier poster layout.

Co-Authored-By: Claude Opus 5.5 <noreply@anthropic.com>
Claude-Session: https://claude.ai/code/session_01VkRRDHxfMApHVBQgQibkFd
</commit_message>
<xml_diff>
--- a/PMDD_Scoping_Review/PMDD_APHA_Poster_FINAL.pptx
+++ b/PMDD_Scoping_Review/PMDD_APHA_Poster_FINAL.pptx
@@ -144,7 +144,7 @@
             </a:solidFill>
           </c:spPr>
           <c:dPt>
-            <c:idx val="1"/>
+            <c:idx val="0"/>
             <c:spPr>
               <a:solidFill>
                 <a:srgbClr val="A31F34"/>
@@ -153,46 +153,25 @@
           </c:dPt>
           <c:cat>
             <c:strRef>
-              <c:f>Sheet1!$A$2:$A$14</c:f>
+              <c:f>Sheet1!$A$2:$A$7</c:f>
               <c:strCache>
-                <c:ptCount val="13"/>
+                <c:ptCount val="6"/>
                 <c:pt idx="0">
-                  <c:v>Lived experience / help-seeking</c:v>
+                  <c:v>Coping mechanisms</c:v>
                 </c:pt>
                 <c:pt idx="1">
-                  <c:v>Coping mechanisms</c:v>
+                  <c:v>Quality of life</c:v>
                 </c:pt>
                 <c:pt idx="2">
-                  <c:v>Trauma &amp; adversity</c:v>
+                  <c:v>Suicidal ideation or self-harm</c:v>
                 </c:pt>
                 <c:pt idx="3">
-                  <c:v>Personality &amp; temperament</c:v>
+                  <c:v>Interpersonal functioning</c:v>
                 </c:pt>
                 <c:pt idx="4">
-                  <c:v>Quality of life</c:v>
+                  <c:v>Psychological distress</c:v>
                 </c:pt>
                 <c:pt idx="5">
-                  <c:v>Interpersonal functioning</c:v>
-                </c:pt>
-                <c:pt idx="6">
-                  <c:v>Anxiety</c:v>
-                </c:pt>
-                <c:pt idx="7">
-                  <c:v>Suicidal ideation / self-harm</c:v>
-                </c:pt>
-                <c:pt idx="8">
-                  <c:v>Academic / occupational</c:v>
-                </c:pt>
-                <c:pt idx="9">
-                  <c:v>Psychological distress</c:v>
-                </c:pt>
-                <c:pt idx="10">
-                  <c:v>Mood &amp; emotion regulation</c:v>
-                </c:pt>
-                <c:pt idx="11">
-                  <c:v>Psychiatric comorbidity</c:v>
-                </c:pt>
-                <c:pt idx="12">
                   <c:v>Depression</c:v>
                 </c:pt>
               </c:strCache>
@@ -200,48 +179,27 @@
           </c:cat>
           <c:val>
             <c:numRef>
-              <c:f>Sheet1!$B$2:$B$14</c:f>
+              <c:f>Sheet1!$B$2:$B$7</c:f>
               <c:numCache>
                 <c:formatCode>General</c:formatCode>
-                <c:ptCount val="13"/>
+                <c:ptCount val="6"/>
                 <c:pt idx="0">
-                  <c:v>5</c:v>
+                  <c:v>3</c:v>
                 </c:pt>
                 <c:pt idx="1">
-                  <c:v>7</c:v>
+                  <c:v>14</c:v>
                 </c:pt>
                 <c:pt idx="2">
-                  <c:v>7</c:v>
+                  <c:v>14</c:v>
                 </c:pt>
                 <c:pt idx="3">
-                  <c:v>7</c:v>
+                  <c:v>18</c:v>
                 </c:pt>
                 <c:pt idx="4">
-                  <c:v>8</c:v>
+                  <c:v>24</c:v>
                 </c:pt>
                 <c:pt idx="5">
-                  <c:v>12</c:v>
-                </c:pt>
-                <c:pt idx="6">
-                  <c:v>13</c:v>
-                </c:pt>
-                <c:pt idx="7">
-                  <c:v>13</c:v>
-                </c:pt>
-                <c:pt idx="8">
-                  <c:v>13</c:v>
-                </c:pt>
-                <c:pt idx="9">
-                  <c:v>16</c:v>
-                </c:pt>
-                <c:pt idx="10">
-                  <c:v>18</c:v>
-                </c:pt>
-                <c:pt idx="11">
-                  <c:v>18</c:v>
-                </c:pt>
-                <c:pt idx="12">
-                  <c:v>28</c:v>
+                  <c:v>39</c:v>
                 </c:pt>
               </c:numCache>
             </c:numRef>
@@ -253,7 +211,7 @@
             <a:lstStyle/>
             <a:p>
               <a:pPr>
-                <a:defRPr sz="420" b="1">
+                <a:defRPr sz="459" b="1">
                   <a:latin typeface="Times New Roman"/>
                 </a:defRPr>
               </a:pPr>
@@ -268,7 +226,7 @@
           <c:showBubbleSize val="0"/>
           <c:showLeaderLines val="1"/>
         </c:dLbls>
-        <c:gapWidth val="40"/>
+        <c:gapWidth val="45"/>
         <c:axId val="-2068027336"/>
         <c:axId val="-2113994440"/>
       </c:barChart>
@@ -294,7 +252,7 @@
           <a:lstStyle/>
           <a:p>
             <a:pPr>
-              <a:defRPr sz="420"/>
+              <a:defRPr sz="459"/>
             </a:pPr>
           </a:p>
         </c:txPr>
@@ -308,7 +266,7 @@
       <c:valAx>
         <c:axId val="-2113994440"/>
         <c:scaling>
-          <c:max val="31.0"/>
+          <c:max val="44.0"/>
           <c:min val="0.0"/>
         </c:scaling>
         <c:delete/>
@@ -327,7 +285,7 @@
     <a:lstStyle/>
     <a:p>
       <a:pPr>
-        <a:defRPr sz="420">
+        <a:defRPr sz="459">
           <a:solidFill>
             <a:srgbClr val="111827"/>
           </a:solidFill>
@@ -381,65 +339,29 @@
           </c:dPt>
           <c:cat>
             <c:strRef>
-              <c:f>Sheet1!$A$2:$A$9</c:f>
+              <c:f>Sheet1!$A$2:$A$3</c:f>
               <c:strCache>
-                <c:ptCount val="8"/>
+                <c:ptCount val="2"/>
                 <c:pt idx="0">
-                  <c:v>South Asia</c:v>
+                  <c:v>High-income / other settings</c:v>
                 </c:pt>
                 <c:pt idx="1">
-                  <c:v>Sub-Saharan Africa</c:v>
-                </c:pt>
-                <c:pt idx="2">
-                  <c:v>Latin America &amp; Caribbean</c:v>
-                </c:pt>
-                <c:pt idx="3">
-                  <c:v>Online / multinational / NR</c:v>
-                </c:pt>
-                <c:pt idx="4">
-                  <c:v>Middle East &amp; North Africa</c:v>
-                </c:pt>
-                <c:pt idx="5">
-                  <c:v>North America</c:v>
-                </c:pt>
-                <c:pt idx="6">
-                  <c:v>East Asia &amp; Pacific</c:v>
-                </c:pt>
-                <c:pt idx="7">
-                  <c:v>Europe &amp; Central Asia</c:v>
+                  <c:v>Low- and middle-income countries</c:v>
                 </c:pt>
               </c:strCache>
             </c:strRef>
           </c:cat>
           <c:val>
             <c:numRef>
-              <c:f>Sheet1!$B$2:$B$9</c:f>
+              <c:f>Sheet1!$B$2:$B$3</c:f>
               <c:numCache>
                 <c:formatCode>General</c:formatCode>
-                <c:ptCount val="8"/>
+                <c:ptCount val="2"/>
                 <c:pt idx="0">
-                  <c:v>1</c:v>
+                  <c:v>41</c:v>
                 </c:pt>
                 <c:pt idx="1">
                   <c:v>3</c:v>
-                </c:pt>
-                <c:pt idx="2">
-                  <c:v>3</c:v>
-                </c:pt>
-                <c:pt idx="3">
-                  <c:v>7</c:v>
-                </c:pt>
-                <c:pt idx="4">
-                  <c:v>10</c:v>
-                </c:pt>
-                <c:pt idx="5">
-                  <c:v>15</c:v>
-                </c:pt>
-                <c:pt idx="6">
-                  <c:v>17</c:v>
-                </c:pt>
-                <c:pt idx="7">
-                  <c:v>29</c:v>
                 </c:pt>
               </c:numCache>
             </c:numRef>
@@ -451,7 +373,7 @@
             <a:lstStyle/>
             <a:p>
               <a:pPr>
-                <a:defRPr sz="420" b="1">
+                <a:defRPr sz="500" b="1">
                   <a:latin typeface="Times New Roman"/>
                 </a:defRPr>
               </a:pPr>
@@ -466,7 +388,7 @@
           <c:showBubbleSize val="0"/>
           <c:showLeaderLines val="1"/>
         </c:dLbls>
-        <c:gapWidth val="40"/>
+        <c:gapWidth val="45"/>
         <c:axId val="-2068027336"/>
         <c:axId val="-2113994440"/>
       </c:barChart>
@@ -492,7 +414,7 @@
           <a:lstStyle/>
           <a:p>
             <a:pPr>
-              <a:defRPr sz="420"/>
+              <a:defRPr sz="500"/>
             </a:pPr>
           </a:p>
         </c:txPr>
@@ -506,7 +428,7 @@
       <c:valAx>
         <c:axId val="-2113994440"/>
         <c:scaling>
-          <c:max val="33.0"/>
+          <c:max val="48.0"/>
           <c:min val="0.0"/>
         </c:scaling>
         <c:delete/>
@@ -525,219 +447,7 @@
     <a:lstStyle/>
     <a:p>
       <a:pPr>
-        <a:defRPr sz="420">
-          <a:solidFill>
-            <a:srgbClr val="111827"/>
-          </a:solidFill>
-          <a:latin typeface="Times New Roman"/>
-        </a:defRPr>
-      </a:pPr>
-      <a:endParaRPr lang="en-US"/>
-    </a:p>
-  </c:txPr>
-  <c:externalData r:id="rId1">
-    <c:autoUpdate val="0"/>
-  </c:externalData>
-</c:chartSpace>
-</file>
-
-<file path=ppt/charts/chart3.xml><?xml version="1.0" encoding="utf-8"?>
-<c:chartSpace xmlns:c="http://schemas.openxmlformats.org/drawingml/2006/chart" xmlns:a="http://schemas.openxmlformats.org/drawingml/2006/main" xmlns:r="http://schemas.openxmlformats.org/officeDocument/2006/relationships">
-  <c:date1904 val="0"/>
-  <c:chart>
-    <c:autoTitleDeleted val="1"/>
-    <c:plotArea>
-      <c:barChart>
-        <c:barDir val="col"/>
-        <c:grouping val="clustered"/>
-        <c:ser>
-          <c:idx val="0"/>
-          <c:order val="0"/>
-          <c:tx>
-            <c:strRef>
-              <c:f>Sheet1!$B$1</c:f>
-              <c:strCache>
-                <c:ptCount val="1"/>
-                <c:pt idx="0">
-                  <c:v>Studies</c:v>
-                </c:pt>
-              </c:strCache>
-            </c:strRef>
-          </c:tx>
-          <c:spPr>
-            <a:solidFill>
-              <a:srgbClr val="0A254E"/>
-            </a:solidFill>
-          </c:spPr>
-          <c:dPt>
-            <c:idx val="0"/>
-            <c:spPr>
-              <a:solidFill>
-                <a:srgbClr val="0A254E"/>
-              </a:solidFill>
-            </c:spPr>
-          </c:dPt>
-          <c:dPt>
-            <c:idx val="1"/>
-            <c:spPr>
-              <a:solidFill>
-                <a:srgbClr val="A31F34"/>
-              </a:solidFill>
-            </c:spPr>
-          </c:dPt>
-          <c:dPt>
-            <c:idx val="2"/>
-            <c:spPr>
-              <a:solidFill>
-                <a:srgbClr val="A31F34"/>
-              </a:solidFill>
-            </c:spPr>
-          </c:dPt>
-          <c:dPt>
-            <c:idx val="3"/>
-            <c:spPr>
-              <a:solidFill>
-                <a:srgbClr val="A31F34"/>
-              </a:solidFill>
-            </c:spPr>
-          </c:dPt>
-          <c:dPt>
-            <c:idx val="4"/>
-            <c:spPr>
-              <a:solidFill>
-                <a:srgbClr val="9CA3AF"/>
-              </a:solidFill>
-            </c:spPr>
-          </c:dPt>
-          <c:cat>
-            <c:strRef>
-              <c:f>Sheet1!$A$2:$A$6</c:f>
-              <c:strCache>
-                <c:ptCount val="5"/>
-                <c:pt idx="0">
-                  <c:v>High</c:v>
-                </c:pt>
-                <c:pt idx="1">
-                  <c:v>Upper-middle</c:v>
-                </c:pt>
-                <c:pt idx="2">
-                  <c:v>Lower-middle</c:v>
-                </c:pt>
-                <c:pt idx="3">
-                  <c:v>Low</c:v>
-                </c:pt>
-                <c:pt idx="4">
-                  <c:v>Online / NR</c:v>
-                </c:pt>
-              </c:strCache>
-            </c:strRef>
-          </c:cat>
-          <c:val>
-            <c:numRef>
-              <c:f>Sheet1!$B$2:$B$6</c:f>
-              <c:numCache>
-                <c:formatCode>General</c:formatCode>
-                <c:ptCount val="5"/>
-                <c:pt idx="0">
-                  <c:v>57</c:v>
-                </c:pt>
-                <c:pt idx="1">
-                  <c:v>16</c:v>
-                </c:pt>
-                <c:pt idx="2">
-                  <c:v>3</c:v>
-                </c:pt>
-                <c:pt idx="3">
-                  <c:v>2</c:v>
-                </c:pt>
-                <c:pt idx="4">
-                  <c:v>7</c:v>
-                </c:pt>
-              </c:numCache>
-            </c:numRef>
-          </c:val>
-        </c:ser>
-        <c:dLbls>
-          <c:txPr>
-            <a:bodyPr/>
-            <a:lstStyle/>
-            <a:p>
-              <a:pPr>
-                <a:defRPr sz="420" b="1">
-                  <a:latin typeface="Times New Roman"/>
-                </a:defRPr>
-              </a:pPr>
-            </a:p>
-          </c:txPr>
-          <c:dLblPos val="outEnd"/>
-          <c:showLegendKey val="0"/>
-          <c:showVal val="1"/>
-          <c:showCatName val="0"/>
-          <c:showSerName val="0"/>
-          <c:showPercent val="0"/>
-          <c:showBubbleSize val="0"/>
-          <c:showLeaderLines val="1"/>
-        </c:dLbls>
-        <c:gapWidth val="40"/>
-        <c:axId val="-2068027336"/>
-        <c:axId val="-2113994440"/>
-      </c:barChart>
-      <c:catAx>
-        <c:axId val="-2068027336"/>
-        <c:scaling>
-          <c:orientation val="minMax"/>
-        </c:scaling>
-        <c:delete val="0"/>
-        <c:axPos val="b"/>
-        <c:majorTickMark val="out"/>
-        <c:minorTickMark val="none"/>
-        <c:tickLblPos val="nextTo"/>
-        <c:spPr>
-          <a:ln>
-            <a:solidFill>
-              <a:srgbClr val="9CA3AF"/>
-            </a:solidFill>
-          </a:ln>
-        </c:spPr>
-        <c:txPr>
-          <a:bodyPr/>
-          <a:lstStyle/>
-          <a:p>
-            <a:pPr>
-              <a:defRPr sz="420"/>
-            </a:pPr>
-          </a:p>
-        </c:txPr>
-        <c:crossAx val="-2113994440"/>
-        <c:crosses val="autoZero"/>
-        <c:auto val="1"/>
-        <c:lblAlgn val="ctr"/>
-        <c:lblOffset val="100"/>
-        <c:noMultiLvlLbl val="0"/>
-      </c:catAx>
-      <c:valAx>
-        <c:axId val="-2113994440"/>
-        <c:scaling>
-          <c:max val="65.0"/>
-          <c:min val="0.0"/>
-        </c:scaling>
-        <c:delete/>
-        <c:axPos val="l"/>
-        <c:majorTickMark val="out"/>
-        <c:minorTickMark val="none"/>
-        <c:tickLblPos val="nextTo"/>
-        <c:crossAx val="-2068027336"/>
-        <c:crosses val="autoZero"/>
-      </c:valAx>
-    </c:plotArea>
-    <c:dispBlanksAs val="gap"/>
-  </c:chart>
-  <c:txPr>
-    <a:bodyPr/>
-    <a:lstStyle/>
-    <a:p>
-      <a:pPr>
-        <a:defRPr sz="420">
+        <a:defRPr sz="500">
           <a:solidFill>
             <a:srgbClr val="111827"/>
           </a:solidFill>
@@ -7531,11 +7241,11 @@
           <a:p>
             <a:pPr algn="just">
               <a:spcAft>
-                <a:spcPts val="120"/>
+                <a:spcPts val="140"/>
               </a:spcAft>
             </a:pPr>
             <a:r>
-              <a:rPr sz="425" b="1" i="0">
+              <a:rPr sz="434" b="1" i="0">
                 <a:solidFill>
                   <a:srgbClr val="111827"/>
                 </a:solidFill>
@@ -7544,23 +7254,23 @@
               <a:t>Background: </a:t>
             </a:r>
             <a:r>
-              <a:rPr sz="425" b="0" i="0">
+              <a:rPr sz="434" b="0" i="0">
                 <a:solidFill>
                   <a:srgbClr val="111827"/>
                 </a:solidFill>
                 <a:latin typeface="Times New Roman"/>
               </a:rPr>
-              <a:t>Premenstrual dysphoric disorder (PMDD) is a DSM-5 depressive disorder affecting an estimated 1.6% of women and girls (~31 million) worldwide.¹ This scoping review mapped psychosocial outcomes and coping mechanisms among women with PMDD and the geographic distribution of the evidence.</a:t>
+              <a:t>Premenstrual dysphoric disorder (PMDD) is a DSM-5 depressive disorder affecting an estimated 31 million women and girls worldwide.¹ This scoping review examined psychosocial outcomes and coping mechanisms among women with PMDD and assessed the geographic distribution of the evidence.</a:t>
             </a:r>
           </a:p>
           <a:p>
             <a:pPr algn="just">
               <a:spcAft>
-                <a:spcPts val="120"/>
+                <a:spcPts val="140"/>
               </a:spcAft>
             </a:pPr>
             <a:r>
-              <a:rPr sz="425" b="1" i="0">
+              <a:rPr sz="434" b="1" i="0">
                 <a:solidFill>
                   <a:srgbClr val="111827"/>
                 </a:solidFill>
@@ -7569,23 +7279,23 @@
               <a:t>Methods: </a:t>
             </a:r>
             <a:r>
-              <a:rPr sz="425" b="0" i="0">
+              <a:rPr sz="434" b="0" i="0">
                 <a:solidFill>
                   <a:srgbClr val="111827"/>
                 </a:solidFill>
                 <a:latin typeface="Times New Roman"/>
               </a:rPr>
-              <a:t>Following Arksey and O’Malley’s framework and PRISMA-ScR, records from CINAHL, APA PsycInfo, APA PsycArticles, MEDLINE, Women’s Studies International, PubMed and the Cochrane Library (2010–2025) were screened. Eligible peer-reviewed empirical or qualitative studies had PMDD as the population and a psychosocial outcome or coping mechanism as a primary aim.</a:t>
+              <a:t>Following Arksey and O’Malley’s framework and PRISMA-ScR guidance, we searched PubMed/MEDLINE, CINAHL, APA PsycInfo, APA PsycArticles and the Cochrane Library for peer-reviewed studies published 2010–2025. Eligible empirical and qualitative studies had PMDD as the primary population and at least one psychosocial outcome or coping mechanism as a primary aim.</a:t>
             </a:r>
           </a:p>
           <a:p>
             <a:pPr algn="just">
               <a:spcAft>
-                <a:spcPts val="120"/>
+                <a:spcPts val="140"/>
               </a:spcAft>
             </a:pPr>
             <a:r>
-              <a:rPr sz="425" b="1" i="0">
+              <a:rPr sz="434" b="1" i="0">
                 <a:solidFill>
                   <a:srgbClr val="111827"/>
                 </a:solidFill>
@@ -7594,23 +7304,23 @@
               <a:t>Results: </a:t>
             </a:r>
             <a:r>
-              <a:rPr sz="425" b="0" i="0">
+              <a:rPr sz="434" b="0" i="0">
                 <a:solidFill>
                   <a:srgbClr val="111827"/>
                 </a:solidFill>
                 <a:latin typeface="Times New Roman"/>
               </a:rPr>
-              <a:t>Of 1,801 records, 342 were duplicates; 1,459 were screened and 85 studies were included. Most studied were depression (n=28), mood and emotion regulation (n=18), psychiatric comorbidity (n=18), psychological distress (n=16) and suicidal ideation or self-harm (n=13); only 7 studies examined coping. Two-thirds (67%) came from high-income countries; 3 (3.5%) came from sub-Saharan Africa (Ethiopia, n=2; Nigeria, n=1).</a:t>
+              <a:t>The search identified 1,943 records; 1,618 remained after deduplication and 44 studies met the inclusion criteria. Depression was most documented (n=39), followed by psychological distress (n=24), interpersonal functioning (n=18), suicidal ideation or self-harm (n=14) and quality of life (n=14). Only three studies examined coping mechanisms. Three studies (6.8%) originated from low- and middle-income countries (LMICs), including one from Nigeria.</a:t>
             </a:r>
           </a:p>
           <a:p>
             <a:pPr algn="just">
               <a:spcAft>
-                <a:spcPts val="120"/>
+                <a:spcPts val="140"/>
               </a:spcAft>
             </a:pPr>
             <a:r>
-              <a:rPr sz="425" b="1" i="0">
+              <a:rPr sz="434" b="1" i="0">
                 <a:solidFill>
                   <a:srgbClr val="111827"/>
                 </a:solidFill>
@@ -7619,23 +7329,23 @@
               <a:t>Conclusions: </a:t>
             </a:r>
             <a:r>
-              <a:rPr sz="425" b="0" i="0">
+              <a:rPr sz="434" b="0" i="0">
                 <a:solidFill>
                   <a:srgbClr val="111827"/>
                 </a:solidFill>
                 <a:latin typeface="Times New Roman"/>
               </a:rPr>
-              <a:t>Evidence on the psychosocial burden of PMDD is growing but is concentrated in high-income settings, relies on provisional diagnoses and rarely addresses coping.</a:t>
+              <a:t>Evidence on PMDD’s psychosocial burden is growing but geographically concentrated in high-income countries, revealing a critical LMIC evidence gap.</a:t>
             </a:r>
           </a:p>
           <a:p>
             <a:pPr algn="just">
               <a:spcAft>
-                <a:spcPts val="120"/>
+                <a:spcPts val="140"/>
               </a:spcAft>
             </a:pPr>
             <a:r>
-              <a:rPr sz="425" b="1" i="0">
+              <a:rPr sz="434" b="1" i="0">
                 <a:solidFill>
                   <a:srgbClr val="111827"/>
                 </a:solidFill>
@@ -7644,7 +7354,7 @@
               <a:t>Keywords: </a:t>
             </a:r>
             <a:r>
-              <a:rPr sz="425" b="0" i="1">
+              <a:rPr sz="434" b="0" i="1">
                 <a:solidFill>
                   <a:srgbClr val="111827"/>
                 </a:solidFill>
@@ -8034,7 +7744,7 @@
                           </a:solidFill>
                           <a:latin typeface="Times New Roman"/>
                         </a:rPr>
-                        <a:t>CINAHL Ultimate, APA PsycInfo, APA PsycArticles, MEDLINE Ultimate, Women’s Studies International, PubMed/MEDLINE and Cochrane Library.</a:t>
+                        <a:t>PubMed/MEDLINE, CINAHL, APA PsycInfo, APA PsycArticles and Cochrane Library.</a:t>
                       </a:r>
                     </a:p>
                   </a:txBody>
@@ -8080,7 +7790,7 @@
                           </a:solidFill>
                           <a:latin typeface="Times New Roman"/>
                         </a:rPr>
-                        <a:t>2010–2025; English language.</a:t>
+                        <a:t>2010–2025.</a:t>
                       </a:r>
                     </a:p>
                   </a:txBody>
@@ -8126,7 +7836,7 @@
                           </a:solidFill>
                           <a:latin typeface="Times New Roman"/>
                         </a:rPr>
-                        <a:t>Peer-reviewed empirical or qualitative studies with PMDD (provisional or confirmed) as the study population and ≥1 psychosocial outcome or coping mechanism as a primary aim.</a:t>
+                        <a:t>Peer-reviewed empirical or qualitative studies with PMDD as the primary population and at least one psychosocial outcome or coping mechanism as a primary aim.</a:t>
                       </a:r>
                     </a:p>
                   </a:txBody>
@@ -8172,7 +7882,7 @@
                           </a:solidFill>
                           <a:latin typeface="Times New Roman"/>
                         </a:rPr>
-                        <a:t>Animal, laboratory/biological, intervention, review, instrument-validation and case-report studies; non-peer-reviewed publications; PMS-only samples.</a:t>
+                        <a:t>Animal studies, laboratory research, reviews, interventions and non-peer-reviewed publications.</a:t>
                       </a:r>
                     </a:p>
                   </a:txBody>
@@ -8218,7 +7928,7 @@
                           </a:solidFill>
                           <a:latin typeface="Times New Roman"/>
                         </a:rPr>
-                        <a:t>1,801 records deduplicated (DOI and title matching) to 1,459; titles, abstracts and subject terms screened with every exclusion reason logged; 85 studies included.</a:t>
+                        <a:t>1,943 records identified; 325 duplicates removed; 1,618 titles and abstracts screened; 64 full-text articles assessed; 44 studies included.</a:t>
                       </a:r>
                     </a:p>
                   </a:txBody>
@@ -8264,7 +7974,7 @@
                           </a:solidFill>
                           <a:latin typeface="Times New Roman"/>
                         </a:rPr>
-                        <a:t>Studies charted by psychosocial domain (13 categories), coping mechanism, PMDD diagnostic method, country, World Bank region and income group (FY2027).</a:t>
+                        <a:t>Included studies categorized by psychosocial outcome, coping mechanism and geographic setting (country and income level).</a:t>
                       </a:r>
                     </a:p>
                   </a:txBody>
@@ -8313,7 +8023,7 @@
                 </a:solidFill>
                 <a:latin typeface="Times New Roman"/>
               </a:rPr>
-              <a:t>1,801</a:t>
+              <a:t>1,943</a:t>
             </a:r>
           </a:p>
           <a:p>
@@ -8345,7 +8055,7 @@
                 </a:solidFill>
                 <a:latin typeface="Times New Roman"/>
               </a:rPr>
-              <a:t>across 7 databases</a:t>
+              <a:t>across 5 databases</a:t>
             </a:r>
           </a:p>
         </p:txBody>
@@ -8384,7 +8094,7 @@
                 </a:solidFill>
                 <a:latin typeface="Times New Roman"/>
               </a:rPr>
-              <a:t>85</a:t>
+              <a:t>44</a:t>
             </a:r>
           </a:p>
           <a:p>
@@ -8490,7 +8200,7 @@
                 </a:solidFill>
                 <a:latin typeface="Times New Roman"/>
               </a:rPr>
-              <a:t>7</a:t>
+              <a:t>3</a:t>
             </a:r>
           </a:p>
           <a:p>
@@ -8522,7 +8232,7 @@
                 </a:solidFill>
                 <a:latin typeface="Times New Roman"/>
               </a:rPr>
-              <a:t>8.2% of 85</a:t>
+              <a:t>6.8% of 44</a:t>
             </a:r>
           </a:p>
         </p:txBody>
@@ -8612,7 +8322,7 @@
                 </a:solidFill>
                 <a:latin typeface="Times New Roman"/>
               </a:rPr>
-              <a:t>studies from sub-Saharan Africa</a:t>
+              <a:t>studies from LMICs</a:t>
             </a:r>
           </a:p>
           <a:p>
@@ -8628,7 +8338,7 @@
                 </a:solidFill>
                 <a:latin typeface="Times New Roman"/>
               </a:rPr>
-              <a:t>3.5% of 85</a:t>
+              <a:t>6.8% of 44</a:t>
             </a:r>
           </a:p>
         </p:txBody>
@@ -8715,8 +8425,8 @@
         </p:nvSpPr>
         <p:spPr>
           <a:xfrm>
-            <a:off x="2414016" y="1828800"/>
-            <a:ext cx="301752" cy="420624"/>
+            <a:off x="2414016" y="1810512"/>
+            <a:ext cx="301752" cy="365760"/>
           </a:xfrm>
           <a:prstGeom prst="roundRect">
             <a:avLst>
@@ -8776,7 +8486,7 @@
         </p:nvSpPr>
         <p:spPr>
           <a:xfrm>
-            <a:off x="2414016" y="2340864"/>
+            <a:off x="2414016" y="2249424"/>
             <a:ext cx="301752" cy="329184"/>
           </a:xfrm>
           <a:prstGeom prst="roundRect">
@@ -8837,8 +8547,8 @@
         </p:nvSpPr>
         <p:spPr>
           <a:xfrm>
-            <a:off x="2414016" y="2761488"/>
-            <a:ext cx="301752" cy="384048"/>
+            <a:off x="2414016" y="2651760"/>
+            <a:ext cx="301752" cy="365760"/>
           </a:xfrm>
           <a:prstGeom prst="roundRect">
             <a:avLst>
@@ -8898,8 +8608,8 @@
         </p:nvSpPr>
         <p:spPr>
           <a:xfrm>
-            <a:off x="2414016" y="3255264"/>
-            <a:ext cx="301752" cy="384048"/>
+            <a:off x="2414016" y="3090672"/>
+            <a:ext cx="301752" cy="365760"/>
           </a:xfrm>
           <a:prstGeom prst="roundRect">
             <a:avLst>
@@ -8946,7 +8656,7 @@
                 </a:solidFill>
                 <a:latin typeface="Times New Roman"/>
               </a:rPr>
-              <a:t>Included</a:t>
+              <a:t>Eligibility</a:t>
             </a:r>
           </a:p>
         </p:txBody>
@@ -8959,8 +8669,69 @@
         </p:nvSpPr>
         <p:spPr>
           <a:xfrm>
-            <a:off x="2761488" y="1828800"/>
-            <a:ext cx="960120" cy="420624"/>
+            <a:off x="2414016" y="3529584"/>
+            <a:ext cx="301752" cy="365760"/>
+          </a:xfrm>
+          <a:prstGeom prst="roundRect">
+            <a:avLst>
+              <a:gd name="adj" fmla="val 8000"/>
+            </a:avLst>
+          </a:prstGeom>
+          <a:solidFill>
+            <a:srgbClr val="FFFFFF"/>
+          </a:solidFill>
+          <a:ln w="5080">
+            <a:solidFill>
+              <a:srgbClr val="9CA3AF"/>
+            </a:solidFill>
+          </a:ln>
+          <a:effectLst/>
+        </p:spPr>
+        <p:style>
+          <a:lnRef idx="1">
+            <a:schemeClr val="accent1"/>
+          </a:lnRef>
+          <a:fillRef idx="3">
+            <a:schemeClr val="accent1"/>
+          </a:fillRef>
+          <a:effectRef idx="2">
+            <a:schemeClr val="accent1"/>
+          </a:effectRef>
+          <a:fontRef idx="minor">
+            <a:schemeClr val="lt1"/>
+          </a:fontRef>
+        </p:style>
+        <p:txBody>
+          <a:bodyPr rtlCol="0" anchor="ctr" wrap="square" lIns="9144" rIns="9144" tIns="13716" bIns="13716"/>
+          <a:lstStyle/>
+          <a:p>
+            <a:pPr algn="ctr">
+              <a:spcAft>
+                <a:spcPts val="120"/>
+              </a:spcAft>
+            </a:pPr>
+            <a:r>
+              <a:rPr sz="340" b="1" i="1">
+                <a:solidFill>
+                  <a:srgbClr val="0A254E"/>
+                </a:solidFill>
+                <a:latin typeface="Times New Roman"/>
+              </a:rPr>
+              <a:t>Included</a:t>
+            </a:r>
+          </a:p>
+        </p:txBody>
+      </p:sp>
+      <p:sp>
+        <p:nvSpPr>
+          <p:cNvPr id="326" name="Rounded Rectangle 325"/>
+          <p:cNvSpPr/>
+          <p:nvPr/>
+        </p:nvSpPr>
+        <p:spPr>
+          <a:xfrm>
+            <a:off x="2761488" y="1810512"/>
+            <a:ext cx="960120" cy="365760"/>
           </a:xfrm>
           <a:prstGeom prst="roundRect">
             <a:avLst>
@@ -9001,13 +8772,13 @@
               </a:spcAft>
             </a:pPr>
             <a:r>
-              <a:rPr sz="370" b="1" i="0">
+              <a:rPr sz="330" b="1" i="0">
                 <a:solidFill>
                   <a:srgbClr val="111827"/>
                 </a:solidFill>
                 <a:latin typeface="Times New Roman"/>
               </a:rPr>
-              <a:t>Records identified via</a:t>
+              <a:t>Records identified via database search</a:t>
             </a:r>
           </a:p>
           <a:p>
@@ -9017,13 +8788,13 @@
               </a:spcAft>
             </a:pPr>
             <a:r>
-              <a:rPr sz="370" b="0" i="0">
+              <a:rPr sz="330" b="0" i="0">
                 <a:solidFill>
                   <a:srgbClr val="111827"/>
                 </a:solidFill>
                 <a:latin typeface="Times New Roman"/>
               </a:rPr>
-              <a:t>database search</a:t>
+              <a:t>PubMed/MEDLINE · CINAHL · APA PsycInfo</a:t>
             </a:r>
           </a:p>
           <a:p>
@@ -9033,170 +8804,29 @@
               </a:spcAft>
             </a:pPr>
             <a:r>
-              <a:rPr sz="370" b="0" i="0">
+              <a:rPr sz="330" b="0" i="0">
                 <a:solidFill>
                   <a:srgbClr val="111827"/>
                 </a:solidFill>
                 <a:latin typeface="Times New Roman"/>
               </a:rPr>
-              <a:t>n = 1,801</a:t>
-            </a:r>
-          </a:p>
-        </p:txBody>
-      </p:sp>
-      <p:sp>
-        <p:nvSpPr>
-          <p:cNvPr id="326" name="Rounded Rectangle 325"/>
-          <p:cNvSpPr/>
-          <p:nvPr/>
-        </p:nvSpPr>
-        <p:spPr>
-          <a:xfrm>
-            <a:off x="3785615" y="1810512"/>
-            <a:ext cx="886968" cy="457200"/>
-          </a:xfrm>
-          <a:prstGeom prst="roundRect">
-            <a:avLst>
-              <a:gd name="adj" fmla="val 8000"/>
-            </a:avLst>
-          </a:prstGeom>
-          <a:solidFill>
-            <a:srgbClr val="FFFFFF"/>
-          </a:solidFill>
-          <a:ln w="7620">
-            <a:solidFill>
-              <a:srgbClr val="9CA3AF"/>
-            </a:solidFill>
-          </a:ln>
-          <a:effectLst/>
-        </p:spPr>
-        <p:style>
-          <a:lnRef idx="1">
-            <a:schemeClr val="accent1"/>
-          </a:lnRef>
-          <a:fillRef idx="3">
-            <a:schemeClr val="accent1"/>
-          </a:fillRef>
-          <a:effectRef idx="2">
-            <a:schemeClr val="accent1"/>
-          </a:effectRef>
-          <a:fontRef idx="minor">
-            <a:schemeClr val="lt1"/>
-          </a:fontRef>
-        </p:style>
-        <p:txBody>
-          <a:bodyPr rtlCol="0" anchor="ctr" wrap="square" lIns="27432" rIns="27432" tIns="13716" bIns="13716"/>
-          <a:lstStyle/>
-          <a:p>
-            <a:pPr algn="l">
+              <a:t>APA PsycArticles · Cochrane Library</a:t>
+            </a:r>
+          </a:p>
+          <a:p>
+            <a:pPr algn="ctr">
               <a:spcAft>
                 <a:spcPts val="0"/>
               </a:spcAft>
             </a:pPr>
             <a:r>
-              <a:rPr sz="290" b="0" i="0">
+              <a:rPr sz="330" b="0" i="0">
                 <a:solidFill>
                   <a:srgbClr val="111827"/>
                 </a:solidFill>
                 <a:latin typeface="Times New Roman"/>
               </a:rPr>
-              <a:t>CINAHL Ultimate: 974</a:t>
-            </a:r>
-          </a:p>
-          <a:p>
-            <a:pPr algn="l">
-              <a:spcAft>
-                <a:spcPts val="0"/>
-              </a:spcAft>
-            </a:pPr>
-            <a:r>
-              <a:rPr sz="290" b="0" i="0">
-                <a:solidFill>
-                  <a:srgbClr val="111827"/>
-                </a:solidFill>
-                <a:latin typeface="Times New Roman"/>
-              </a:rPr>
-              <a:t>APA PsycInfo: 649</a:t>
-            </a:r>
-          </a:p>
-          <a:p>
-            <a:pPr algn="l">
-              <a:spcAft>
-                <a:spcPts val="0"/>
-              </a:spcAft>
-            </a:pPr>
-            <a:r>
-              <a:rPr sz="290" b="0" i="0">
-                <a:solidFill>
-                  <a:srgbClr val="111827"/>
-                </a:solidFill>
-                <a:latin typeface="Times New Roman"/>
-              </a:rPr>
-              <a:t>MEDLINE Ultimate: 145</a:t>
-            </a:r>
-          </a:p>
-          <a:p>
-            <a:pPr algn="l">
-              <a:spcAft>
-                <a:spcPts val="0"/>
-              </a:spcAft>
-            </a:pPr>
-            <a:r>
-              <a:rPr sz="290" b="0" i="0">
-                <a:solidFill>
-                  <a:srgbClr val="111827"/>
-                </a:solidFill>
-                <a:latin typeface="Times New Roman"/>
-              </a:rPr>
-              <a:t>Women's Studies International: 15</a:t>
-            </a:r>
-          </a:p>
-          <a:p>
-            <a:pPr algn="l">
-              <a:spcAft>
-                <a:spcPts val="0"/>
-              </a:spcAft>
-            </a:pPr>
-            <a:r>
-              <a:rPr sz="290" b="0" i="0">
-                <a:solidFill>
-                  <a:srgbClr val="111827"/>
-                </a:solidFill>
-                <a:latin typeface="Times New Roman"/>
-              </a:rPr>
-              <a:t>APA PsycArticles: 8</a:t>
-            </a:r>
-          </a:p>
-          <a:p>
-            <a:pPr algn="l">
-              <a:spcAft>
-                <a:spcPts val="0"/>
-              </a:spcAft>
-            </a:pPr>
-            <a:r>
-              <a:rPr sz="290" b="0" i="0">
-                <a:solidFill>
-                  <a:srgbClr val="111827"/>
-                </a:solidFill>
-                <a:latin typeface="Times New Roman"/>
-              </a:rPr>
-              <a:t>PubMed/MEDLINE: 6</a:t>
-            </a:r>
-          </a:p>
-          <a:p>
-            <a:pPr algn="l">
-              <a:spcAft>
-                <a:spcPts val="0"/>
-              </a:spcAft>
-            </a:pPr>
-            <a:r>
-              <a:rPr sz="290" b="0" i="0">
-                <a:solidFill>
-                  <a:srgbClr val="111827"/>
-                </a:solidFill>
-                <a:latin typeface="Times New Roman"/>
-              </a:rPr>
-              <a:t>Cochrane Database of Systematic Reviews: 4</a:t>
+              <a:t>n = 1,943</a:t>
             </a:r>
           </a:p>
         </p:txBody>
@@ -9209,8 +8839,8 @@
         </p:nvCxnSpPr>
         <p:spPr>
           <a:xfrm>
-            <a:off x="3241548" y="2249424"/>
-            <a:ext cx="0" cy="91440"/>
+            <a:off x="3241548" y="2176272"/>
+            <a:ext cx="0" cy="73152"/>
           </a:xfrm>
           <a:prstGeom prst="line">
             <a:avLst/>
@@ -9245,7 +8875,7 @@
         </p:nvSpPr>
         <p:spPr>
           <a:xfrm>
-            <a:off x="2761488" y="2340864"/>
+            <a:off x="2761488" y="2249424"/>
             <a:ext cx="960120" cy="329184"/>
           </a:xfrm>
           <a:prstGeom prst="roundRect">
@@ -9309,7 +8939,7 @@
                 </a:solidFill>
                 <a:latin typeface="Times New Roman"/>
               </a:rPr>
-              <a:t>342 duplicates removed</a:t>
+              <a:t>325 duplicates removed</a:t>
             </a:r>
           </a:p>
           <a:p>
@@ -9325,7 +8955,7 @@
                 </a:solidFill>
                 <a:latin typeface="Times New Roman"/>
               </a:rPr>
-              <a:t>n = 1,459</a:t>
+              <a:t>n = 1,618</a:t>
             </a:r>
           </a:p>
         </p:txBody>
@@ -9338,8 +8968,8 @@
         </p:nvCxnSpPr>
         <p:spPr>
           <a:xfrm>
-            <a:off x="3241548" y="2670048"/>
-            <a:ext cx="0" cy="91440"/>
+            <a:off x="3241548" y="2578608"/>
+            <a:ext cx="0" cy="73152"/>
           </a:xfrm>
           <a:prstGeom prst="line">
             <a:avLst/>
@@ -9374,8 +9004,8 @@
         </p:nvSpPr>
         <p:spPr>
           <a:xfrm>
-            <a:off x="2761488" y="2761488"/>
-            <a:ext cx="960120" cy="384048"/>
+            <a:off x="2761488" y="2651760"/>
+            <a:ext cx="960120" cy="365760"/>
           </a:xfrm>
           <a:prstGeom prst="roundRect">
             <a:avLst>
@@ -9438,7 +9068,7 @@
                 </a:solidFill>
                 <a:latin typeface="Times New Roman"/>
               </a:rPr>
-              <a:t>(title, abstract, subject terms)</a:t>
+              <a:t>(title and abstract)</a:t>
             </a:r>
           </a:p>
           <a:p>
@@ -9454,7 +9084,7 @@
                 </a:solidFill>
                 <a:latin typeface="Times New Roman"/>
               </a:rPr>
-              <a:t>n = 1,459</a:t>
+              <a:t>n = 1,618</a:t>
             </a:r>
           </a:p>
         </p:txBody>
@@ -9467,8 +9097,8 @@
         </p:nvSpPr>
         <p:spPr>
           <a:xfrm>
-            <a:off x="3785615" y="2395728"/>
-            <a:ext cx="886968" cy="896112"/>
+            <a:off x="3785615" y="2651760"/>
+            <a:ext cx="886968" cy="365760"/>
           </a:xfrm>
           <a:prstGeom prst="roundRect">
             <a:avLst>
@@ -9503,7 +9133,7 @@
           <a:bodyPr rtlCol="0" anchor="ctr" wrap="square" lIns="27432" rIns="27432" tIns="13716" bIns="13716"/>
           <a:lstStyle/>
           <a:p>
-            <a:pPr algn="l">
+            <a:pPr algn="ctr">
               <a:spcAft>
                 <a:spcPts val="0"/>
               </a:spcAft>
@@ -9515,11 +9145,11 @@
                 </a:solidFill>
                 <a:latin typeface="Times New Roman"/>
               </a:rPr>
-              <a:t>Excluded (n = 1,374)</a:t>
-            </a:r>
-          </a:p>
-          <a:p>
-            <a:pPr algn="l">
+              <a:t>Excluded (n = 1,554)</a:t>
+            </a:r>
+          </a:p>
+          <a:p>
+            <a:pPr algn="ctr">
               <a:spcAft>
                 <a:spcPts val="0"/>
               </a:spcAft>
@@ -9531,11 +9161,11 @@
                 </a:solidFill>
                 <a:latin typeface="Times New Roman"/>
               </a:rPr>
-              <a:t>PMDD not primary population: 491</a:t>
-            </a:r>
-          </a:p>
-          <a:p>
-            <a:pPr algn="l">
+              <a:t>Not PMDD-focused or no psychosocial/</a:t>
+            </a:r>
+          </a:p>
+          <a:p>
+            <a:pPr algn="ctr">
               <a:spcAft>
                 <a:spcPts val="0"/>
               </a:spcAft>
@@ -9547,11 +9177,11 @@
                 </a:solidFill>
                 <a:latin typeface="Times New Roman"/>
               </a:rPr>
-              <a:t>Outside 2010–2025: 457</a:t>
-            </a:r>
-          </a:p>
-          <a:p>
-            <a:pPr algn="l">
+              <a:t>coping aim; review, intervention,</a:t>
+            </a:r>
+          </a:p>
+          <a:p>
+            <a:pPr algn="ctr">
               <a:spcAft>
                 <a:spcPts val="0"/>
               </a:spcAft>
@@ -9563,119 +9193,7 @@
                 </a:solidFill>
                 <a:latin typeface="Times New Roman"/>
               </a:rPr>
-              <a:t>Reviews / commentaries: 170</a:t>
-            </a:r>
-          </a:p>
-          <a:p>
-            <a:pPr algn="l">
-              <a:spcAft>
-                <a:spcPts val="0"/>
-              </a:spcAft>
-            </a:pPr>
-            <a:r>
-              <a:rPr sz="320" b="0" i="0">
-                <a:solidFill>
-                  <a:srgbClr val="111827"/>
-                </a:solidFill>
-                <a:latin typeface="Times New Roman"/>
-              </a:rPr>
-              <a:t>Other ineligible formats: 106</a:t>
-            </a:r>
-          </a:p>
-          <a:p>
-            <a:pPr algn="l">
-              <a:spcAft>
-                <a:spcPts val="0"/>
-              </a:spcAft>
-            </a:pPr>
-            <a:r>
-              <a:rPr sz="320" b="0" i="0">
-                <a:solidFill>
-                  <a:srgbClr val="111827"/>
-                </a:solidFill>
-                <a:latin typeface="Times New Roman"/>
-              </a:rPr>
-              <a:t>Non-English: 65</a:t>
-            </a:r>
-          </a:p>
-          <a:p>
-            <a:pPr algn="l">
-              <a:spcAft>
-                <a:spcPts val="0"/>
-              </a:spcAft>
-            </a:pPr>
-            <a:r>
-              <a:rPr sz="320" b="0" i="0">
-                <a:solidFill>
-                  <a:srgbClr val="111827"/>
-                </a:solidFill>
-                <a:latin typeface="Times New Roman"/>
-              </a:rPr>
-              <a:t>Intervention studies: 28</a:t>
-            </a:r>
-          </a:p>
-          <a:p>
-            <a:pPr algn="l">
-              <a:spcAft>
-                <a:spcPts val="0"/>
-              </a:spcAft>
-            </a:pPr>
-            <a:r>
-              <a:rPr sz="320" b="0" i="0">
-                <a:solidFill>
-                  <a:srgbClr val="111827"/>
-                </a:solidFill>
-                <a:latin typeface="Times New Roman"/>
-              </a:rPr>
-              <a:t>Laboratory / biological: 22</a:t>
-            </a:r>
-          </a:p>
-          <a:p>
-            <a:pPr algn="l">
-              <a:spcAft>
-                <a:spcPts val="0"/>
-              </a:spcAft>
-            </a:pPr>
-            <a:r>
-              <a:rPr sz="320" b="0" i="0">
-                <a:solidFill>
-                  <a:srgbClr val="111827"/>
-                </a:solidFill>
-                <a:latin typeface="Times New Roman"/>
-              </a:rPr>
-              <a:t>No psychosocial/coping aim: 15</a:t>
-            </a:r>
-          </a:p>
-          <a:p>
-            <a:pPr algn="l">
-              <a:spcAft>
-                <a:spcPts val="0"/>
-              </a:spcAft>
-            </a:pPr>
-            <a:r>
-              <a:rPr sz="320" b="0" i="0">
-                <a:solidFill>
-                  <a:srgbClr val="111827"/>
-                </a:solidFill>
-                <a:latin typeface="Times New Roman"/>
-              </a:rPr>
-              <a:t>Instrument validation: 11</a:t>
-            </a:r>
-          </a:p>
-          <a:p>
-            <a:pPr algn="l">
-              <a:spcAft>
-                <a:spcPts val="0"/>
-              </a:spcAft>
-            </a:pPr>
-            <a:r>
-              <a:rPr sz="320" b="0" i="0">
-                <a:solidFill>
-                  <a:srgbClr val="111827"/>
-                </a:solidFill>
-                <a:latin typeface="Times New Roman"/>
-              </a:rPr>
-              <a:t>Animal studies: 9</a:t>
+              <a:t>animal or laboratory study</a:t>
             </a:r>
           </a:p>
         </p:txBody>
@@ -9688,7 +9206,7 @@
         </p:nvCxnSpPr>
         <p:spPr>
           <a:xfrm>
-            <a:off x="3721608" y="2953512"/>
+            <a:off x="3721608" y="2834640"/>
             <a:ext cx="64007" cy="0"/>
           </a:xfrm>
           <a:prstGeom prst="line">
@@ -9724,8 +9242,8 @@
         </p:nvCxnSpPr>
         <p:spPr>
           <a:xfrm>
-            <a:off x="3241548" y="3145536"/>
-            <a:ext cx="0" cy="109728"/>
+            <a:off x="3241548" y="3017520"/>
+            <a:ext cx="0" cy="73152"/>
           </a:xfrm>
           <a:prstGeom prst="line">
             <a:avLst/>
@@ -9760,8 +9278,266 @@
         </p:nvSpPr>
         <p:spPr>
           <a:xfrm>
-            <a:off x="2761488" y="3255264"/>
-            <a:ext cx="960120" cy="384048"/>
+            <a:off x="2761488" y="3090672"/>
+            <a:ext cx="960120" cy="365760"/>
+          </a:xfrm>
+          <a:prstGeom prst="roundRect">
+            <a:avLst>
+              <a:gd name="adj" fmla="val 8000"/>
+            </a:avLst>
+          </a:prstGeom>
+          <a:solidFill>
+            <a:srgbClr val="EEF2F8"/>
+          </a:solidFill>
+          <a:ln w="7620">
+            <a:solidFill>
+              <a:srgbClr val="0A254E"/>
+            </a:solidFill>
+          </a:ln>
+          <a:effectLst/>
+        </p:spPr>
+        <p:style>
+          <a:lnRef idx="1">
+            <a:schemeClr val="accent1"/>
+          </a:lnRef>
+          <a:fillRef idx="3">
+            <a:schemeClr val="accent1"/>
+          </a:fillRef>
+          <a:effectRef idx="2">
+            <a:schemeClr val="accent1"/>
+          </a:effectRef>
+          <a:fontRef idx="minor">
+            <a:schemeClr val="lt1"/>
+          </a:fontRef>
+        </p:style>
+        <p:txBody>
+          <a:bodyPr rtlCol="0" anchor="ctr" wrap="square" lIns="27432" rIns="27432" tIns="13716" bIns="13716"/>
+          <a:lstStyle/>
+          <a:p>
+            <a:pPr algn="ctr">
+              <a:spcAft>
+                <a:spcPts val="0"/>
+              </a:spcAft>
+            </a:pPr>
+            <a:r>
+              <a:rPr sz="360" b="1" i="0">
+                <a:solidFill>
+                  <a:srgbClr val="111827"/>
+                </a:solidFill>
+                <a:latin typeface="Times New Roman"/>
+              </a:rPr>
+              <a:t>Full-text articles assessed</a:t>
+            </a:r>
+          </a:p>
+          <a:p>
+            <a:pPr algn="ctr">
+              <a:spcAft>
+                <a:spcPts val="0"/>
+              </a:spcAft>
+            </a:pPr>
+            <a:r>
+              <a:rPr sz="360" b="0" i="0">
+                <a:solidFill>
+                  <a:srgbClr val="111827"/>
+                </a:solidFill>
+                <a:latin typeface="Times New Roman"/>
+              </a:rPr>
+              <a:t>for eligibility</a:t>
+            </a:r>
+          </a:p>
+          <a:p>
+            <a:pPr algn="ctr">
+              <a:spcAft>
+                <a:spcPts val="0"/>
+              </a:spcAft>
+            </a:pPr>
+            <a:r>
+              <a:rPr sz="360" b="0" i="0">
+                <a:solidFill>
+                  <a:srgbClr val="111827"/>
+                </a:solidFill>
+                <a:latin typeface="Times New Roman"/>
+              </a:rPr>
+              <a:t>n = 64</a:t>
+            </a:r>
+          </a:p>
+        </p:txBody>
+      </p:sp>
+      <p:sp>
+        <p:nvSpPr>
+          <p:cNvPr id="335" name="Rounded Rectangle 334"/>
+          <p:cNvSpPr/>
+          <p:nvPr/>
+        </p:nvSpPr>
+        <p:spPr>
+          <a:xfrm>
+            <a:off x="3785615" y="3090672"/>
+            <a:ext cx="886968" cy="365760"/>
+          </a:xfrm>
+          <a:prstGeom prst="roundRect">
+            <a:avLst>
+              <a:gd name="adj" fmla="val 8000"/>
+            </a:avLst>
+          </a:prstGeom>
+          <a:solidFill>
+            <a:srgbClr val="FDECEE"/>
+          </a:solidFill>
+          <a:ln w="7620">
+            <a:solidFill>
+              <a:srgbClr val="A31F34"/>
+            </a:solidFill>
+          </a:ln>
+          <a:effectLst/>
+        </p:spPr>
+        <p:style>
+          <a:lnRef idx="1">
+            <a:schemeClr val="accent1"/>
+          </a:lnRef>
+          <a:fillRef idx="3">
+            <a:schemeClr val="accent1"/>
+          </a:fillRef>
+          <a:effectRef idx="2">
+            <a:schemeClr val="accent1"/>
+          </a:effectRef>
+          <a:fontRef idx="minor">
+            <a:schemeClr val="lt1"/>
+          </a:fontRef>
+        </p:style>
+        <p:txBody>
+          <a:bodyPr rtlCol="0" anchor="ctr" wrap="square" lIns="27432" rIns="27432" tIns="13716" bIns="13716"/>
+          <a:lstStyle/>
+          <a:p>
+            <a:pPr algn="ctr">
+              <a:spcAft>
+                <a:spcPts val="0"/>
+              </a:spcAft>
+            </a:pPr>
+            <a:r>
+              <a:rPr sz="330" b="1" i="0">
+                <a:solidFill>
+                  <a:srgbClr val="111827"/>
+                </a:solidFill>
+                <a:latin typeface="Times New Roman"/>
+              </a:rPr>
+              <a:t>Excluded (n = 20)</a:t>
+            </a:r>
+          </a:p>
+          <a:p>
+            <a:pPr algn="ctr">
+              <a:spcAft>
+                <a:spcPts val="0"/>
+              </a:spcAft>
+            </a:pPr>
+            <a:r>
+              <a:rPr sz="330" b="0" i="0">
+                <a:solidFill>
+                  <a:srgbClr val="111827"/>
+                </a:solidFill>
+                <a:latin typeface="Times New Roman"/>
+              </a:rPr>
+              <a:t>Did not meet inclusion</a:t>
+            </a:r>
+          </a:p>
+          <a:p>
+            <a:pPr algn="ctr">
+              <a:spcAft>
+                <a:spcPts val="0"/>
+              </a:spcAft>
+            </a:pPr>
+            <a:r>
+              <a:rPr sz="330" b="0" i="0">
+                <a:solidFill>
+                  <a:srgbClr val="111827"/>
+                </a:solidFill>
+                <a:latin typeface="Times New Roman"/>
+              </a:rPr>
+              <a:t>criteria at full text</a:t>
+            </a:r>
+          </a:p>
+        </p:txBody>
+      </p:sp>
+      <p:cxnSp>
+        <p:nvCxnSpPr>
+          <p:cNvPr id="336" name="Connector 335"/>
+          <p:cNvCxnSpPr/>
+          <p:nvPr/>
+        </p:nvCxnSpPr>
+        <p:spPr>
+          <a:xfrm>
+            <a:off x="3721608" y="3273552"/>
+            <a:ext cx="64007" cy="0"/>
+          </a:xfrm>
+          <a:prstGeom prst="line">
+            <a:avLst/>
+          </a:prstGeom>
+          <a:ln w="11430">
+            <a:solidFill>
+              <a:srgbClr val="0A254E"/>
+            </a:solidFill>
+            <a:tailEnd type="triangle" w="med" len="med"/>
+          </a:ln>
+        </p:spPr>
+        <p:style>
+          <a:lnRef idx="2">
+            <a:schemeClr val="accent1"/>
+          </a:lnRef>
+          <a:fillRef idx="0">
+            <a:schemeClr val="accent1"/>
+          </a:fillRef>
+          <a:effectRef idx="1">
+            <a:schemeClr val="accent1"/>
+          </a:effectRef>
+          <a:fontRef idx="minor">
+            <a:schemeClr val="tx1"/>
+          </a:fontRef>
+        </p:style>
+      </p:cxnSp>
+      <p:cxnSp>
+        <p:nvCxnSpPr>
+          <p:cNvPr id="337" name="Connector 336"/>
+          <p:cNvCxnSpPr/>
+          <p:nvPr/>
+        </p:nvCxnSpPr>
+        <p:spPr>
+          <a:xfrm>
+            <a:off x="3241548" y="3456432"/>
+            <a:ext cx="0" cy="73152"/>
+          </a:xfrm>
+          <a:prstGeom prst="line">
+            <a:avLst/>
+          </a:prstGeom>
+          <a:ln w="11430">
+            <a:solidFill>
+              <a:srgbClr val="0A254E"/>
+            </a:solidFill>
+            <a:tailEnd type="triangle" w="med" len="med"/>
+          </a:ln>
+        </p:spPr>
+        <p:style>
+          <a:lnRef idx="2">
+            <a:schemeClr val="accent1"/>
+          </a:lnRef>
+          <a:fillRef idx="0">
+            <a:schemeClr val="accent1"/>
+          </a:fillRef>
+          <a:effectRef idx="1">
+            <a:schemeClr val="accent1"/>
+          </a:effectRef>
+          <a:fontRef idx="minor">
+            <a:schemeClr val="tx1"/>
+          </a:fontRef>
+        </p:style>
+      </p:cxnSp>
+      <p:sp>
+        <p:nvSpPr>
+          <p:cNvPr id="338" name="Rounded Rectangle 337"/>
+          <p:cNvSpPr/>
+          <p:nvPr/>
+        </p:nvSpPr>
+        <p:spPr>
+          <a:xfrm>
+            <a:off x="2761488" y="3529584"/>
+            <a:ext cx="960120" cy="365760"/>
           </a:xfrm>
           <a:prstGeom prst="roundRect">
             <a:avLst>
@@ -9840,60 +9616,21 @@
                 </a:solidFill>
                 <a:latin typeface="Times New Roman"/>
               </a:rPr>
-              <a:t>n = 85</a:t>
-            </a:r>
-          </a:p>
-        </p:txBody>
-      </p:sp>
-      <p:sp>
-        <p:nvSpPr>
-          <p:cNvPr id="335" name="TextBox 334"/>
-          <p:cNvSpPr txBox="1"/>
+              <a:t>n = 44</a:t>
+            </a:r>
+          </a:p>
+        </p:txBody>
+      </p:sp>
+      <p:sp>
+        <p:nvSpPr>
+          <p:cNvPr id="339" name="Rounded Rectangle 338"/>
+          <p:cNvSpPr/>
           <p:nvPr/>
         </p:nvSpPr>
         <p:spPr>
           <a:xfrm>
-            <a:off x="2414016" y="3694176"/>
-            <a:ext cx="2258568" cy="237744"/>
-          </a:xfrm>
-          <a:prstGeom prst="rect">
-            <a:avLst/>
-          </a:prstGeom>
-          <a:noFill/>
-        </p:spPr>
-        <p:txBody>
-          <a:bodyPr wrap="square" anchor="t" lIns="27432" rIns="27432" tIns="13716" bIns="13716">
-            <a:spAutoFit/>
-          </a:bodyPr>
-          <a:lstStyle/>
-          <a:p>
-            <a:pPr algn="l">
-              <a:spcAft>
-                <a:spcPts val="120"/>
-              </a:spcAft>
-            </a:pPr>
-            <a:r>
-              <a:rPr sz="320" b="0" i="1">
-                <a:solidFill>
-                  <a:srgbClr val="4B5563"/>
-                </a:solidFill>
-                <a:latin typeface="Times New Roman"/>
-              </a:rPr>
-              <a:t>Eligibility judged on titles, abstracts and subject terms; full-text verification ongoing. All decisions logged in the supplementary workbook.</a:t>
-            </a:r>
-          </a:p>
-        </p:txBody>
-      </p:sp>
-      <p:sp>
-        <p:nvSpPr>
-          <p:cNvPr id="336" name="Rounded Rectangle 335"/>
-          <p:cNvSpPr/>
-          <p:nvPr/>
-        </p:nvSpPr>
-        <p:spPr>
-          <a:xfrm>
-            <a:off x="2414016" y="3959352"/>
-            <a:ext cx="2258568" cy="566928"/>
+            <a:off x="2414016" y="4005072"/>
+            <a:ext cx="2258568" cy="548640"/>
           </a:xfrm>
           <a:prstGeom prst="roundRect">
             <a:avLst>
@@ -9995,7 +9732,7 @@
       </p:sp>
       <p:sp>
         <p:nvSpPr>
-          <p:cNvPr id="337" name="TextBox 336"/>
+          <p:cNvPr id="340" name="TextBox 339"/>
           <p:cNvSpPr txBox="1"/>
           <p:nvPr/>
         </p:nvSpPr>
@@ -10027,14 +9764,14 @@
                 </a:solidFill>
                 <a:latin typeface="Times New Roman"/>
               </a:rPr>
-              <a:t>Fig 2. Included Studies Reporting Each Outcome (of 85)</a:t>
+              <a:t>Fig 2. Included Studies Reporting Each Outcome (of 44)</a:t>
             </a:r>
           </a:p>
         </p:txBody>
       </p:sp>
       <p:graphicFrame>
         <p:nvGraphicFramePr>
-          <p:cNvPr id="338" name="Chart 337"/>
+          <p:cNvPr id="341" name="Chart 340"/>
           <p:cNvGraphicFramePr>
             <a:graphicFrameLocks noGrp="1"/>
           </p:cNvGraphicFramePr>
@@ -10052,7 +9789,7 @@
       </p:graphicFrame>
       <p:sp>
         <p:nvSpPr>
-          <p:cNvPr id="339" name="TextBox 338"/>
+          <p:cNvPr id="342" name="TextBox 341"/>
           <p:cNvSpPr txBox="1"/>
           <p:nvPr/>
         </p:nvSpPr>
@@ -10091,7 +9828,7 @@
       </p:sp>
       <p:sp>
         <p:nvSpPr>
-          <p:cNvPr id="340" name="TextBox 339"/>
+          <p:cNvPr id="343" name="TextBox 342"/>
           <p:cNvSpPr txBox="1"/>
           <p:nvPr/>
         </p:nvSpPr>
@@ -10123,22 +9860,22 @@
                 </a:solidFill>
                 <a:latin typeface="Times New Roman"/>
               </a:rPr>
-              <a:t>Fig 3. Share of the 85 Included Studies, by World Bank Region and Income Group</a:t>
+              <a:t>Fig 3. Geographic Setting of the 44 Included Studies</a:t>
             </a:r>
           </a:p>
         </p:txBody>
       </p:sp>
       <p:graphicFrame>
         <p:nvGraphicFramePr>
-          <p:cNvPr id="341" name="Chart 340"/>
+          <p:cNvPr id="344" name="Chart 343"/>
           <p:cNvGraphicFramePr>
             <a:graphicFrameLocks noGrp="1"/>
           </p:cNvGraphicFramePr>
           <p:nvPr/>
         </p:nvGraphicFramePr>
         <p:xfrm>
-          <a:off x="2414016" y="4818888"/>
-          <a:ext cx="2514600" cy="1600200"/>
+          <a:off x="2414016" y="4864608"/>
+          <a:ext cx="2651760" cy="1097280"/>
         </p:xfrm>
         <a:graphic>
           <a:graphicData uri="http://schemas.openxmlformats.org/drawingml/2006/chart">
@@ -10146,34 +9883,109 @@
           </a:graphicData>
         </a:graphic>
       </p:graphicFrame>
-      <p:graphicFrame>
-        <p:nvGraphicFramePr>
-          <p:cNvPr id="342" name="Chart 341"/>
-          <p:cNvGraphicFramePr>
-            <a:graphicFrameLocks noGrp="1"/>
-          </p:cNvGraphicFramePr>
+      <p:sp>
+        <p:nvSpPr>
+          <p:cNvPr id="345" name="Rounded Rectangle 344"/>
+          <p:cNvSpPr/>
           <p:nvPr/>
-        </p:nvGraphicFramePr>
-        <p:xfrm>
-          <a:off x="4983480" y="4818888"/>
-          <a:ext cx="2011680" cy="1600200"/>
-        </p:xfrm>
-        <a:graphic>
-          <a:graphicData uri="http://schemas.openxmlformats.org/drawingml/2006/chart">
-            <c:chart xmlns:c="http://schemas.openxmlformats.org/drawingml/2006/chart" r:id="rId11"/>
-          </a:graphicData>
-        </a:graphic>
-      </p:graphicFrame>
-      <p:sp>
-        <p:nvSpPr>
-          <p:cNvPr id="343" name="TextBox 342"/>
+        </p:nvSpPr>
+        <p:spPr>
+          <a:xfrm>
+            <a:off x="5212080" y="4910328"/>
+            <a:ext cx="1737360" cy="1005840"/>
+          </a:xfrm>
+          <a:prstGeom prst="roundRect">
+            <a:avLst>
+              <a:gd name="adj" fmla="val 8000"/>
+            </a:avLst>
+          </a:prstGeom>
+          <a:solidFill>
+            <a:srgbClr val="EEF2F8"/>
+          </a:solidFill>
+          <a:ln w="7620">
+            <a:solidFill>
+              <a:srgbClr val="A31F34"/>
+            </a:solidFill>
+          </a:ln>
+          <a:effectLst/>
+        </p:spPr>
+        <p:style>
+          <a:lnRef idx="1">
+            <a:schemeClr val="accent1"/>
+          </a:lnRef>
+          <a:fillRef idx="3">
+            <a:schemeClr val="accent1"/>
+          </a:fillRef>
+          <a:effectRef idx="2">
+            <a:schemeClr val="accent1"/>
+          </a:effectRef>
+          <a:fontRef idx="minor">
+            <a:schemeClr val="lt1"/>
+          </a:fontRef>
+        </p:style>
+        <p:txBody>
+          <a:bodyPr rtlCol="0" anchor="ctr" wrap="square" lIns="27432" rIns="27432" tIns="13716" bIns="13716"/>
+          <a:lstStyle/>
+          <a:p>
+            <a:pPr algn="ctr">
+              <a:spcAft>
+                <a:spcPts val="0"/>
+              </a:spcAft>
+            </a:pPr>
+            <a:r>
+              <a:rPr sz="2000" b="1" i="0">
+                <a:solidFill>
+                  <a:srgbClr val="A31F34"/>
+                </a:solidFill>
+                <a:latin typeface="Times New Roman"/>
+              </a:rPr>
+              <a:t>6.8%</a:t>
+            </a:r>
+          </a:p>
+          <a:p>
+            <a:pPr algn="ctr">
+              <a:spcAft>
+                <a:spcPts val="100"/>
+              </a:spcAft>
+            </a:pPr>
+            <a:r>
+              <a:rPr sz="550" b="0" i="0">
+                <a:solidFill>
+                  <a:srgbClr val="111827"/>
+                </a:solidFill>
+                <a:latin typeface="Times New Roman"/>
+              </a:rPr>
+              <a:t>of included studies came from LMICs</a:t>
+            </a:r>
+          </a:p>
+          <a:p>
+            <a:pPr algn="ctr">
+              <a:spcAft>
+                <a:spcPts val="0"/>
+              </a:spcAft>
+            </a:pPr>
+            <a:r>
+              <a:rPr sz="550" b="1" i="0">
+                <a:solidFill>
+                  <a:srgbClr val="A31F34"/>
+                </a:solidFill>
+                <a:latin typeface="Times New Roman"/>
+              </a:rPr>
+              <a:t>Sub-Saharan Africa: 1 study (Nigeria)</a:t>
+            </a:r>
+          </a:p>
+        </p:txBody>
+      </p:sp>
+      <p:sp>
+        <p:nvSpPr>
+          <p:cNvPr id="346" name="TextBox 345"/>
           <p:cNvSpPr txBox="1"/>
           <p:nvPr/>
         </p:nvSpPr>
         <p:spPr>
           <a:xfrm>
-            <a:off x="2414016" y="6400800"/>
-            <a:ext cx="4572000" cy="274320"/>
+            <a:off x="2414016" y="5989320"/>
+            <a:ext cx="4572000" cy="457200"/>
           </a:xfrm>
           <a:prstGeom prst="rect">
             <a:avLst/>
@@ -10192,20 +10004,20 @@
               </a:spcAft>
             </a:pPr>
             <a:r>
-              <a:rPr sz="340" b="0" i="1">
+              <a:rPr sz="420" b="0" i="1">
                 <a:solidFill>
                   <a:srgbClr val="4B5563"/>
                 </a:solidFill>
                 <a:latin typeface="Times New Roman"/>
               </a:rPr>
-              <a:t>Sub-Saharan Africa: 3 studies (Ethiopia 2, Nigeria 1). Red columns = low- and middle-income countries (21 studies, 25%); only 5 (5.9%) from low or lower-middle-income countries. Income groups: World Bank FY2027.</a:t>
-            </a:r>
-          </a:p>
-        </p:txBody>
-      </p:sp>
-      <p:sp>
-        <p:nvSpPr>
-          <p:cNvPr id="344" name="Rectangle 343"/>
+              <a:t>41 of 44 studies (93.2%) were conducted in high-income or other non-LMIC settings; 3 (6.8%) came from LMICs, only one of them from sub-Saharan Africa. Evidence on PMDD’s psychosocial burden therefore reflects mainly high-income contexts.</a:t>
+            </a:r>
+          </a:p>
+        </p:txBody>
+      </p:sp>
+      <p:sp>
+        <p:nvSpPr>
+          <p:cNvPr id="347" name="Rectangle 346"/>
           <p:cNvSpPr/>
           <p:nvPr/>
         </p:nvSpPr>
@@ -10262,7 +10074,7 @@
       </p:sp>
       <p:sp>
         <p:nvSpPr>
-          <p:cNvPr id="345" name="Rectangle 344"/>
+          <p:cNvPr id="348" name="Rectangle 347"/>
           <p:cNvSpPr/>
           <p:nvPr/>
         </p:nvSpPr>
@@ -10306,7 +10118,7 @@
               </a:spcAft>
             </a:pPr>
             <a:r>
-              <a:rPr sz="450" b="1" i="0">
+              <a:rPr sz="459" b="1" i="0">
                 <a:solidFill>
                   <a:srgbClr val="111827"/>
                 </a:solidFill>
@@ -10322,13 +10134,13 @@
               </a:spcAft>
             </a:pPr>
             <a:r>
-              <a:rPr sz="450" b="0" i="0">
+              <a:rPr sz="459" b="0" i="0">
                 <a:solidFill>
                   <a:srgbClr val="111827"/>
                 </a:solidFill>
                 <a:latin typeface="Times New Roman"/>
               </a:rPr>
-              <a:t>Of 1,801 records, 342 duplicates were removed; 1,459 titles and abstracts were screened and 85 studies met the inclusion criteria (Fig. 1). Nearly half (49%) were published since 2020; most were cross-sectional (56%), and only 24% confirmed PMDD with prospective daily ratings.</a:t>
+              <a:t>The database search identified 1,943 records. After 325 duplicates were removed, 1,618 records were screened by title and abstract; 64 articles underwent full-text assessment, 20 were excluded, and 44 studies were included (Fig. 1).</a:t>
             </a:r>
           </a:p>
           <a:p>
@@ -10338,13 +10150,13 @@
               </a:spcAft>
             </a:pPr>
             <a:r>
-              <a:rPr sz="450" b="0" i="0">
+              <a:rPr sz="459" b="0" i="0">
                 <a:solidFill>
                   <a:srgbClr val="111827"/>
                 </a:solidFill>
                 <a:latin typeface="Times New Roman"/>
               </a:rPr>
-              <a:t>Depression was the most frequently examined outcome (n=28), followed by mood and emotion regulation and psychiatric comorbidity (n=18 each), psychological distress (n=16) and suicidal ideation or self-harm (n=13) (Fig. 2). PMDD was associated with suicidal ideation (OR 2.22) and attempts (OR 2.10) in a US national sample,⁵ and 72% of a global PMDD sample reported lifetime active suicidal ideation.⁶ Only 7 studies examined coping, mostly self-medication or maladaptive coping styles.</a:t>
+              <a:t>Depression was the most documented outcome (n=39), followed by psychological distress (n=24), interpersonal functioning (n=18), suicidal ideation or self-harm (n=14) and quality of life (n=14). Only three studies examined coping mechanisms (Fig. 2).</a:t>
             </a:r>
           </a:p>
           <a:p>
@@ -10354,13 +10166,13 @@
               </a:spcAft>
             </a:pPr>
             <a:r>
-              <a:rPr sz="450" b="0" i="0">
+              <a:rPr sz="459" b="0" i="0">
                 <a:solidFill>
                   <a:srgbClr val="111827"/>
                 </a:solidFill>
                 <a:latin typeface="Times New Roman"/>
               </a:rPr>
-              <a:t>Two-thirds of studies (67%) came from high-income countries; 3 came from sub-Saharan Africa (Fig. 3).</a:t>
+              <a:t>Geographic representation was critically skewed: three of the 44 studies (6.8%) originated from LMICs, including one from Nigeria, the only study from sub-Saharan Africa (Fig. 3).</a:t>
             </a:r>
           </a:p>
           <a:p>
@@ -10370,7 +10182,7 @@
               </a:spcAft>
             </a:pPr>
             <a:r>
-              <a:rPr sz="450" b="1" i="0">
+              <a:rPr sz="459" b="1" i="0">
                 <a:solidFill>
                   <a:srgbClr val="111827"/>
                 </a:solidFill>
@@ -10386,13 +10198,13 @@
               </a:spcAft>
             </a:pPr>
             <a:r>
-              <a:rPr sz="450" b="0" i="0">
+              <a:rPr sz="459" b="0" i="0">
                 <a:solidFill>
                   <a:srgbClr val="111827"/>
                 </a:solidFill>
                 <a:latin typeface="Times New Roman"/>
               </a:rPr>
-              <a:t>The literature consistently links PMDD with depression, suicidality, impaired functioning and reduced quality of life, but it relies heavily on provisional diagnoses, and coping and lived experience remain understudied. No study from sub-Saharan Africa examined suicidality, quality of life or coping, so the burden there is largely undocumented.</a:t>
+              <a:t>PMDD research consistently documents depression, distress, relationship difficulties and suicidality; large studies have linked PMDD with suicidal ideation and attempts.⁵,⁶ Yet coping mechanisms remain largely unexamined, and the near-absence of LMIC and African studies leaves the burden in these settings invisible to health systems.</a:t>
             </a:r>
           </a:p>
           <a:p>
@@ -10402,7 +10214,7 @@
               </a:spcAft>
             </a:pPr>
             <a:r>
-              <a:rPr sz="450" b="1" i="0">
+              <a:rPr sz="459" b="1" i="0">
                 <a:solidFill>
                   <a:srgbClr val="111827"/>
                 </a:solidFill>
@@ -10418,13 +10230,13 @@
               </a:spcAft>
             </a:pPr>
             <a:r>
-              <a:rPr sz="450" b="0" i="0">
+              <a:rPr sz="459" b="0" i="0">
                 <a:solidFill>
                   <a:srgbClr val="111827"/>
                 </a:solidFill>
                 <a:latin typeface="Times New Roman"/>
               </a:rPr>
-              <a:t>PMDD research documents a substantial psychosocial burden, while coping mechanisms and low-income settings remain underrepresented. Culturally responsive screening and Africa-centred research are needed.</a:t>
+              <a:t>Evidence on PMDD’s psychosocial burden is growing but geographically concentrated in high-income countries. Findings call for culturally responsive screening, integrated mental and reproductive health services, and Africa-centred research investment.</a:t>
             </a:r>
           </a:p>
           <a:p>
@@ -10434,7 +10246,7 @@
               </a:spcAft>
             </a:pPr>
             <a:r>
-              <a:rPr sz="450" b="1" i="0">
+              <a:rPr sz="459" b="1" i="0">
                 <a:solidFill>
                   <a:srgbClr val="111827"/>
                 </a:solidFill>
@@ -10452,22 +10264,22 @@
               <a:buChar char="•"/>
             </a:pPr>
             <a:r>
-              <a:rPr sz="450" b="1" i="0">
+              <a:rPr sz="459" b="1" i="0">
                 <a:solidFill>
                   <a:srgbClr val="111827"/>
                 </a:solidFill>
                 <a:latin typeface="Times New Roman"/>
               </a:rPr>
-              <a:t>Screening stage: </a:t>
-            </a:r>
-            <a:r>
-              <a:rPr sz="450" b="0" i="0">
+              <a:t>Search scope: </a:t>
+            </a:r>
+            <a:r>
+              <a:rPr sz="459" b="0" i="0">
                 <a:solidFill>
                   <a:srgbClr val="111827"/>
                 </a:solidFill>
                 <a:latin typeface="Times New Roman"/>
               </a:rPr>
-              <a:t>eligibility judged on titles and abstracts; full-text verification ongoing.</a:t>
+              <a:t>studies outside the five databases or the 2010–2025 period may have been missed.</a:t>
             </a:r>
           </a:p>
           <a:p>
@@ -10479,22 +10291,22 @@
               <a:buChar char="•"/>
             </a:pPr>
             <a:r>
-              <a:rPr sz="450" b="1" i="0">
+              <a:rPr sz="459" b="1" i="0">
                 <a:solidFill>
                   <a:srgbClr val="111827"/>
                 </a:solidFill>
                 <a:latin typeface="Times New Roman"/>
               </a:rPr>
-              <a:t>Search scope: </a:t>
-            </a:r>
-            <a:r>
-              <a:rPr sz="450" b="0" i="0">
+              <a:t>Study differences: </a:t>
+            </a:r>
+            <a:r>
+              <a:rPr sz="459" b="0" i="0">
                 <a:solidFill>
                   <a:srgbClr val="111827"/>
                 </a:solidFill>
                 <a:latin typeface="Times New Roman"/>
               </a:rPr>
-              <a:t>English only; African Journals Online and grey literature not searched.</a:t>
+              <a:t>variation in design and outcome definitions limits direct comparison.</a:t>
             </a:r>
           </a:p>
           <a:p>
@@ -10506,22 +10318,22 @@
               <a:buChar char="•"/>
             </a:pPr>
             <a:r>
-              <a:rPr sz="450" b="1" i="0">
+              <a:rPr sz="459" b="1" i="0">
                 <a:solidFill>
                   <a:srgbClr val="111827"/>
                 </a:solidFill>
                 <a:latin typeface="Times New Roman"/>
               </a:rPr>
-              <a:t>Diagnosis: </a:t>
-            </a:r>
-            <a:r>
-              <a:rPr sz="450" b="0" i="0">
+              <a:t>Coding overlap: </a:t>
+            </a:r>
+            <a:r>
+              <a:rPr sz="459" b="0" i="0">
                 <a:solidFill>
                   <a:srgbClr val="111827"/>
                 </a:solidFill>
                 <a:latin typeface="Times New Roman"/>
               </a:rPr>
-              <a:t>many studies used provisional diagnoses or combined PMS and PMDD.</a:t>
+              <a:t>a study could address more than one outcome, so counts should not be summed.</a:t>
             </a:r>
           </a:p>
           <a:p>
@@ -10533,29 +10345,29 @@
               <a:buChar char="•"/>
             </a:pPr>
             <a:r>
-              <a:rPr sz="450" b="1" i="0">
+              <a:rPr sz="459" b="1" i="0">
                 <a:solidFill>
                   <a:srgbClr val="111827"/>
                 </a:solidFill>
                 <a:latin typeface="Times New Roman"/>
               </a:rPr>
-              <a:t>Coding overlap: </a:t>
-            </a:r>
-            <a:r>
-              <a:rPr sz="450" b="0" i="0">
+              <a:t>Geographic coverage: </a:t>
+            </a:r>
+            <a:r>
+              <a:rPr sz="459" b="0" i="0">
                 <a:solidFill>
                   <a:srgbClr val="111827"/>
                 </a:solidFill>
                 <a:latin typeface="Times New Roman"/>
               </a:rPr>
-              <a:t>studies can address several domains, so counts should not be summed.</a:t>
-            </a:r>
-          </a:p>
-        </p:txBody>
-      </p:sp>
-      <p:sp>
-        <p:nvSpPr>
-          <p:cNvPr id="346" name="Rectangle 345"/>
+              <a:t>few LMIC studies limit conclusions about those settings.</a:t>
+            </a:r>
+          </a:p>
+        </p:txBody>
+      </p:sp>
+      <p:sp>
+        <p:nvSpPr>
+          <p:cNvPr id="349" name="Rectangle 348"/>
           <p:cNvSpPr/>
           <p:nvPr/>
         </p:nvSpPr>
@@ -10612,7 +10424,7 @@
       </p:sp>
       <p:sp>
         <p:nvSpPr>
-          <p:cNvPr id="347" name="Rectangle 346"/>
+          <p:cNvPr id="350" name="Rectangle 349"/>
           <p:cNvSpPr/>
           <p:nvPr/>
         </p:nvSpPr>
@@ -10847,7 +10659,7 @@
       </p:sp>
       <p:sp>
         <p:nvSpPr>
-          <p:cNvPr id="348" name="Rectangle 347"/>
+          <p:cNvPr id="351" name="Rectangle 350"/>
           <p:cNvSpPr/>
           <p:nvPr/>
         </p:nvSpPr>
@@ -10904,7 +10716,7 @@
       </p:sp>
       <p:sp>
         <p:nvSpPr>
-          <p:cNvPr id="349" name="Rectangle 348"/>
+          <p:cNvPr id="352" name="Rectangle 351"/>
           <p:cNvSpPr/>
           <p:nvPr/>
         </p:nvSpPr>

</xml_diff>

<commit_message>
Add world map to final PMDD poster
Fig 3 now shows a world map highlighting Nigeria, the only included
study from sub-Saharan Africa, alongside the verified LMIC share.

Co-Authored-By: Claude Opus 5.5 <noreply@anthropic.com>
Claude-Session: https://claude.ai/code/session_01VkRRDHxfMApHVBQgQibkFd
</commit_message>
<xml_diff>
--- a/PMDD_Scoping_Review/PMDD_APHA_Poster_FINAL.pptx
+++ b/PMDD_Scoping_Review/PMDD_APHA_Poster_FINAL.pptx
@@ -286,168 +286,6 @@
     <a:p>
       <a:pPr>
         <a:defRPr sz="459">
-          <a:solidFill>
-            <a:srgbClr val="111827"/>
-          </a:solidFill>
-          <a:latin typeface="Times New Roman"/>
-        </a:defRPr>
-      </a:pPr>
-      <a:endParaRPr lang="en-US"/>
-    </a:p>
-  </c:txPr>
-  <c:externalData r:id="rId1">
-    <c:autoUpdate val="0"/>
-  </c:externalData>
-</c:chartSpace>
-</file>
-
-<file path=ppt/charts/chart2.xml><?xml version="1.0" encoding="utf-8"?>
-<c:chartSpace xmlns:c="http://schemas.openxmlformats.org/drawingml/2006/chart" xmlns:a="http://schemas.openxmlformats.org/drawingml/2006/main" xmlns:r="http://schemas.openxmlformats.org/officeDocument/2006/relationships">
-  <c:date1904 val="0"/>
-  <c:chart>
-    <c:autoTitleDeleted val="1"/>
-    <c:plotArea>
-      <c:barChart>
-        <c:barDir val="bar"/>
-        <c:grouping val="clustered"/>
-        <c:ser>
-          <c:idx val="0"/>
-          <c:order val="0"/>
-          <c:tx>
-            <c:strRef>
-              <c:f>Sheet1!$B$1</c:f>
-              <c:strCache>
-                <c:ptCount val="1"/>
-                <c:pt idx="0">
-                  <c:v>Studies</c:v>
-                </c:pt>
-              </c:strCache>
-            </c:strRef>
-          </c:tx>
-          <c:spPr>
-            <a:solidFill>
-              <a:srgbClr val="0A254E"/>
-            </a:solidFill>
-          </c:spPr>
-          <c:dPt>
-            <c:idx val="1"/>
-            <c:spPr>
-              <a:solidFill>
-                <a:srgbClr val="A31F34"/>
-              </a:solidFill>
-            </c:spPr>
-          </c:dPt>
-          <c:cat>
-            <c:strRef>
-              <c:f>Sheet1!$A$2:$A$3</c:f>
-              <c:strCache>
-                <c:ptCount val="2"/>
-                <c:pt idx="0">
-                  <c:v>High-income / other settings</c:v>
-                </c:pt>
-                <c:pt idx="1">
-                  <c:v>Low- and middle-income countries</c:v>
-                </c:pt>
-              </c:strCache>
-            </c:strRef>
-          </c:cat>
-          <c:val>
-            <c:numRef>
-              <c:f>Sheet1!$B$2:$B$3</c:f>
-              <c:numCache>
-                <c:formatCode>General</c:formatCode>
-                <c:ptCount val="2"/>
-                <c:pt idx="0">
-                  <c:v>41</c:v>
-                </c:pt>
-                <c:pt idx="1">
-                  <c:v>3</c:v>
-                </c:pt>
-              </c:numCache>
-            </c:numRef>
-          </c:val>
-        </c:ser>
-        <c:dLbls>
-          <c:txPr>
-            <a:bodyPr/>
-            <a:lstStyle/>
-            <a:p>
-              <a:pPr>
-                <a:defRPr sz="500" b="1">
-                  <a:latin typeface="Times New Roman"/>
-                </a:defRPr>
-              </a:pPr>
-            </a:p>
-          </c:txPr>
-          <c:dLblPos val="outEnd"/>
-          <c:showLegendKey val="0"/>
-          <c:showVal val="1"/>
-          <c:showCatName val="0"/>
-          <c:showSerName val="0"/>
-          <c:showPercent val="0"/>
-          <c:showBubbleSize val="0"/>
-          <c:showLeaderLines val="1"/>
-        </c:dLbls>
-        <c:gapWidth val="45"/>
-        <c:axId val="-2068027336"/>
-        <c:axId val="-2113994440"/>
-      </c:barChart>
-      <c:catAx>
-        <c:axId val="-2068027336"/>
-        <c:scaling>
-          <c:orientation val="minMax"/>
-        </c:scaling>
-        <c:delete val="0"/>
-        <c:axPos val="l"/>
-        <c:majorTickMark val="out"/>
-        <c:minorTickMark val="none"/>
-        <c:tickLblPos val="nextTo"/>
-        <c:spPr>
-          <a:ln>
-            <a:solidFill>
-              <a:srgbClr val="9CA3AF"/>
-            </a:solidFill>
-          </a:ln>
-        </c:spPr>
-        <c:txPr>
-          <a:bodyPr/>
-          <a:lstStyle/>
-          <a:p>
-            <a:pPr>
-              <a:defRPr sz="500"/>
-            </a:pPr>
-          </a:p>
-        </c:txPr>
-        <c:crossAx val="-2113994440"/>
-        <c:crosses val="autoZero"/>
-        <c:auto val="1"/>
-        <c:lblAlgn val="ctr"/>
-        <c:lblOffset val="100"/>
-        <c:noMultiLvlLbl val="0"/>
-      </c:catAx>
-      <c:valAx>
-        <c:axId val="-2113994440"/>
-        <c:scaling>
-          <c:max val="48.0"/>
-          <c:min val="0.0"/>
-        </c:scaling>
-        <c:delete/>
-        <c:axPos val="b"/>
-        <c:majorTickMark val="out"/>
-        <c:minorTickMark val="none"/>
-        <c:tickLblPos val="nextTo"/>
-        <c:crossAx val="-2068027336"/>
-        <c:crosses val="autoZero"/>
-      </c:valAx>
-    </c:plotArea>
-    <c:dispBlanksAs val="gap"/>
-  </c:chart>
-  <c:txPr>
-    <a:bodyPr/>
-    <a:lstStyle/>
-    <a:p>
-      <a:pPr>
-        <a:defRPr sz="500">
           <a:solidFill>
             <a:srgbClr val="111827"/>
           </a:solidFill>
@@ -9865,24 +9703,30 @@
           </a:p>
         </p:txBody>
       </p:sp>
-      <p:graphicFrame>
-        <p:nvGraphicFramePr>
-          <p:cNvPr id="344" name="Chart 343"/>
-          <p:cNvGraphicFramePr>
-            <a:graphicFrameLocks noGrp="1"/>
-          </p:cNvGraphicFramePr>
+      <p:pic>
+        <p:nvPicPr>
+          <p:cNvPr id="344" name="Picture 343" descr="fig3_map.png"/>
+          <p:cNvPicPr>
+            <a:picLocks noChangeAspect="1"/>
+          </p:cNvPicPr>
           <p:nvPr/>
-        </p:nvGraphicFramePr>
-        <p:xfrm>
-          <a:off x="2414016" y="4864608"/>
-          <a:ext cx="2651760" cy="1097280"/>
-        </p:xfrm>
-        <a:graphic>
-          <a:graphicData uri="http://schemas.openxmlformats.org/drawingml/2006/chart">
-            <c:chart xmlns:c="http://schemas.openxmlformats.org/drawingml/2006/chart" r:id="rId10"/>
-          </a:graphicData>
-        </a:graphic>
-      </p:graphicFrame>
+        </p:nvPicPr>
+        <p:blipFill>
+          <a:blip r:embed="rId10"/>
+          <a:stretch>
+            <a:fillRect/>
+          </a:stretch>
+        </p:blipFill>
+        <p:spPr>
+          <a:xfrm>
+            <a:off x="2414016" y="4837176"/>
+            <a:ext cx="3108960" cy="1276399"/>
+          </a:xfrm>
+          <a:prstGeom prst="rect">
+            <a:avLst/>
+          </a:prstGeom>
+        </p:spPr>
+      </p:pic>
       <p:sp>
         <p:nvSpPr>
           <p:cNvPr id="345" name="Rounded Rectangle 344"/>
@@ -9891,8 +9735,8 @@
         </p:nvSpPr>
         <p:spPr>
           <a:xfrm>
-            <a:off x="5212080" y="4910328"/>
-            <a:ext cx="1737360" cy="1005840"/>
+            <a:off x="5577840" y="4956048"/>
+            <a:ext cx="1371600" cy="1097280"/>
           </a:xfrm>
           <a:prstGeom prst="roundRect">
             <a:avLst>
@@ -9949,13 +9793,29 @@
               </a:spcAft>
             </a:pPr>
             <a:r>
-              <a:rPr sz="550" b="0" i="0">
+              <a:rPr sz="520" b="0" i="0">
                 <a:solidFill>
                   <a:srgbClr val="111827"/>
                 </a:solidFill>
                 <a:latin typeface="Times New Roman"/>
               </a:rPr>
-              <a:t>of included studies came from LMICs</a:t>
+              <a:t>of included studies (3 of 44) came from LMICs</a:t>
+            </a:r>
+          </a:p>
+          <a:p>
+            <a:pPr algn="ctr">
+              <a:spcAft>
+                <a:spcPts val="100"/>
+              </a:spcAft>
+            </a:pPr>
+            <a:r>
+              <a:rPr sz="520" b="0" i="0">
+                <a:solidFill>
+                  <a:srgbClr val="111827"/>
+                </a:solidFill>
+                <a:latin typeface="Times New Roman"/>
+              </a:rPr>
+              <a:t>41 of 44 (93.2%) from high-income or other settings</a:t>
             </a:r>
           </a:p>
           <a:p>
@@ -9965,7 +9825,7 @@
               </a:spcAft>
             </a:pPr>
             <a:r>
-              <a:rPr sz="550" b="1" i="0">
+              <a:rPr sz="520" b="1" i="0">
                 <a:solidFill>
                   <a:srgbClr val="A31F34"/>
                 </a:solidFill>
@@ -9984,8 +9844,8 @@
         </p:nvSpPr>
         <p:spPr>
           <a:xfrm>
-            <a:off x="2414016" y="5989320"/>
-            <a:ext cx="4572000" cy="457200"/>
+            <a:off x="2414016" y="6217920"/>
+            <a:ext cx="4572000" cy="365760"/>
           </a:xfrm>
           <a:prstGeom prst="rect">
             <a:avLst/>
@@ -10010,7 +9870,7 @@
                 </a:solidFill>
                 <a:latin typeface="Times New Roman"/>
               </a:rPr>
-              <a:t>41 of 44 studies (93.2%) were conducted in high-income or other non-LMIC settings; 3 (6.8%) came from LMICs, only one of them from sub-Saharan Africa. Evidence on PMDD’s psychosocial burden therefore reflects mainly high-income contexts.</a:t>
+              <a:t>Nigeria (red) is the only included study from sub-Saharan Africa. Evidence on PMDD’s psychosocial burden reflects mainly high-income contexts.</a:t>
             </a:r>
           </a:p>
         </p:txBody>

</xml_diff>

<commit_message>
Shade high-income countries on the poster map
Adds World Bank high-income countries as a labelled background layer,
with a caption noting that not every shaded country contributed a
study.

Co-Authored-By: Claude Opus 5.5 <noreply@anthropic.com>
Claude-Session: https://claude.ai/code/session_01VkRRDHxfMApHVBQgQibkFd
</commit_message>
<xml_diff>
--- a/PMDD_Scoping_Review/PMDD_APHA_Poster_FINAL.pptx
+++ b/PMDD_Scoping_Review/PMDD_APHA_Poster_FINAL.pptx
@@ -9720,7 +9720,7 @@
         <p:spPr>
           <a:xfrm>
             <a:off x="2414016" y="4837176"/>
-            <a:ext cx="3108960" cy="1276399"/>
+            <a:ext cx="3108960" cy="1256792"/>
           </a:xfrm>
           <a:prstGeom prst="rect">
             <a:avLst/>
@@ -9870,7 +9870,7 @@
                 </a:solidFill>
                 <a:latin typeface="Times New Roman"/>
               </a:rPr>
-              <a:t>Nigeria (red) is the only included study from sub-Saharan Africa. Evidence on PMDD’s psychosocial burden reflects mainly high-income contexts.</a:t>
+              <a:t>Navy shading shows World Bank high-income countries (FY2027); 41 of 44 studies came from high-income or other non-LMIC settings, but not every shaded country contributed a study. Nigeria (red) is the only study from sub-Saharan Africa.</a:t>
             </a:r>
           </a:p>
         </p:txBody>

</xml_diff>

<commit_message>
Correct poster screening labels, income wording and map
Labels the 64-record stage as title/abstract eligibility assessment,
describes the 3 studies as low- and lower-middle-income, and maps the
countries of the 44 listed studies. Adds the country coding of the 44.

Co-Authored-By: Claude Opus 5.5 <noreply@anthropic.com>
Claude-Session: https://claude.ai/code/session_01VkRRDHxfMApHVBQgQibkFd
</commit_message>
<xml_diff>
--- a/PMDD_Scoping_Review/PMDD_APHA_Poster_FINAL.pptx
+++ b/PMDD_Scoping_Review/PMDD_APHA_Poster_FINAL.pptx
@@ -7148,7 +7148,7 @@
                 </a:solidFill>
                 <a:latin typeface="Times New Roman"/>
               </a:rPr>
-              <a:t>The search identified 1,943 records; 1,618 remained after deduplication and 44 studies met the inclusion criteria. Depression was most documented (n=39), followed by psychological distress (n=24), interpersonal functioning (n=18), suicidal ideation or self-harm (n=14) and quality of life (n=14). Only three studies examined coping mechanisms. Three studies (6.8%) originated from low- and middle-income countries (LMICs), including one from Nigeria.</a:t>
+              <a:t>The search identified 1,943 records; 1,618 remained after deduplication and 44 studies met the inclusion criteria. Depression was most documented (n=39), followed by psychological distress (n=24), interpersonal functioning (n=18), suicidal ideation or self-harm (n=14) and quality of life (n=14). Only three studies examined coping mechanisms. Only three studies (6.8%) originated from low- and lower-middle-income countries, including one from Nigeria.</a:t>
             </a:r>
           </a:p>
           <a:p>
@@ -7766,7 +7766,7 @@
                           </a:solidFill>
                           <a:latin typeface="Times New Roman"/>
                         </a:rPr>
-                        <a:t>1,943 records identified; 325 duplicates removed; 1,618 titles and abstracts screened; 64 full-text articles assessed; 44 studies included.</a:t>
+                        <a:t>1,943 records identified; 325 duplicates removed; 1,618 records screened by title and abstract; 64 assessed for eligibility; 44 studies included.</a:t>
                       </a:r>
                     </a:p>
                   </a:txBody>
@@ -8160,7 +8160,7 @@
                 </a:solidFill>
                 <a:latin typeface="Times New Roman"/>
               </a:rPr>
-              <a:t>studies from LMICs</a:t>
+              <a:t>low/lower-middle-income studies</a:t>
             </a:r>
           </a:p>
           <a:p>
@@ -9164,7 +9164,7 @@
                 </a:solidFill>
                 <a:latin typeface="Times New Roman"/>
               </a:rPr>
-              <a:t>Full-text articles assessed</a:t>
+              <a:t>Records assessed for eligibility</a:t>
             </a:r>
           </a:p>
           <a:p>
@@ -9180,7 +9180,7 @@
                 </a:solidFill>
                 <a:latin typeface="Times New Roman"/>
               </a:rPr>
-              <a:t>for eligibility</a:t>
+              <a:t>(title and abstract)</a:t>
             </a:r>
           </a:p>
           <a:p>
@@ -9273,7 +9273,7 @@
                 </a:solidFill>
                 <a:latin typeface="Times New Roman"/>
               </a:rPr>
-              <a:t>Did not meet inclusion</a:t>
+              <a:t>Did not meet</a:t>
             </a:r>
           </a:p>
           <a:p>
@@ -9289,7 +9289,7 @@
                 </a:solidFill>
                 <a:latin typeface="Times New Roman"/>
               </a:rPr>
-              <a:t>criteria at full text</a:t>
+              <a:t>inclusion criteria</a:t>
             </a:r>
           </a:p>
         </p:txBody>
@@ -9720,7 +9720,7 @@
         <p:spPr>
           <a:xfrm>
             <a:off x="2414016" y="4837176"/>
-            <a:ext cx="3108960" cy="1256792"/>
+            <a:ext cx="3108960" cy="1243968"/>
           </a:xfrm>
           <a:prstGeom prst="rect">
             <a:avLst/>
@@ -9799,7 +9799,7 @@
                 </a:solidFill>
                 <a:latin typeface="Times New Roman"/>
               </a:rPr>
-              <a:t>of included studies (3 of 44) came from LMICs</a:t>
+              <a:t>of included studies (3 of 44) came from low- and lower-middle-income countries</a:t>
             </a:r>
           </a:p>
           <a:p>
@@ -9815,7 +9815,7 @@
                 </a:solidFill>
                 <a:latin typeface="Times New Roman"/>
               </a:rPr>
-              <a:t>41 of 44 (93.2%) from high-income or other settings</a:t>
+              <a:t>20 high-income · 7 upper-middle-income</a:t>
             </a:r>
           </a:p>
           <a:p>
@@ -9870,7 +9870,7 @@
                 </a:solidFill>
                 <a:latin typeface="Times New Roman"/>
               </a:rPr>
-              <a:t>Navy shading shows World Bank high-income countries (FY2027); 41 of 44 studies came from high-income or other non-LMIC settings, but not every shaded country contributed a study. Nigeria (red) is the only study from sub-Saharan Africa.</a:t>
+              <a:t>Shaded countries contributed at least one study (World Bank FY2027 income groups). Also included: Hong Kong (1; not visible at this scale), online or multinational samples (4), country not reported (1), and 9 studies whose setting is being verified.</a:t>
             </a:r>
           </a:p>
         </p:txBody>
@@ -10000,7 +10000,7 @@
                 </a:solidFill>
                 <a:latin typeface="Times New Roman"/>
               </a:rPr>
-              <a:t>The database search identified 1,943 records. After 325 duplicates were removed, 1,618 records were screened by title and abstract; 64 articles underwent full-text assessment, 20 were excluded, and 44 studies were included (Fig. 1).</a:t>
+              <a:t>The database search identified 1,943 records. After 325 duplicates were removed, 1,618 records were screened by title and abstract; 64 were assessed for eligibility, 20 were excluded, and 44 studies were included (Fig. 1).</a:t>
             </a:r>
           </a:p>
           <a:p>
@@ -10032,7 +10032,7 @@
                 </a:solidFill>
                 <a:latin typeface="Times New Roman"/>
               </a:rPr>
-              <a:t>Geographic representation was critically skewed: three of the 44 studies (6.8%) originated from LMICs, including one from Nigeria, the only study from sub-Saharan Africa (Fig. 3).</a:t>
+              <a:t>Geographic representation was skewed: 20 studies came from high-income countries and 7 from upper-middle-income countries (Türkiye, Iran); only three (6.8%) came from low- and lower-middle-income countries (Bangladesh, Lebanon, Nigeria), and Nigeria was the only study from sub-Saharan Africa (Fig. 3).</a:t>
             </a:r>
           </a:p>
           <a:p>
@@ -10064,7 +10064,7 @@
                 </a:solidFill>
                 <a:latin typeface="Times New Roman"/>
               </a:rPr>
-              <a:t>PMDD research consistently documents depression, distress, relationship difficulties and suicidality; large studies have linked PMDD with suicidal ideation and attempts.⁵,⁶ Yet coping mechanisms remain largely unexamined, and the near-absence of LMIC and African studies leaves the burden in these settings invisible to health systems.</a:t>
+              <a:t>PMDD research consistently documents depression, distress, relationship difficulties and suicidality; large studies have linked PMDD with suicidal ideation and attempts.⁵,⁶ Yet coping mechanisms remain largely unexamined, and the scarcity of studies from low- and lower-middle-income countries and Africa leaves the burden in these settings invisible to health systems.</a:t>
             </a:r>
           </a:p>
           <a:p>
@@ -10220,7 +10220,7 @@
                 </a:solidFill>
                 <a:latin typeface="Times New Roman"/>
               </a:rPr>
-              <a:t>few LMIC studies limit conclusions about those settings.</a:t>
+              <a:t>few studies from low- and lower-middle-income countries limit conclusions about those settings.</a:t>
             </a:r>
           </a:p>
         </p:txBody>

</xml_diff>

<commit_message>
Label every mapped country with its study count
Co-Authored-By: Claude Opus 5.5 <noreply@anthropic.com>
Claude-Session: https://claude.ai/code/session_01VkRRDHxfMApHVBQgQibkFd
</commit_message>
<xml_diff>
--- a/PMDD_Scoping_Review/PMDD_APHA_Poster_FINAL.pptx
+++ b/PMDD_Scoping_Review/PMDD_APHA_Poster_FINAL.pptx
@@ -9720,7 +9720,7 @@
         <p:spPr>
           <a:xfrm>
             <a:off x="2414016" y="4837176"/>
-            <a:ext cx="3108960" cy="1243968"/>
+            <a:ext cx="3108960" cy="1399585"/>
           </a:xfrm>
           <a:prstGeom prst="rect">
             <a:avLst/>
@@ -9870,7 +9870,7 @@
                 </a:solidFill>
                 <a:latin typeface="Times New Roman"/>
               </a:rPr>
-              <a:t>Shaded countries contributed at least one study (World Bank FY2027 income groups). Also included: Hong Kong (1; not visible at this scale), online or multinational samples (4), country not reported (1), and 9 studies whose setting is being verified.</a:t>
+              <a:t>Numbers show studies per country (World Bank FY2027 income groups). *Includes Hong Kong (1; not visible at this scale). Also included: online or multinational samples (4), country not reported (1), and 9 studies whose setting is being verified.</a:t>
             </a:r>
           </a:p>
         </p:txBody>

</xml_diff>

<commit_message>
Add publication-period chart to the PMDD poster
Co-Authored-By: Claude Opus 5.5 <noreply@anthropic.com>
Claude-Session: https://claude.ai/code/session_01VkRRDHxfMApHVBQgQibkFd
</commit_message>
<xml_diff>
--- a/PMDD_Scoping_Review/PMDD_APHA_Poster_FINAL.pptx
+++ b/PMDD_Scoping_Review/PMDD_APHA_Poster_FINAL.pptx
@@ -286,6 +286,180 @@
     <a:p>
       <a:pPr>
         <a:defRPr sz="459">
+          <a:solidFill>
+            <a:srgbClr val="111827"/>
+          </a:solidFill>
+          <a:latin typeface="Times New Roman"/>
+        </a:defRPr>
+      </a:pPr>
+      <a:endParaRPr lang="en-US"/>
+    </a:p>
+  </c:txPr>
+  <c:externalData r:id="rId1">
+    <c:autoUpdate val="0"/>
+  </c:externalData>
+</c:chartSpace>
+</file>
+
+<file path=ppt/charts/chart2.xml><?xml version="1.0" encoding="utf-8"?>
+<c:chartSpace xmlns:c="http://schemas.openxmlformats.org/drawingml/2006/chart" xmlns:a="http://schemas.openxmlformats.org/drawingml/2006/main" xmlns:r="http://schemas.openxmlformats.org/officeDocument/2006/relationships">
+  <c:date1904 val="0"/>
+  <c:chart>
+    <c:autoTitleDeleted val="1"/>
+    <c:plotArea>
+      <c:barChart>
+        <c:barDir val="col"/>
+        <c:grouping val="clustered"/>
+        <c:ser>
+          <c:idx val="0"/>
+          <c:order val="0"/>
+          <c:tx>
+            <c:strRef>
+              <c:f>Sheet1!$B$1</c:f>
+              <c:strCache>
+                <c:ptCount val="1"/>
+                <c:pt idx="0">
+                  <c:v>Studies</c:v>
+                </c:pt>
+              </c:strCache>
+            </c:strRef>
+          </c:tx>
+          <c:spPr>
+            <a:solidFill>
+              <a:srgbClr val="0A254E"/>
+            </a:solidFill>
+          </c:spPr>
+          <c:dPt>
+            <c:idx val="3"/>
+            <c:spPr>
+              <a:solidFill>
+                <a:srgbClr val="A31F34"/>
+              </a:solidFill>
+            </c:spPr>
+          </c:dPt>
+          <c:cat>
+            <c:strRef>
+              <c:f>Sheet1!$A$2:$A$5</c:f>
+              <c:strCache>
+                <c:ptCount val="4"/>
+                <c:pt idx="0">
+                  <c:v>2010–13</c:v>
+                </c:pt>
+                <c:pt idx="1">
+                  <c:v>2014–17</c:v>
+                </c:pt>
+                <c:pt idx="2">
+                  <c:v>2018–21</c:v>
+                </c:pt>
+                <c:pt idx="3">
+                  <c:v>2022–25</c:v>
+                </c:pt>
+              </c:strCache>
+            </c:strRef>
+          </c:cat>
+          <c:val>
+            <c:numRef>
+              <c:f>Sheet1!$B$2:$B$5</c:f>
+              <c:numCache>
+                <c:formatCode>General</c:formatCode>
+                <c:ptCount val="4"/>
+                <c:pt idx="0">
+                  <c:v>6</c:v>
+                </c:pt>
+                <c:pt idx="1">
+                  <c:v>6</c:v>
+                </c:pt>
+                <c:pt idx="2">
+                  <c:v>5</c:v>
+                </c:pt>
+                <c:pt idx="3">
+                  <c:v>27</c:v>
+                </c:pt>
+              </c:numCache>
+            </c:numRef>
+          </c:val>
+        </c:ser>
+        <c:dLbls>
+          <c:txPr>
+            <a:bodyPr/>
+            <a:lstStyle/>
+            <a:p>
+              <a:pPr>
+                <a:defRPr sz="420" b="1">
+                  <a:latin typeface="Times New Roman"/>
+                </a:defRPr>
+              </a:pPr>
+            </a:p>
+          </c:txPr>
+          <c:dLblPos val="outEnd"/>
+          <c:showLegendKey val="0"/>
+          <c:showVal val="1"/>
+          <c:showCatName val="0"/>
+          <c:showSerName val="0"/>
+          <c:showPercent val="0"/>
+          <c:showBubbleSize val="0"/>
+          <c:showLeaderLines val="1"/>
+        </c:dLbls>
+        <c:gapWidth val="45"/>
+        <c:axId val="-2068027336"/>
+        <c:axId val="-2113994440"/>
+      </c:barChart>
+      <c:catAx>
+        <c:axId val="-2068027336"/>
+        <c:scaling>
+          <c:orientation val="minMax"/>
+        </c:scaling>
+        <c:delete val="0"/>
+        <c:axPos val="b"/>
+        <c:majorTickMark val="out"/>
+        <c:minorTickMark val="none"/>
+        <c:tickLblPos val="nextTo"/>
+        <c:spPr>
+          <a:ln>
+            <a:solidFill>
+              <a:srgbClr val="9CA3AF"/>
+            </a:solidFill>
+          </a:ln>
+        </c:spPr>
+        <c:txPr>
+          <a:bodyPr/>
+          <a:lstStyle/>
+          <a:p>
+            <a:pPr>
+              <a:defRPr sz="420"/>
+            </a:pPr>
+          </a:p>
+        </c:txPr>
+        <c:crossAx val="-2113994440"/>
+        <c:crosses val="autoZero"/>
+        <c:auto val="1"/>
+        <c:lblAlgn val="ctr"/>
+        <c:lblOffset val="100"/>
+        <c:noMultiLvlLbl val="0"/>
+      </c:catAx>
+      <c:valAx>
+        <c:axId val="-2113994440"/>
+        <c:scaling>
+          <c:max val="32.0"/>
+          <c:min val="0.0"/>
+        </c:scaling>
+        <c:delete/>
+        <c:axPos val="l"/>
+        <c:majorTickMark val="out"/>
+        <c:minorTickMark val="none"/>
+        <c:tickLblPos val="nextTo"/>
+        <c:crossAx val="-2068027336"/>
+        <c:crosses val="autoZero"/>
+      </c:valAx>
+    </c:plotArea>
+    <c:dispBlanksAs val="gap"/>
+  </c:chart>
+  <c:txPr>
+    <a:bodyPr/>
+    <a:lstStyle/>
+    <a:p>
+      <a:pPr>
+        <a:defRPr sz="420">
           <a:solidFill>
             <a:srgbClr val="111827"/>
           </a:solidFill>
@@ -9974,11 +10148,11 @@
           <a:p>
             <a:pPr algn="just">
               <a:spcAft>
-                <a:spcPts val="150"/>
+                <a:spcPts val="100"/>
               </a:spcAft>
             </a:pPr>
             <a:r>
-              <a:rPr sz="459" b="1" i="0">
+              <a:rPr sz="409" b="1" i="0">
                 <a:solidFill>
                   <a:srgbClr val="111827"/>
                 </a:solidFill>
@@ -9990,11 +10164,11 @@
           <a:p>
             <a:pPr algn="just">
               <a:spcAft>
-                <a:spcPts val="150"/>
+                <a:spcPts val="100"/>
               </a:spcAft>
             </a:pPr>
             <a:r>
-              <a:rPr sz="459" b="0" i="0">
+              <a:rPr sz="409" b="0" i="0">
                 <a:solidFill>
                   <a:srgbClr val="111827"/>
                 </a:solidFill>
@@ -10006,11 +10180,11 @@
           <a:p>
             <a:pPr algn="just">
               <a:spcAft>
-                <a:spcPts val="150"/>
+                <a:spcPts val="100"/>
               </a:spcAft>
             </a:pPr>
             <a:r>
-              <a:rPr sz="459" b="0" i="0">
+              <a:rPr sz="409" b="0" i="0">
                 <a:solidFill>
                   <a:srgbClr val="111827"/>
                 </a:solidFill>
@@ -10022,11 +10196,11 @@
           <a:p>
             <a:pPr algn="just">
               <a:spcAft>
-                <a:spcPts val="150"/>
+                <a:spcPts val="100"/>
               </a:spcAft>
             </a:pPr>
             <a:r>
-              <a:rPr sz="459" b="0" i="0">
+              <a:rPr sz="409" b="0" i="0">
                 <a:solidFill>
                   <a:srgbClr val="111827"/>
                 </a:solidFill>
@@ -10038,11 +10212,11 @@
           <a:p>
             <a:pPr algn="just">
               <a:spcAft>
-                <a:spcPts val="150"/>
+                <a:spcPts val="100"/>
               </a:spcAft>
             </a:pPr>
             <a:r>
-              <a:rPr sz="459" b="1" i="0">
+              <a:rPr sz="409" b="1" i="0">
                 <a:solidFill>
                   <a:srgbClr val="111827"/>
                 </a:solidFill>
@@ -10054,11 +10228,11 @@
           <a:p>
             <a:pPr algn="just">
               <a:spcAft>
-                <a:spcPts val="150"/>
+                <a:spcPts val="100"/>
               </a:spcAft>
             </a:pPr>
             <a:r>
-              <a:rPr sz="459" b="0" i="0">
+              <a:rPr sz="409" b="0" i="0">
                 <a:solidFill>
                   <a:srgbClr val="111827"/>
                 </a:solidFill>
@@ -10070,11 +10244,11 @@
           <a:p>
             <a:pPr algn="just">
               <a:spcAft>
-                <a:spcPts val="150"/>
+                <a:spcPts val="100"/>
               </a:spcAft>
             </a:pPr>
             <a:r>
-              <a:rPr sz="459" b="1" i="0">
+              <a:rPr sz="409" b="1" i="0">
                 <a:solidFill>
                   <a:srgbClr val="111827"/>
                 </a:solidFill>
@@ -10086,11 +10260,11 @@
           <a:p>
             <a:pPr algn="just">
               <a:spcAft>
-                <a:spcPts val="150"/>
+                <a:spcPts val="100"/>
               </a:spcAft>
             </a:pPr>
             <a:r>
-              <a:rPr sz="459" b="0" i="0">
+              <a:rPr sz="409" b="0" i="0">
                 <a:solidFill>
                   <a:srgbClr val="111827"/>
                 </a:solidFill>
@@ -10102,11 +10276,11 @@
           <a:p>
             <a:pPr algn="just">
               <a:spcAft>
-                <a:spcPts val="150"/>
+                <a:spcPts val="100"/>
               </a:spcAft>
             </a:pPr>
             <a:r>
-              <a:rPr sz="459" b="1" i="0">
+              <a:rPr sz="409" b="1" i="0">
                 <a:solidFill>
                   <a:srgbClr val="111827"/>
                 </a:solidFill>
@@ -10118,13 +10292,13 @@
           <a:p>
             <a:pPr algn="just" marL="73152" indent="-64008">
               <a:spcAft>
-                <a:spcPts val="150"/>
+                <a:spcPts val="100"/>
               </a:spcAft>
               <a:buFont typeface="Arial"/>
               <a:buChar char="•"/>
             </a:pPr>
             <a:r>
-              <a:rPr sz="459" b="1" i="0">
+              <a:rPr sz="409" b="1" i="0">
                 <a:solidFill>
                   <a:srgbClr val="111827"/>
                 </a:solidFill>
@@ -10133,7 +10307,7 @@
               <a:t>Search scope: </a:t>
             </a:r>
             <a:r>
-              <a:rPr sz="459" b="0" i="0">
+              <a:rPr sz="409" b="0" i="0">
                 <a:solidFill>
                   <a:srgbClr val="111827"/>
                 </a:solidFill>
@@ -10145,13 +10319,13 @@
           <a:p>
             <a:pPr algn="just" marL="73152" indent="-64008">
               <a:spcAft>
-                <a:spcPts val="150"/>
+                <a:spcPts val="100"/>
               </a:spcAft>
               <a:buFont typeface="Arial"/>
               <a:buChar char="•"/>
             </a:pPr>
             <a:r>
-              <a:rPr sz="459" b="1" i="0">
+              <a:rPr sz="409" b="1" i="0">
                 <a:solidFill>
                   <a:srgbClr val="111827"/>
                 </a:solidFill>
@@ -10160,7 +10334,7 @@
               <a:t>Study differences: </a:t>
             </a:r>
             <a:r>
-              <a:rPr sz="459" b="0" i="0">
+              <a:rPr sz="409" b="0" i="0">
                 <a:solidFill>
                   <a:srgbClr val="111827"/>
                 </a:solidFill>
@@ -10172,13 +10346,13 @@
           <a:p>
             <a:pPr algn="just" marL="73152" indent="-64008">
               <a:spcAft>
-                <a:spcPts val="150"/>
+                <a:spcPts val="100"/>
               </a:spcAft>
               <a:buFont typeface="Arial"/>
               <a:buChar char="•"/>
             </a:pPr>
             <a:r>
-              <a:rPr sz="459" b="1" i="0">
+              <a:rPr sz="409" b="1" i="0">
                 <a:solidFill>
                   <a:srgbClr val="111827"/>
                 </a:solidFill>
@@ -10187,7 +10361,7 @@
               <a:t>Coding overlap: </a:t>
             </a:r>
             <a:r>
-              <a:rPr sz="459" b="0" i="0">
+              <a:rPr sz="409" b="0" i="0">
                 <a:solidFill>
                   <a:srgbClr val="111827"/>
                 </a:solidFill>
@@ -10199,13 +10373,13 @@
           <a:p>
             <a:pPr algn="just" marL="73152" indent="-64008">
               <a:spcAft>
-                <a:spcPts val="150"/>
+                <a:spcPts val="100"/>
               </a:spcAft>
               <a:buFont typeface="Arial"/>
               <a:buChar char="•"/>
             </a:pPr>
             <a:r>
-              <a:rPr sz="459" b="1" i="0">
+              <a:rPr sz="409" b="1" i="0">
                 <a:solidFill>
                   <a:srgbClr val="111827"/>
                 </a:solidFill>
@@ -10214,7 +10388,7 @@
               <a:t>Geographic coverage: </a:t>
             </a:r>
             <a:r>
-              <a:rPr sz="459" b="0" i="0">
+              <a:rPr sz="409" b="0" i="0">
                 <a:solidFill>
                   <a:srgbClr val="111827"/>
                 </a:solidFill>
@@ -10723,6 +10897,102 @@
                 <a:latin typeface="Times New Roman"/>
               </a:rPr>
               <a:t>Scan the QR code for the full reference list.</a:t>
+            </a:r>
+          </a:p>
+        </p:txBody>
+      </p:sp>
+      <p:sp>
+        <p:nvSpPr>
+          <p:cNvPr id="353" name="TextBox 352"/>
+          <p:cNvSpPr txBox="1"/>
+          <p:nvPr/>
+        </p:nvSpPr>
+        <p:spPr>
+          <a:xfrm>
+            <a:off x="7162495" y="3291840"/>
+            <a:ext cx="1826056" cy="118872"/>
+          </a:xfrm>
+          <a:prstGeom prst="rect">
+            <a:avLst/>
+          </a:prstGeom>
+          <a:noFill/>
+        </p:spPr>
+        <p:txBody>
+          <a:bodyPr wrap="square" anchor="t" lIns="27432" rIns="27432" tIns="13716" bIns="13716">
+            <a:spAutoFit/>
+          </a:bodyPr>
+          <a:lstStyle/>
+          <a:p>
+            <a:pPr algn="l">
+              <a:spcAft>
+                <a:spcPts val="120"/>
+              </a:spcAft>
+            </a:pPr>
+            <a:r>
+              <a:rPr sz="459" b="1" i="0">
+                <a:solidFill>
+                  <a:srgbClr val="0A254E"/>
+                </a:solidFill>
+                <a:latin typeface="Times New Roman"/>
+              </a:rPr>
+              <a:t>Fig 4. Included Studies by Publication Period</a:t>
+            </a:r>
+          </a:p>
+        </p:txBody>
+      </p:sp>
+      <p:graphicFrame>
+        <p:nvGraphicFramePr>
+          <p:cNvPr id="354" name="Chart 353"/>
+          <p:cNvGraphicFramePr>
+            <a:graphicFrameLocks noGrp="1"/>
+          </p:cNvGraphicFramePr>
+          <p:nvPr/>
+        </p:nvGraphicFramePr>
+        <p:xfrm>
+          <a:off x="7199071" y="3401568"/>
+          <a:ext cx="1752904" cy="548640"/>
+        </p:xfrm>
+        <a:graphic>
+          <a:graphicData uri="http://schemas.openxmlformats.org/drawingml/2006/chart">
+            <c:chart xmlns:c="http://schemas.openxmlformats.org/drawingml/2006/chart" r:id="rId11"/>
+          </a:graphicData>
+        </a:graphic>
+      </p:graphicFrame>
+      <p:sp>
+        <p:nvSpPr>
+          <p:cNvPr id="355" name="TextBox 354"/>
+          <p:cNvSpPr txBox="1"/>
+          <p:nvPr/>
+        </p:nvSpPr>
+        <p:spPr>
+          <a:xfrm>
+            <a:off x="7162495" y="3950208"/>
+            <a:ext cx="1826056" cy="91440"/>
+          </a:xfrm>
+          <a:prstGeom prst="rect">
+            <a:avLst/>
+          </a:prstGeom>
+          <a:noFill/>
+        </p:spPr>
+        <p:txBody>
+          <a:bodyPr wrap="square" anchor="t" lIns="27432" rIns="27432" tIns="13716" bIns="13716">
+            <a:spAutoFit/>
+          </a:bodyPr>
+          <a:lstStyle/>
+          <a:p>
+            <a:pPr algn="ctr">
+              <a:spcAft>
+                <a:spcPts val="120"/>
+              </a:spcAft>
+            </a:pPr>
+            <a:r>
+              <a:rPr sz="350" b="0" i="1">
+                <a:solidFill>
+                  <a:srgbClr val="4B5563"/>
+                </a:solidFill>
+                <a:latin typeface="Times New Roman"/>
+              </a:rPr>
+              <a:t>27 of 44 studies (61%) were published in 2022–2025.</a:t>
             </a:r>
           </a:p>
         </p:txBody>

</xml_diff>

<commit_message>
Convert PMDD poster to AMA citations and add full AMA reference list
Adds numbered AMA superscript citations (20 references) across the
poster, a key-takeaway banner, fuller introduction and public health
sections, and a 51-entry AMA reference document for the QR code.

Co-Authored-By: Claude Opus 5.5 <noreply@anthropic.com>
Claude-Session: https://claude.ai/code/session_01VkRRDHxfMApHVBQgQibkFd
</commit_message>
<xml_diff>
--- a/PMDD_Scoping_Review/PMDD_APHA_Poster_FINAL.pptx
+++ b/PMDD_Scoping_Review/PMDD_APHA_Poster_FINAL.pptx
@@ -7091,8 +7091,8 @@
         </p:blipFill>
         <p:spPr>
           <a:xfrm>
-            <a:off x="7125919" y="5788152"/>
-            <a:ext cx="914400" cy="914400"/>
+            <a:off x="7135063" y="5815584"/>
+            <a:ext cx="786384" cy="786384"/>
           </a:xfrm>
           <a:prstGeom prst="rect">
             <a:avLst/>
@@ -7253,11 +7253,11 @@
           <a:p>
             <a:pPr algn="just">
               <a:spcAft>
-                <a:spcPts val="140"/>
+                <a:spcPts val="120"/>
               </a:spcAft>
             </a:pPr>
             <a:r>
-              <a:rPr sz="434" b="1" i="0">
+              <a:rPr sz="430" b="1" i="0">
                 <a:solidFill>
                   <a:srgbClr val="111827"/>
                 </a:solidFill>
@@ -7266,7 +7266,7 @@
               <a:t>Background: </a:t>
             </a:r>
             <a:r>
-              <a:rPr sz="434" b="0" i="0">
+              <a:rPr sz="430" b="0" i="0">
                 <a:solidFill>
                   <a:srgbClr val="111827"/>
                 </a:solidFill>
@@ -7278,11 +7278,11 @@
           <a:p>
             <a:pPr algn="just">
               <a:spcAft>
-                <a:spcPts val="140"/>
+                <a:spcPts val="120"/>
               </a:spcAft>
             </a:pPr>
             <a:r>
-              <a:rPr sz="434" b="1" i="0">
+              <a:rPr sz="430" b="1" i="0">
                 <a:solidFill>
                   <a:srgbClr val="111827"/>
                 </a:solidFill>
@@ -7291,7 +7291,7 @@
               <a:t>Methods: </a:t>
             </a:r>
             <a:r>
-              <a:rPr sz="434" b="0" i="0">
+              <a:rPr sz="430" b="0" i="0">
                 <a:solidFill>
                   <a:srgbClr val="111827"/>
                 </a:solidFill>
@@ -7303,11 +7303,11 @@
           <a:p>
             <a:pPr algn="just">
               <a:spcAft>
-                <a:spcPts val="140"/>
+                <a:spcPts val="120"/>
               </a:spcAft>
             </a:pPr>
             <a:r>
-              <a:rPr sz="434" b="1" i="0">
+              <a:rPr sz="430" b="1" i="0">
                 <a:solidFill>
                   <a:srgbClr val="111827"/>
                 </a:solidFill>
@@ -7316,7 +7316,7 @@
               <a:t>Results: </a:t>
             </a:r>
             <a:r>
-              <a:rPr sz="434" b="0" i="0">
+              <a:rPr sz="430" b="0" i="0">
                 <a:solidFill>
                   <a:srgbClr val="111827"/>
                 </a:solidFill>
@@ -7328,11 +7328,11 @@
           <a:p>
             <a:pPr algn="just">
               <a:spcAft>
-                <a:spcPts val="140"/>
+                <a:spcPts val="120"/>
               </a:spcAft>
             </a:pPr>
             <a:r>
-              <a:rPr sz="434" b="1" i="0">
+              <a:rPr sz="430" b="1" i="0">
                 <a:solidFill>
                   <a:srgbClr val="111827"/>
                 </a:solidFill>
@@ -7341,7 +7341,7 @@
               <a:t>Conclusions: </a:t>
             </a:r>
             <a:r>
-              <a:rPr sz="434" b="0" i="0">
+              <a:rPr sz="430" b="0" i="0">
                 <a:solidFill>
                   <a:srgbClr val="111827"/>
                 </a:solidFill>
@@ -7353,11 +7353,11 @@
           <a:p>
             <a:pPr algn="just">
               <a:spcAft>
-                <a:spcPts val="140"/>
+                <a:spcPts val="120"/>
               </a:spcAft>
             </a:pPr>
             <a:r>
-              <a:rPr sz="434" b="1" i="0">
+              <a:rPr sz="430" b="1" i="0">
                 <a:solidFill>
                   <a:srgbClr val="111827"/>
                 </a:solidFill>
@@ -7366,7 +7366,7 @@
               <a:t>Keywords: </a:t>
             </a:r>
             <a:r>
-              <a:rPr sz="434" b="0" i="1">
+              <a:rPr sz="430" b="0" i="1">
                 <a:solidFill>
                   <a:srgbClr val="111827"/>
                 </a:solidFill>
@@ -7476,11 +7476,11 @@
           <a:p>
             <a:pPr algn="just">
               <a:spcAft>
-                <a:spcPts val="180"/>
+                <a:spcPts val="160"/>
               </a:spcAft>
             </a:pPr>
             <a:r>
-              <a:rPr sz="459" b="1" i="0">
+              <a:rPr sz="445" b="1" i="0">
                 <a:solidFill>
                   <a:srgbClr val="111827"/>
                 </a:solidFill>
@@ -7489,23 +7489,23 @@
               <a:t>Introduction: </a:t>
             </a:r>
             <a:r>
-              <a:rPr sz="459" b="0" i="0">
+              <a:rPr sz="445" b="0" i="0">
                 <a:solidFill>
                   <a:srgbClr val="111827"/>
                 </a:solidFill>
                 <a:latin typeface="Times New Roman"/>
               </a:rPr>
-              <a:t>PMDD is a recurring, hormone-linked mood disorder in which irritability, mood swings, depressed mood and anxiety emerge in the late luteal phase and remit after menses begin; DSM-5 classifies it as a depressive disorder.² Using prospectively confirmed diagnoses, community prevalence is about 1.6%, roughly 31 million women and girls worldwide.¹ PMDD has been linked with suicidal thoughts, strained relationships and reduced quality of life, but this evidence is scattered across disciplines, and it is unclear how women cope or where the research has been conducted.</a:t>
+              <a:t>PMDD is a recurring, hormone-linked mood disorder in which irritability, mood swings, depressed mood and anxiety emerge in the late luteal phase and remit after menses begin. It is classified as a depressive disorder in DSM-5² and recognized in ICD-11.³ Using prospectively confirmed diagnoses, community prevalence is about 1.6%, roughly 31 million women and girls worldwide.¹ PMDD has been linked with suicidal ideation and attempts,⁴˒⁵ strained romantic relationships⁶ and reduced quality of life.⁷ Premenstrual symptoms are also common across Africa, where pooled premenstrual syndrome prevalence reaches 47%,⁸ yet it remains unclear how women with PMDD cope or where the evidence has been generated.</a:t>
             </a:r>
           </a:p>
           <a:p>
             <a:pPr algn="just">
               <a:spcAft>
-                <a:spcPts val="180"/>
+                <a:spcPts val="160"/>
               </a:spcAft>
             </a:pPr>
             <a:r>
-              <a:rPr sz="459" b="1" i="0">
+              <a:rPr sz="445" b="1" i="0">
                 <a:solidFill>
                   <a:srgbClr val="111827"/>
                 </a:solidFill>
@@ -7514,7 +7514,7 @@
               <a:t>Objective: </a:t>
             </a:r>
             <a:r>
-              <a:rPr sz="459" b="0" i="0">
+              <a:rPr sz="445" b="0" i="0">
                 <a:solidFill>
                   <a:srgbClr val="111827"/>
                 </a:solidFill>
@@ -7526,11 +7526,11 @@
           <a:p>
             <a:pPr algn="just">
               <a:spcAft>
-                <a:spcPts val="180"/>
+                <a:spcPts val="160"/>
               </a:spcAft>
             </a:pPr>
             <a:r>
-              <a:rPr sz="459" b="1" i="0">
+              <a:rPr sz="445" b="1" i="0">
                 <a:solidFill>
                   <a:srgbClr val="111827"/>
                 </a:solidFill>
@@ -7539,7 +7539,7 @@
               <a:t>Research Question: </a:t>
             </a:r>
             <a:r>
-              <a:rPr sz="459" b="0" i="0">
+              <a:rPr sz="445" b="0" i="0">
                 <a:solidFill>
                   <a:srgbClr val="111827"/>
                 </a:solidFill>
@@ -7710,7 +7710,7 @@
                           </a:solidFill>
                           <a:latin typeface="Times New Roman"/>
                         </a:rPr>
-                        <a:t>Scoping review guided by Arksey and O’Malley’s framework³ and reported using PRISMA-ScR.⁴</a:t>
+                        <a:t>Scoping review guided by Arksey and O’Malley’s framework⁹ with Levac et al.’s refinements,¹⁰ reported using PRISMA-ScR.¹¹</a:t>
                       </a:r>
                     </a:p>
                   </a:txBody>
@@ -7986,7 +7986,7 @@
                           </a:solidFill>
                           <a:latin typeface="Times New Roman"/>
                         </a:rPr>
-                        <a:t>Included studies categorized by psychosocial outcome, coping mechanism and geographic setting (country and income level).</a:t>
+                        <a:t>Included studies categorized by psychosocial outcome, coping mechanism, publication year and geographic setting (country and World Bank income group¹²).</a:t>
                       </a:r>
                     </a:p>
                   </a:txBody>
@@ -10018,8 +10018,8 @@
         </p:nvSpPr>
         <p:spPr>
           <a:xfrm>
-            <a:off x="2414016" y="6217920"/>
-            <a:ext cx="4572000" cy="365760"/>
+            <a:off x="2414016" y="6236208"/>
+            <a:ext cx="4572000" cy="201168"/>
           </a:xfrm>
           <a:prstGeom prst="rect">
             <a:avLst/>
@@ -10174,7 +10174,7 @@
                 </a:solidFill>
                 <a:latin typeface="Times New Roman"/>
               </a:rPr>
-              <a:t>The database search identified 1,943 records. After 325 duplicates were removed, 1,618 records were screened by title and abstract; 64 were assessed for eligibility, 20 were excluded, and 44 studies were included (Fig. 1).</a:t>
+              <a:t>The database search identified 1,943 records. After 325 duplicates were removed, 1,618 records were screened by title and abstract; 64 were assessed for eligibility, 20 were excluded, and 44 studies were included (Fig. 1). Most (61%) were published in 2022–2025 (Fig. 4).</a:t>
             </a:r>
           </a:p>
           <a:p>
@@ -10190,7 +10190,7 @@
                 </a:solidFill>
                 <a:latin typeface="Times New Roman"/>
               </a:rPr>
-              <a:t>Depression was the most documented outcome (n=39), followed by psychological distress (n=24), interpersonal functioning (n=18), suicidal ideation or self-harm (n=14) and quality of life (n=14). Only three studies examined coping mechanisms (Fig. 2).</a:t>
+              <a:t>Depression was the most documented outcome (n=39); one nationwide cohort found a 2.6-fold higher risk of later depression after a PMDD diagnosis.¹³ Psychological distress (n=24), interpersonal functioning (n=18), suicidal ideation or self-harm (n=14) and quality of life (n=14) followed. Only three studies examined coping mechanisms, such as peer support shared in online PMDD communities¹⁴ (Fig. 2).</a:t>
             </a:r>
           </a:p>
           <a:p>
@@ -10206,7 +10206,7 @@
                 </a:solidFill>
                 <a:latin typeface="Times New Roman"/>
               </a:rPr>
-              <a:t>Geographic representation was skewed: 20 studies came from high-income countries and 7 from upper-middle-income countries (Türkiye, Iran); only three (6.8%) came from low- and lower-middle-income countries (Bangladesh, Lebanon, Nigeria), and Nigeria was the only study from sub-Saharan Africa (Fig. 3).</a:t>
+              <a:t>Twenty studies came from high-income countries and seven from upper-middle-income countries (Türkiye, Iran); only three (6.8%) came from low- and lower-middle-income countries—Bangladesh,¹⁵ Lebanon¹⁶ and Nigeria,¹⁷ the only study from sub-Saharan Africa (Fig. 3).</a:t>
             </a:r>
           </a:p>
           <a:p>
@@ -10238,7 +10238,7 @@
                 </a:solidFill>
                 <a:latin typeface="Times New Roman"/>
               </a:rPr>
-              <a:t>PMDD research consistently documents depression, distress, relationship difficulties and suicidality; large studies have linked PMDD with suicidal ideation and attempts.⁵,⁶ Yet coping mechanisms remain largely unexamined, and the scarcity of studies from low- and lower-middle-income countries and Africa leaves the burden in these settings invisible to health systems.</a:t>
+              <a:t>PMDD research consistently documents depression, distress, relationship difficulties and suicidality.⁴⁻⁷ Patients describe misdiagnosis and uneven provider knowledge,¹⁸˒¹⁹ yet coping remains largely unexamined, and the scarcity of studies from low-income settings and Africa leaves the burden there invisible to health systems.</a:t>
             </a:r>
           </a:p>
           <a:p>
@@ -10270,7 +10270,7 @@
                 </a:solidFill>
                 <a:latin typeface="Times New Roman"/>
               </a:rPr>
-              <a:t>Evidence on PMDD’s psychosocial burden is growing but geographically concentrated in high-income countries. Findings call for culturally responsive screening, integrated mental and reproductive health services, and Africa-centred research investment.</a:t>
+              <a:t>Evidence on PMDD’s psychosocial burden is growing but geographically concentrated in high-income countries, calling for culturally responsive screening, integrated mental and reproductive health services, and Africa-centred research investment.</a:t>
             </a:r>
           </a:p>
           <a:p>
@@ -10498,11 +10498,11 @@
           <a:p>
             <a:pPr algn="l">
               <a:spcAft>
-                <a:spcPts val="90"/>
+                <a:spcPts val="70"/>
               </a:spcAft>
             </a:pPr>
             <a:r>
-              <a:rPr sz="420" b="1" i="0">
+              <a:rPr sz="405" b="1" i="0">
                 <a:solidFill>
                   <a:srgbClr val="111827"/>
                 </a:solidFill>
@@ -10514,13 +10514,13 @@
           <a:p>
             <a:pPr algn="l" marL="73152" indent="-64008">
               <a:spcAft>
-                <a:spcPts val="90"/>
+                <a:spcPts val="70"/>
               </a:spcAft>
               <a:buFont typeface="Arial"/>
               <a:buChar char="•"/>
             </a:pPr>
             <a:r>
-              <a:rPr sz="420" b="1" i="0">
+              <a:rPr sz="405" b="1" i="0">
                 <a:solidFill>
                   <a:srgbClr val="111827"/>
                 </a:solidFill>
@@ -10529,25 +10529,25 @@
               <a:t>Screen for suicide risk: </a:t>
             </a:r>
             <a:r>
-              <a:rPr sz="420" b="0" i="0">
+              <a:rPr sz="405" b="0" i="0">
                 <a:solidFill>
                   <a:srgbClr val="111827"/>
                 </a:solidFill>
                 <a:latin typeface="Times New Roman"/>
               </a:rPr>
-              <a:t>ask about suicidal thoughts when women present with severe premenstrual mood symptoms.</a:t>
+              <a:t>ask about suicidal thoughts when women present with severe premenstrual mood symptoms.⁴˒⁵</a:t>
             </a:r>
           </a:p>
           <a:p>
             <a:pPr algn="l" marL="73152" indent="-64008">
               <a:spcAft>
-                <a:spcPts val="90"/>
+                <a:spcPts val="70"/>
               </a:spcAft>
               <a:buFont typeface="Arial"/>
               <a:buChar char="•"/>
             </a:pPr>
             <a:r>
-              <a:rPr sz="420" b="1" i="0">
+              <a:rPr sz="405" b="1" i="0">
                 <a:solidFill>
                   <a:srgbClr val="111827"/>
                 </a:solidFill>
@@ -10556,137 +10556,164 @@
               <a:t>Integrate care: </a:t>
             </a:r>
             <a:r>
-              <a:rPr sz="420" b="0" i="0">
+              <a:rPr sz="405" b="0" i="0">
                 <a:solidFill>
                   <a:srgbClr val="111827"/>
                 </a:solidFill>
                 <a:latin typeface="Times New Roman"/>
               </a:rPr>
-              <a:t>include PMDD screening in sexual and reproductive, school and university health services.</a:t>
+              <a:t>embed PMDD screening in sexual and reproductive, school and university health services.</a:t>
             </a:r>
           </a:p>
           <a:p>
             <a:pPr algn="l" marL="73152" indent="-64008">
               <a:spcAft>
-                <a:spcPts val="90"/>
+                <a:spcPts val="70"/>
               </a:spcAft>
               <a:buFont typeface="Arial"/>
               <a:buChar char="•"/>
             </a:pPr>
             <a:r>
-              <a:rPr sz="420" b="1" i="0">
+              <a:rPr sz="405" b="1" i="0">
                 <a:solidFill>
                   <a:srgbClr val="111827"/>
                 </a:solidFill>
                 <a:latin typeface="Times New Roman"/>
               </a:rPr>
-              <a:t>Address coping needs: </a:t>
-            </a:r>
-            <a:r>
-              <a:rPr sz="420" b="0" i="0">
+              <a:t>Train providers: </a:t>
+            </a:r>
+            <a:r>
+              <a:rPr sz="405" b="0" i="0">
                 <a:solidFill>
                   <a:srgbClr val="111827"/>
                 </a:solidFill>
                 <a:latin typeface="Times New Roman"/>
               </a:rPr>
-              <a:t>ask how women manage symptoms and what support they need.</a:t>
-            </a:r>
-          </a:p>
-          <a:p>
-            <a:pPr algn="l">
-              <a:spcAft>
-                <a:spcPts val="90"/>
-              </a:spcAft>
-            </a:pPr>
-            <a:r>
-              <a:rPr sz="420" b="1" i="0">
-                <a:solidFill>
-                  <a:srgbClr val="111827"/>
-                </a:solidFill>
-                <a:latin typeface="Times New Roman"/>
-              </a:rPr>
-              <a:t>Future Work</a:t>
+              <a:t>improve recognition to reduce misdiagnosis and delayed care.¹⁸</a:t>
             </a:r>
           </a:p>
           <a:p>
             <a:pPr algn="l" marL="73152" indent="-64008">
               <a:spcAft>
-                <a:spcPts val="90"/>
+                <a:spcPts val="70"/>
               </a:spcAft>
               <a:buFont typeface="Arial"/>
               <a:buChar char="•"/>
             </a:pPr>
             <a:r>
-              <a:rPr sz="420" b="1" i="0">
+              <a:rPr sz="405" b="1" i="0">
                 <a:solidFill>
                   <a:srgbClr val="111827"/>
                 </a:solidFill>
                 <a:latin typeface="Times New Roman"/>
               </a:rPr>
-              <a:t>Confirm PMDD prospectively </a:t>
-            </a:r>
-            <a:r>
-              <a:rPr sz="420" b="0" i="0">
+              <a:t>Address coping needs: </a:t>
+            </a:r>
+            <a:r>
+              <a:rPr sz="405" b="0" i="0">
                 <a:solidFill>
                   <a:srgbClr val="111827"/>
                 </a:solidFill>
                 <a:latin typeface="Times New Roman"/>
               </a:rPr>
-              <a:t>in studies from low- and middle-income countries.</a:t>
+              <a:t>ask how women manage symptoms and connect them with peer and professional support.¹⁴</a:t>
+            </a:r>
+          </a:p>
+          <a:p>
+            <a:pPr algn="l">
+              <a:spcAft>
+                <a:spcPts val="70"/>
+              </a:spcAft>
+            </a:pPr>
+            <a:r>
+              <a:rPr sz="405" b="1" i="0">
+                <a:solidFill>
+                  <a:srgbClr val="111827"/>
+                </a:solidFill>
+                <a:latin typeface="Times New Roman"/>
+              </a:rPr>
+              <a:t>Future Work</a:t>
             </a:r>
           </a:p>
           <a:p>
             <a:pPr algn="l" marL="73152" indent="-64008">
               <a:spcAft>
-                <a:spcPts val="90"/>
+                <a:spcPts val="70"/>
               </a:spcAft>
               <a:buFont typeface="Arial"/>
               <a:buChar char="•"/>
             </a:pPr>
             <a:r>
-              <a:rPr sz="420" b="1" i="0">
+              <a:rPr sz="405" b="1" i="0">
                 <a:solidFill>
                   <a:srgbClr val="111827"/>
                 </a:solidFill>
                 <a:latin typeface="Times New Roman"/>
               </a:rPr>
-              <a:t>Study lived experience: </a:t>
-            </a:r>
-            <a:r>
-              <a:rPr sz="420" b="0" i="0">
+              <a:t>Confirm PMDD prospectively </a:t>
+            </a:r>
+            <a:r>
+              <a:rPr sz="405" b="0" i="0">
                 <a:solidFill>
                   <a:srgbClr val="111827"/>
                 </a:solidFill>
                 <a:latin typeface="Times New Roman"/>
               </a:rPr>
-              <a:t>stigma, coping and help-seeking in African settings.</a:t>
+              <a:t>using validated daily ratings.¹˒²⁰</a:t>
             </a:r>
           </a:p>
           <a:p>
             <a:pPr algn="l" marL="73152" indent="-64008">
               <a:spcAft>
-                <a:spcPts val="90"/>
+                <a:spcPts val="70"/>
               </a:spcAft>
               <a:buFont typeface="Arial"/>
               <a:buChar char="•"/>
             </a:pPr>
             <a:r>
-              <a:rPr sz="420" b="1" i="0">
+              <a:rPr sz="405" b="1" i="0">
                 <a:solidFill>
                   <a:srgbClr val="111827"/>
                 </a:solidFill>
                 <a:latin typeface="Times New Roman"/>
               </a:rPr>
+              <a:t>Prioritize low-income and African settings, </a:t>
+            </a:r>
+            <a:r>
+              <a:rPr sz="405" b="0" i="0">
+                <a:solidFill>
+                  <a:srgbClr val="111827"/>
+                </a:solidFill>
+                <a:latin typeface="Times New Roman"/>
+              </a:rPr>
+              <a:t>including qualitative studies of stigma and coping.</a:t>
+            </a:r>
+          </a:p>
+          <a:p>
+            <a:pPr algn="l" marL="73152" indent="-64008">
+              <a:spcAft>
+                <a:spcPts val="70"/>
+              </a:spcAft>
+              <a:buFont typeface="Arial"/>
+              <a:buChar char="•"/>
+            </a:pPr>
+            <a:r>
+              <a:rPr sz="405" b="1" i="0">
+                <a:solidFill>
+                  <a:srgbClr val="111827"/>
+                </a:solidFill>
+                <a:latin typeface="Times New Roman"/>
+              </a:rPr>
               <a:t>Validate screening tools </a:t>
             </a:r>
             <a:r>
-              <a:rPr sz="420" b="0" i="0">
+              <a:rPr sz="405" b="0" i="0">
                 <a:solidFill>
                   <a:srgbClr val="111827"/>
                 </a:solidFill>
                 <a:latin typeface="Times New Roman"/>
               </a:rPr>
-              <a:t>in African languages.</a:t>
+              <a:t>in African languages and test coping-focused interventions.</a:t>
             </a:r>
           </a:p>
         </p:txBody>
@@ -10756,8 +10783,8 @@
         </p:nvSpPr>
         <p:spPr>
           <a:xfrm>
-            <a:off x="8067751" y="5788152"/>
-            <a:ext cx="975664" cy="914400"/>
+            <a:off x="7958023" y="5769864"/>
+            <a:ext cx="1085392" cy="960120"/>
           </a:xfrm>
           <a:prstGeom prst="rect">
             <a:avLst/>
@@ -10790,27 +10817,27 @@
           <a:p>
             <a:pPr algn="l">
               <a:spcAft>
-                <a:spcPts val="60"/>
+                <a:spcPts val="15"/>
               </a:spcAft>
             </a:pPr>
             <a:r>
-              <a:rPr sz="300" b="0" i="0">
+              <a:rPr sz="254" b="0" i="0">
                 <a:solidFill>
                   <a:srgbClr val="111827"/>
                 </a:solidFill>
                 <a:latin typeface="Times New Roman"/>
               </a:rPr>
-              <a:t>1. Reilly TJ et al. J Affect Disord. 2024;349:534-540.</a:t>
+              <a:t>1. Reilly TJ, et al. J Affect Disord. 2024;349:534-540.</a:t>
             </a:r>
           </a:p>
           <a:p>
             <a:pPr algn="l">
               <a:spcAft>
-                <a:spcPts val="60"/>
+                <a:spcPts val="15"/>
               </a:spcAft>
             </a:pPr>
             <a:r>
-              <a:rPr sz="300" b="0" i="0">
+              <a:rPr sz="254" b="0" i="0">
                 <a:solidFill>
                   <a:srgbClr val="111827"/>
                 </a:solidFill>
@@ -10822,80 +10849,304 @@
           <a:p>
             <a:pPr algn="l">
               <a:spcAft>
-                <a:spcPts val="60"/>
+                <a:spcPts val="15"/>
               </a:spcAft>
             </a:pPr>
             <a:r>
-              <a:rPr sz="300" b="0" i="0">
+              <a:rPr sz="254" b="0" i="0">
                 <a:solidFill>
                   <a:srgbClr val="111827"/>
                 </a:solidFill>
                 <a:latin typeface="Times New Roman"/>
               </a:rPr>
-              <a:t>3. Arksey H, O’Malley L. Int J Soc Res Methodol. 2005;8:19-32.</a:t>
+              <a:t>3. World Health Organization. ICD-11. 2022.</a:t>
             </a:r>
           </a:p>
           <a:p>
             <a:pPr algn="l">
               <a:spcAft>
-                <a:spcPts val="60"/>
+                <a:spcPts val="15"/>
               </a:spcAft>
             </a:pPr>
             <a:r>
-              <a:rPr sz="300" b="0" i="0">
+              <a:rPr sz="254" b="0" i="0">
                 <a:solidFill>
                   <a:srgbClr val="111827"/>
                 </a:solidFill>
                 <a:latin typeface="Times New Roman"/>
               </a:rPr>
-              <a:t>4. Tricco AC et al. Ann Intern Med. 2018;169:467-473.</a:t>
+              <a:t>4. Pilver CE, et al. Soc Psychiatry Psychiatr Epidemiol. 2013;48:437-446.</a:t>
             </a:r>
           </a:p>
           <a:p>
             <a:pPr algn="l">
               <a:spcAft>
-                <a:spcPts val="60"/>
+                <a:spcPts val="15"/>
               </a:spcAft>
             </a:pPr>
             <a:r>
-              <a:rPr sz="300" b="0" i="0">
+              <a:rPr sz="254" b="0" i="0">
                 <a:solidFill>
                   <a:srgbClr val="111827"/>
                 </a:solidFill>
                 <a:latin typeface="Times New Roman"/>
               </a:rPr>
-              <a:t>5. Pilver CE et al. Soc Psychiatry Psychiatr Epidemiol. 2013;48:437-446.</a:t>
+              <a:t>5. Eisenlohr-Moul T, et al. BMC Psychiatry. 2022;22:199.</a:t>
             </a:r>
           </a:p>
           <a:p>
             <a:pPr algn="l">
               <a:spcAft>
-                <a:spcPts val="60"/>
+                <a:spcPts val="15"/>
               </a:spcAft>
             </a:pPr>
             <a:r>
-              <a:rPr sz="300" b="0" i="0">
+              <a:rPr sz="254" b="0" i="0">
                 <a:solidFill>
                   <a:srgbClr val="111827"/>
                 </a:solidFill>
                 <a:latin typeface="Times New Roman"/>
               </a:rPr>
-              <a:t>6. Eisenlohr-Moul T et al. BMC Psychiatry. 2022;22. doi:10.1186/s12888-022-03851-0</a:t>
+              <a:t>6. Westermark V, et al. J Affect Disord. 2024;364:132-138.</a:t>
             </a:r>
           </a:p>
           <a:p>
             <a:pPr algn="l">
               <a:spcAft>
-                <a:spcPts val="60"/>
+                <a:spcPts val="15"/>
               </a:spcAft>
             </a:pPr>
             <a:r>
-              <a:rPr sz="300" b="0" i="1">
+              <a:rPr sz="254" b="0" i="0">
                 <a:solidFill>
                   <a:srgbClr val="111827"/>
                 </a:solidFill>
                 <a:latin typeface="Times New Roman"/>
               </a:rPr>
+              <a:t>7. Wang Q, et al. JAMA Netw Open. 2025;8:e2533823.</a:t>
+            </a:r>
+          </a:p>
+          <a:p>
+            <a:pPr algn="l">
+              <a:spcAft>
+                <a:spcPts val="15"/>
+              </a:spcAft>
+            </a:pPr>
+            <a:r>
+              <a:rPr sz="254" b="0" i="0">
+                <a:solidFill>
+                  <a:srgbClr val="111827"/>
+                </a:solidFill>
+                <a:latin typeface="Times New Roman"/>
+              </a:rPr>
+              <a:t>8. Andualem F, et al. Front Psychiatry. 2024;15:1338304.</a:t>
+            </a:r>
+          </a:p>
+          <a:p>
+            <a:pPr algn="l">
+              <a:spcAft>
+                <a:spcPts val="15"/>
+              </a:spcAft>
+            </a:pPr>
+            <a:r>
+              <a:rPr sz="254" b="0" i="0">
+                <a:solidFill>
+                  <a:srgbClr val="111827"/>
+                </a:solidFill>
+                <a:latin typeface="Times New Roman"/>
+              </a:rPr>
+              <a:t>9. Arksey H, O’Malley L. Int J Soc Res Methodol. 2005;8:19-32.</a:t>
+            </a:r>
+          </a:p>
+          <a:p>
+            <a:pPr algn="l">
+              <a:spcAft>
+                <a:spcPts val="15"/>
+              </a:spcAft>
+            </a:pPr>
+            <a:r>
+              <a:rPr sz="254" b="0" i="0">
+                <a:solidFill>
+                  <a:srgbClr val="111827"/>
+                </a:solidFill>
+                <a:latin typeface="Times New Roman"/>
+              </a:rPr>
+              <a:t>10. Levac D, et al. Implement Sci. 2010;5:69.</a:t>
+            </a:r>
+          </a:p>
+          <a:p>
+            <a:pPr algn="l">
+              <a:spcAft>
+                <a:spcPts val="15"/>
+              </a:spcAft>
+            </a:pPr>
+            <a:r>
+              <a:rPr sz="254" b="0" i="0">
+                <a:solidFill>
+                  <a:srgbClr val="111827"/>
+                </a:solidFill>
+                <a:latin typeface="Times New Roman"/>
+              </a:rPr>
+              <a:t>11. Tricco AC, et al. Ann Intern Med. 2018;169:467-473.</a:t>
+            </a:r>
+          </a:p>
+          <a:p>
+            <a:pPr algn="l">
+              <a:spcAft>
+                <a:spcPts val="15"/>
+              </a:spcAft>
+            </a:pPr>
+            <a:r>
+              <a:rPr sz="254" b="0" i="0">
+                <a:solidFill>
+                  <a:srgbClr val="111827"/>
+                </a:solidFill>
+                <a:latin typeface="Times New Roman"/>
+              </a:rPr>
+              <a:t>12. World Bank. Country income classifications, FY2027. 2026.</a:t>
+            </a:r>
+          </a:p>
+          <a:p>
+            <a:pPr algn="l">
+              <a:spcAft>
+                <a:spcPts val="15"/>
+              </a:spcAft>
+            </a:pPr>
+            <a:r>
+              <a:rPr sz="254" b="0" i="0">
+                <a:solidFill>
+                  <a:srgbClr val="111827"/>
+                </a:solidFill>
+                <a:latin typeface="Times New Roman"/>
+              </a:rPr>
+              <a:t>13. Li DJ, et al. Asian J Psychiatr. 2023;79:103355.</a:t>
+            </a:r>
+          </a:p>
+          <a:p>
+            <a:pPr algn="l">
+              <a:spcAft>
+                <a:spcPts val="15"/>
+              </a:spcAft>
+            </a:pPr>
+            <a:r>
+              <a:rPr sz="254" b="0" i="0">
+                <a:solidFill>
+                  <a:srgbClr val="111827"/>
+                </a:solidFill>
+                <a:latin typeface="Times New Roman"/>
+              </a:rPr>
+              <a:t>14. Winslow A, et al. Womens Reprod Health. 2023;10:420-435.</a:t>
+            </a:r>
+          </a:p>
+          <a:p>
+            <a:pPr algn="l">
+              <a:spcAft>
+                <a:spcPts val="15"/>
+              </a:spcAft>
+            </a:pPr>
+            <a:r>
+              <a:rPr sz="254" b="0" i="0">
+                <a:solidFill>
+                  <a:srgbClr val="111827"/>
+                </a:solidFill>
+                <a:latin typeface="Times New Roman"/>
+              </a:rPr>
+              <a:t>15. Roy N, et al. PLoS One. 2025;20:e0321097.</a:t>
+            </a:r>
+          </a:p>
+          <a:p>
+            <a:pPr algn="l">
+              <a:spcAft>
+                <a:spcPts val="15"/>
+              </a:spcAft>
+            </a:pPr>
+            <a:r>
+              <a:rPr sz="254" b="0" i="0">
+                <a:solidFill>
+                  <a:srgbClr val="111827"/>
+                </a:solidFill>
+                <a:latin typeface="Times New Roman"/>
+              </a:rPr>
+              <a:t>16. Younes Y, et al. BMC Psychiatry. 2021;21:548.</a:t>
+            </a:r>
+          </a:p>
+          <a:p>
+            <a:pPr algn="l">
+              <a:spcAft>
+                <a:spcPts val="15"/>
+              </a:spcAft>
+            </a:pPr>
+            <a:r>
+              <a:rPr sz="254" b="0" i="0">
+                <a:solidFill>
+                  <a:srgbClr val="111827"/>
+                </a:solidFill>
+                <a:latin typeface="Times New Roman"/>
+              </a:rPr>
+              <a:t>17. Adegoke AA, et al. Gend Behav. 2014;12:6087-6094.</a:t>
+            </a:r>
+          </a:p>
+          <a:p>
+            <a:pPr algn="l">
+              <a:spcAft>
+                <a:spcPts val="15"/>
+              </a:spcAft>
+            </a:pPr>
+            <a:r>
+              <a:rPr sz="254" b="0" i="0">
+                <a:solidFill>
+                  <a:srgbClr val="111827"/>
+                </a:solidFill>
+                <a:latin typeface="Times New Roman"/>
+              </a:rPr>
+              <a:t>18. Hantsoo L, et al. J Womens Health. 2022;31:100-109.</a:t>
+            </a:r>
+          </a:p>
+          <a:p>
+            <a:pPr algn="l">
+              <a:spcAft>
+                <a:spcPts val="15"/>
+              </a:spcAft>
+            </a:pPr>
+            <a:r>
+              <a:rPr sz="254" b="0" i="0">
+                <a:solidFill>
+                  <a:srgbClr val="111827"/>
+                </a:solidFill>
+                <a:latin typeface="Times New Roman"/>
+              </a:rPr>
+              <a:t>19. Habib S, et al. Womens Reprod Health. 2025;12:310-329.</a:t>
+            </a:r>
+          </a:p>
+          <a:p>
+            <a:pPr algn="l">
+              <a:spcAft>
+                <a:spcPts val="15"/>
+              </a:spcAft>
+            </a:pPr>
+            <a:r>
+              <a:rPr sz="254" b="0" i="0">
+                <a:solidFill>
+                  <a:srgbClr val="111827"/>
+                </a:solidFill>
+                <a:latin typeface="Times New Roman"/>
+              </a:rPr>
+              <a:t>20. Naik SS, et al. Front Glob Womens Health. 2023;4:1181583.</a:t>
+            </a:r>
+          </a:p>
+          <a:p>
+            <a:pPr algn="l">
+              <a:spcAft>
+                <a:spcPts val="15"/>
+              </a:spcAft>
+            </a:pPr>
+            <a:r>
+              <a:rPr sz="254" b="1" i="1">
+                <a:solidFill>
+                  <a:srgbClr val="111827"/>
+                </a:solidFill>
+                <a:latin typeface="Times New Roman"/>
+              </a:rPr>
               <a:t>Scan the QR code for the full reference list.</a:t>
             </a:r>
           </a:p>
@@ -10903,13 +11154,81 @@
       </p:sp>
       <p:sp>
         <p:nvSpPr>
-          <p:cNvPr id="353" name="TextBox 352"/>
+          <p:cNvPr id="353" name="Rounded Rectangle 352"/>
+          <p:cNvSpPr/>
+          <p:nvPr/>
+        </p:nvSpPr>
+        <p:spPr>
+          <a:xfrm>
+            <a:off x="2428646" y="6455664"/>
+            <a:ext cx="4516221" cy="237744"/>
+          </a:xfrm>
+          <a:prstGeom prst="roundRect">
+            <a:avLst>
+              <a:gd name="adj" fmla="val 8000"/>
+            </a:avLst>
+          </a:prstGeom>
+          <a:solidFill>
+            <a:srgbClr val="0A254E"/>
+          </a:solidFill>
+          <a:ln>
+            <a:noFill/>
+          </a:ln>
+          <a:effectLst/>
+        </p:spPr>
+        <p:style>
+          <a:lnRef idx="1">
+            <a:schemeClr val="accent1"/>
+          </a:lnRef>
+          <a:fillRef idx="3">
+            <a:schemeClr val="accent1"/>
+          </a:fillRef>
+          <a:effectRef idx="2">
+            <a:schemeClr val="accent1"/>
+          </a:effectRef>
+          <a:fontRef idx="minor">
+            <a:schemeClr val="lt1"/>
+          </a:fontRef>
+        </p:style>
+        <p:txBody>
+          <a:bodyPr rtlCol="0" anchor="ctr" wrap="square" lIns="73152" rIns="73152" tIns="13716" bIns="13716"/>
+          <a:lstStyle/>
+          <a:p>
+            <a:pPr algn="ctr">
+              <a:spcAft>
+                <a:spcPts val="120"/>
+              </a:spcAft>
+            </a:pPr>
+            <a:r>
+              <a:rPr sz="560" b="1" i="0">
+                <a:solidFill>
+                  <a:srgbClr val="F2C14E"/>
+                </a:solidFill>
+                <a:latin typeface="Times New Roman"/>
+              </a:rPr>
+              <a:t>KEY TAKEAWAY  </a:t>
+            </a:r>
+            <a:r>
+              <a:rPr sz="560" b="0" i="0">
+                <a:solidFill>
+                  <a:srgbClr val="FFFFFF"/>
+                </a:solidFill>
+                <a:latin typeface="Times New Roman"/>
+              </a:rPr>
+              <a:t>PMDD’s psychosocial burden is well documented in high-income countries, yet nearly invisible in low-income settings and sub-Saharan Africa.</a:t>
+            </a:r>
+          </a:p>
+        </p:txBody>
+      </p:sp>
+      <p:sp>
+        <p:nvSpPr>
+          <p:cNvPr id="354" name="TextBox 353"/>
           <p:cNvSpPr txBox="1"/>
           <p:nvPr/>
         </p:nvSpPr>
         <p:spPr>
           <a:xfrm>
-            <a:off x="7162495" y="3291840"/>
+            <a:off x="7162495" y="3310128"/>
             <a:ext cx="1826056" cy="118872"/>
           </a:xfrm>
           <a:prstGeom prst="rect">
@@ -10942,15 +11261,15 @@
       </p:sp>
       <p:graphicFrame>
         <p:nvGraphicFramePr>
-          <p:cNvPr id="354" name="Chart 353"/>
+          <p:cNvPr id="355" name="Chart 354"/>
           <p:cNvGraphicFramePr>
             <a:graphicFrameLocks noGrp="1"/>
           </p:cNvGraphicFramePr>
           <p:nvPr/>
         </p:nvGraphicFramePr>
         <p:xfrm>
-          <a:off x="7199071" y="3401568"/>
-          <a:ext cx="1752904" cy="548640"/>
+          <a:off x="7199071" y="3419856"/>
+          <a:ext cx="1752904" cy="530352"/>
         </p:xfrm>
         <a:graphic>
           <a:graphicData uri="http://schemas.openxmlformats.org/drawingml/2006/chart">
@@ -10960,7 +11279,7 @@
       </p:graphicFrame>
       <p:sp>
         <p:nvSpPr>
-          <p:cNvPr id="355" name="TextBox 354"/>
+          <p:cNvPr id="356" name="TextBox 355"/>
           <p:cNvSpPr txBox="1"/>
           <p:nvPr/>
         </p:nvSpPr>

</xml_diff>

<commit_message>
Restore QR code to its original template position and size
Co-Authored-By: Claude Opus 5.5 <noreply@anthropic.com>
Claude-Session: https://claude.ai/code/session_01VkRRDHxfMApHVBQgQibkFd
</commit_message>
<xml_diff>
--- a/PMDD_Scoping_Review/PMDD_APHA_Poster_FINAL.pptx
+++ b/PMDD_Scoping_Review/PMDD_APHA_Poster_FINAL.pptx
@@ -7091,8 +7091,8 @@
         </p:blipFill>
         <p:spPr>
           <a:xfrm>
-            <a:off x="7135063" y="5815584"/>
-            <a:ext cx="786384" cy="786384"/>
+            <a:off x="7563916" y="5785408"/>
+            <a:ext cx="1032357" cy="1032357"/>
           </a:xfrm>
           <a:prstGeom prst="rect">
             <a:avLst/>
@@ -10777,20 +10777,22 @@
       </p:sp>
       <p:sp>
         <p:nvSpPr>
-          <p:cNvPr id="352" name="Rectangle 351"/>
+          <p:cNvPr id="352" name="Rounded Rectangle 351"/>
           <p:cNvSpPr/>
           <p:nvPr/>
         </p:nvSpPr>
         <p:spPr>
           <a:xfrm>
-            <a:off x="7958023" y="5769864"/>
-            <a:ext cx="1085392" cy="960120"/>
-          </a:xfrm>
-          <a:prstGeom prst="rect">
-            <a:avLst/>
+            <a:off x="2428646" y="6455664"/>
+            <a:ext cx="4516221" cy="237744"/>
+          </a:xfrm>
+          <a:prstGeom prst="roundRect">
+            <a:avLst>
+              <a:gd name="adj" fmla="val 8000"/>
+            </a:avLst>
           </a:prstGeom>
           <a:solidFill>
-            <a:srgbClr val="FFFFFF"/>
+            <a:srgbClr val="0A254E"/>
           </a:solidFill>
           <a:ln>
             <a:noFill/>
@@ -10812,385 +10814,6 @@
           </a:fontRef>
         </p:style>
         <p:txBody>
-          <a:bodyPr rtlCol="0" anchor="t" wrap="square" lIns="45720" rIns="45720" tIns="36576" bIns="13716"/>
-          <a:lstStyle/>
-          <a:p>
-            <a:pPr algn="l">
-              <a:spcAft>
-                <a:spcPts val="15"/>
-              </a:spcAft>
-            </a:pPr>
-            <a:r>
-              <a:rPr sz="254" b="0" i="0">
-                <a:solidFill>
-                  <a:srgbClr val="111827"/>
-                </a:solidFill>
-                <a:latin typeface="Times New Roman"/>
-              </a:rPr>
-              <a:t>1. Reilly TJ, et al. J Affect Disord. 2024;349:534-540.</a:t>
-            </a:r>
-          </a:p>
-          <a:p>
-            <a:pPr algn="l">
-              <a:spcAft>
-                <a:spcPts val="15"/>
-              </a:spcAft>
-            </a:pPr>
-            <a:r>
-              <a:rPr sz="254" b="0" i="0">
-                <a:solidFill>
-                  <a:srgbClr val="111827"/>
-                </a:solidFill>
-                <a:latin typeface="Times New Roman"/>
-              </a:rPr>
-              <a:t>2. American Psychiatric Association. DSM-5. 2013.</a:t>
-            </a:r>
-          </a:p>
-          <a:p>
-            <a:pPr algn="l">
-              <a:spcAft>
-                <a:spcPts val="15"/>
-              </a:spcAft>
-            </a:pPr>
-            <a:r>
-              <a:rPr sz="254" b="0" i="0">
-                <a:solidFill>
-                  <a:srgbClr val="111827"/>
-                </a:solidFill>
-                <a:latin typeface="Times New Roman"/>
-              </a:rPr>
-              <a:t>3. World Health Organization. ICD-11. 2022.</a:t>
-            </a:r>
-          </a:p>
-          <a:p>
-            <a:pPr algn="l">
-              <a:spcAft>
-                <a:spcPts val="15"/>
-              </a:spcAft>
-            </a:pPr>
-            <a:r>
-              <a:rPr sz="254" b="0" i="0">
-                <a:solidFill>
-                  <a:srgbClr val="111827"/>
-                </a:solidFill>
-                <a:latin typeface="Times New Roman"/>
-              </a:rPr>
-              <a:t>4. Pilver CE, et al. Soc Psychiatry Psychiatr Epidemiol. 2013;48:437-446.</a:t>
-            </a:r>
-          </a:p>
-          <a:p>
-            <a:pPr algn="l">
-              <a:spcAft>
-                <a:spcPts val="15"/>
-              </a:spcAft>
-            </a:pPr>
-            <a:r>
-              <a:rPr sz="254" b="0" i="0">
-                <a:solidFill>
-                  <a:srgbClr val="111827"/>
-                </a:solidFill>
-                <a:latin typeface="Times New Roman"/>
-              </a:rPr>
-              <a:t>5. Eisenlohr-Moul T, et al. BMC Psychiatry. 2022;22:199.</a:t>
-            </a:r>
-          </a:p>
-          <a:p>
-            <a:pPr algn="l">
-              <a:spcAft>
-                <a:spcPts val="15"/>
-              </a:spcAft>
-            </a:pPr>
-            <a:r>
-              <a:rPr sz="254" b="0" i="0">
-                <a:solidFill>
-                  <a:srgbClr val="111827"/>
-                </a:solidFill>
-                <a:latin typeface="Times New Roman"/>
-              </a:rPr>
-              <a:t>6. Westermark V, et al. J Affect Disord. 2024;364:132-138.</a:t>
-            </a:r>
-          </a:p>
-          <a:p>
-            <a:pPr algn="l">
-              <a:spcAft>
-                <a:spcPts val="15"/>
-              </a:spcAft>
-            </a:pPr>
-            <a:r>
-              <a:rPr sz="254" b="0" i="0">
-                <a:solidFill>
-                  <a:srgbClr val="111827"/>
-                </a:solidFill>
-                <a:latin typeface="Times New Roman"/>
-              </a:rPr>
-              <a:t>7. Wang Q, et al. JAMA Netw Open. 2025;8:e2533823.</a:t>
-            </a:r>
-          </a:p>
-          <a:p>
-            <a:pPr algn="l">
-              <a:spcAft>
-                <a:spcPts val="15"/>
-              </a:spcAft>
-            </a:pPr>
-            <a:r>
-              <a:rPr sz="254" b="0" i="0">
-                <a:solidFill>
-                  <a:srgbClr val="111827"/>
-                </a:solidFill>
-                <a:latin typeface="Times New Roman"/>
-              </a:rPr>
-              <a:t>8. Andualem F, et al. Front Psychiatry. 2024;15:1338304.</a:t>
-            </a:r>
-          </a:p>
-          <a:p>
-            <a:pPr algn="l">
-              <a:spcAft>
-                <a:spcPts val="15"/>
-              </a:spcAft>
-            </a:pPr>
-            <a:r>
-              <a:rPr sz="254" b="0" i="0">
-                <a:solidFill>
-                  <a:srgbClr val="111827"/>
-                </a:solidFill>
-                <a:latin typeface="Times New Roman"/>
-              </a:rPr>
-              <a:t>9. Arksey H, O’Malley L. Int J Soc Res Methodol. 2005;8:19-32.</a:t>
-            </a:r>
-          </a:p>
-          <a:p>
-            <a:pPr algn="l">
-              <a:spcAft>
-                <a:spcPts val="15"/>
-              </a:spcAft>
-            </a:pPr>
-            <a:r>
-              <a:rPr sz="254" b="0" i="0">
-                <a:solidFill>
-                  <a:srgbClr val="111827"/>
-                </a:solidFill>
-                <a:latin typeface="Times New Roman"/>
-              </a:rPr>
-              <a:t>10. Levac D, et al. Implement Sci. 2010;5:69.</a:t>
-            </a:r>
-          </a:p>
-          <a:p>
-            <a:pPr algn="l">
-              <a:spcAft>
-                <a:spcPts val="15"/>
-              </a:spcAft>
-            </a:pPr>
-            <a:r>
-              <a:rPr sz="254" b="0" i="0">
-                <a:solidFill>
-                  <a:srgbClr val="111827"/>
-                </a:solidFill>
-                <a:latin typeface="Times New Roman"/>
-              </a:rPr>
-              <a:t>11. Tricco AC, et al. Ann Intern Med. 2018;169:467-473.</a:t>
-            </a:r>
-          </a:p>
-          <a:p>
-            <a:pPr algn="l">
-              <a:spcAft>
-                <a:spcPts val="15"/>
-              </a:spcAft>
-            </a:pPr>
-            <a:r>
-              <a:rPr sz="254" b="0" i="0">
-                <a:solidFill>
-                  <a:srgbClr val="111827"/>
-                </a:solidFill>
-                <a:latin typeface="Times New Roman"/>
-              </a:rPr>
-              <a:t>12. World Bank. Country income classifications, FY2027. 2026.</a:t>
-            </a:r>
-          </a:p>
-          <a:p>
-            <a:pPr algn="l">
-              <a:spcAft>
-                <a:spcPts val="15"/>
-              </a:spcAft>
-            </a:pPr>
-            <a:r>
-              <a:rPr sz="254" b="0" i="0">
-                <a:solidFill>
-                  <a:srgbClr val="111827"/>
-                </a:solidFill>
-                <a:latin typeface="Times New Roman"/>
-              </a:rPr>
-              <a:t>13. Li DJ, et al. Asian J Psychiatr. 2023;79:103355.</a:t>
-            </a:r>
-          </a:p>
-          <a:p>
-            <a:pPr algn="l">
-              <a:spcAft>
-                <a:spcPts val="15"/>
-              </a:spcAft>
-            </a:pPr>
-            <a:r>
-              <a:rPr sz="254" b="0" i="0">
-                <a:solidFill>
-                  <a:srgbClr val="111827"/>
-                </a:solidFill>
-                <a:latin typeface="Times New Roman"/>
-              </a:rPr>
-              <a:t>14. Winslow A, et al. Womens Reprod Health. 2023;10:420-435.</a:t>
-            </a:r>
-          </a:p>
-          <a:p>
-            <a:pPr algn="l">
-              <a:spcAft>
-                <a:spcPts val="15"/>
-              </a:spcAft>
-            </a:pPr>
-            <a:r>
-              <a:rPr sz="254" b="0" i="0">
-                <a:solidFill>
-                  <a:srgbClr val="111827"/>
-                </a:solidFill>
-                <a:latin typeface="Times New Roman"/>
-              </a:rPr>
-              <a:t>15. Roy N, et al. PLoS One. 2025;20:e0321097.</a:t>
-            </a:r>
-          </a:p>
-          <a:p>
-            <a:pPr algn="l">
-              <a:spcAft>
-                <a:spcPts val="15"/>
-              </a:spcAft>
-            </a:pPr>
-            <a:r>
-              <a:rPr sz="254" b="0" i="0">
-                <a:solidFill>
-                  <a:srgbClr val="111827"/>
-                </a:solidFill>
-                <a:latin typeface="Times New Roman"/>
-              </a:rPr>
-              <a:t>16. Younes Y, et al. BMC Psychiatry. 2021;21:548.</a:t>
-            </a:r>
-          </a:p>
-          <a:p>
-            <a:pPr algn="l">
-              <a:spcAft>
-                <a:spcPts val="15"/>
-              </a:spcAft>
-            </a:pPr>
-            <a:r>
-              <a:rPr sz="254" b="0" i="0">
-                <a:solidFill>
-                  <a:srgbClr val="111827"/>
-                </a:solidFill>
-                <a:latin typeface="Times New Roman"/>
-              </a:rPr>
-              <a:t>17. Adegoke AA, et al. Gend Behav. 2014;12:6087-6094.</a:t>
-            </a:r>
-          </a:p>
-          <a:p>
-            <a:pPr algn="l">
-              <a:spcAft>
-                <a:spcPts val="15"/>
-              </a:spcAft>
-            </a:pPr>
-            <a:r>
-              <a:rPr sz="254" b="0" i="0">
-                <a:solidFill>
-                  <a:srgbClr val="111827"/>
-                </a:solidFill>
-                <a:latin typeface="Times New Roman"/>
-              </a:rPr>
-              <a:t>18. Hantsoo L, et al. J Womens Health. 2022;31:100-109.</a:t>
-            </a:r>
-          </a:p>
-          <a:p>
-            <a:pPr algn="l">
-              <a:spcAft>
-                <a:spcPts val="15"/>
-              </a:spcAft>
-            </a:pPr>
-            <a:r>
-              <a:rPr sz="254" b="0" i="0">
-                <a:solidFill>
-                  <a:srgbClr val="111827"/>
-                </a:solidFill>
-                <a:latin typeface="Times New Roman"/>
-              </a:rPr>
-              <a:t>19. Habib S, et al. Womens Reprod Health. 2025;12:310-329.</a:t>
-            </a:r>
-          </a:p>
-          <a:p>
-            <a:pPr algn="l">
-              <a:spcAft>
-                <a:spcPts val="15"/>
-              </a:spcAft>
-            </a:pPr>
-            <a:r>
-              <a:rPr sz="254" b="0" i="0">
-                <a:solidFill>
-                  <a:srgbClr val="111827"/>
-                </a:solidFill>
-                <a:latin typeface="Times New Roman"/>
-              </a:rPr>
-              <a:t>20. Naik SS, et al. Front Glob Womens Health. 2023;4:1181583.</a:t>
-            </a:r>
-          </a:p>
-          <a:p>
-            <a:pPr algn="l">
-              <a:spcAft>
-                <a:spcPts val="15"/>
-              </a:spcAft>
-            </a:pPr>
-            <a:r>
-              <a:rPr sz="254" b="1" i="1">
-                <a:solidFill>
-                  <a:srgbClr val="111827"/>
-                </a:solidFill>
-                <a:latin typeface="Times New Roman"/>
-              </a:rPr>
-              <a:t>Scan the QR code for the full reference list.</a:t>
-            </a:r>
-          </a:p>
-        </p:txBody>
-      </p:sp>
-      <p:sp>
-        <p:nvSpPr>
-          <p:cNvPr id="353" name="Rounded Rectangle 352"/>
-          <p:cNvSpPr/>
-          <p:nvPr/>
-        </p:nvSpPr>
-        <p:spPr>
-          <a:xfrm>
-            <a:off x="2428646" y="6455664"/>
-            <a:ext cx="4516221" cy="237744"/>
-          </a:xfrm>
-          <a:prstGeom prst="roundRect">
-            <a:avLst>
-              <a:gd name="adj" fmla="val 8000"/>
-            </a:avLst>
-          </a:prstGeom>
-          <a:solidFill>
-            <a:srgbClr val="0A254E"/>
-          </a:solidFill>
-          <a:ln>
-            <a:noFill/>
-          </a:ln>
-          <a:effectLst/>
-        </p:spPr>
-        <p:style>
-          <a:lnRef idx="1">
-            <a:schemeClr val="accent1"/>
-          </a:lnRef>
-          <a:fillRef idx="3">
-            <a:schemeClr val="accent1"/>
-          </a:fillRef>
-          <a:effectRef idx="2">
-            <a:schemeClr val="accent1"/>
-          </a:effectRef>
-          <a:fontRef idx="minor">
-            <a:schemeClr val="lt1"/>
-          </a:fontRef>
-        </p:style>
-        <p:txBody>
           <a:bodyPr rtlCol="0" anchor="ctr" wrap="square" lIns="73152" rIns="73152" tIns="13716" bIns="13716"/>
           <a:lstStyle/>
           <a:p>
@@ -11222,7 +10845,7 @@
       </p:sp>
       <p:sp>
         <p:nvSpPr>
-          <p:cNvPr id="354" name="TextBox 353"/>
+          <p:cNvPr id="353" name="TextBox 352"/>
           <p:cNvSpPr txBox="1"/>
           <p:nvPr/>
         </p:nvSpPr>
@@ -11261,7 +10884,7 @@
       </p:sp>
       <p:graphicFrame>
         <p:nvGraphicFramePr>
-          <p:cNvPr id="355" name="Chart 354"/>
+          <p:cNvPr id="354" name="Chart 353"/>
           <p:cNvGraphicFramePr>
             <a:graphicFrameLocks noGrp="1"/>
           </p:cNvGraphicFramePr>
@@ -11279,7 +10902,7 @@
       </p:graphicFrame>
       <p:sp>
         <p:nvSpPr>
-          <p:cNvPr id="356" name="TextBox 355"/>
+          <p:cNvPr id="355" name="TextBox 354"/>
           <p:cNvSpPr txBox="1"/>
           <p:nvPr/>
         </p:nvSpPr>

</xml_diff>

<commit_message>
Use AMA figure labels and in-text figure references on poster
Co-Authored-By: Claude Opus 5.5 <noreply@anthropic.com>
Claude-Session: https://claude.ai/code/session_01VkRRDHxfMApHVBQgQibkFd
</commit_message>
<xml_diff>
--- a/PMDD_Scoping_Review/PMDD_APHA_Poster_FINAL.pptx
+++ b/PMDD_Scoping_Review/PMDD_APHA_Poster_FINAL.pptx
@@ -8424,7 +8424,16 @@
                 </a:solidFill>
                 <a:latin typeface="Times New Roman"/>
               </a:rPr>
-              <a:t>Fig 1. Study Selection — PRISMA-ScR Flow Diagram</a:t>
+              <a:t>Figure 1. </a:t>
+            </a:r>
+            <a:r>
+              <a:rPr sz="520" b="1" i="0">
+                <a:solidFill>
+                  <a:srgbClr val="0A254E"/>
+                </a:solidFill>
+                <a:latin typeface="Times New Roman"/>
+              </a:rPr>
+              <a:t>Study Selection Flow Diagram (Adapted From PRISMA-ScR¹¹)</a:t>
             </a:r>
           </a:p>
         </p:txBody>
@@ -9776,7 +9785,16 @@
                 </a:solidFill>
                 <a:latin typeface="Times New Roman"/>
               </a:rPr>
-              <a:t>Fig 2. Included Studies Reporting Each Outcome (of 44)</a:t>
+              <a:t>Figure 2. </a:t>
+            </a:r>
+            <a:r>
+              <a:rPr sz="520" b="1" i="0">
+                <a:solidFill>
+                  <a:srgbClr val="0A254E"/>
+                </a:solidFill>
+                <a:latin typeface="Times New Roman"/>
+              </a:rPr>
+              <a:t>Psychosocial Outcomes Reported in the 44 Included Studies</a:t>
             </a:r>
           </a:p>
         </p:txBody>
@@ -9872,7 +9890,16 @@
                 </a:solidFill>
                 <a:latin typeface="Times New Roman"/>
               </a:rPr>
-              <a:t>Fig 3. Geographic Setting of the 44 Included Studies</a:t>
+              <a:t>Figure 3. </a:t>
+            </a:r>
+            <a:r>
+              <a:rPr sz="520" b="1" i="0">
+                <a:solidFill>
+                  <a:srgbClr val="0A254E"/>
+                </a:solidFill>
+                <a:latin typeface="Times New Roman"/>
+              </a:rPr>
+              <a:t>Country Setting and World Bank Income Group of Included Studies¹²</a:t>
             </a:r>
           </a:p>
         </p:txBody>
@@ -10174,7 +10201,7 @@
                 </a:solidFill>
                 <a:latin typeface="Times New Roman"/>
               </a:rPr>
-              <a:t>The database search identified 1,943 records. After 325 duplicates were removed, 1,618 records were screened by title and abstract; 64 were assessed for eligibility, 20 were excluded, and 44 studies were included (Fig. 1). Most (61%) were published in 2022–2025 (Fig. 4).</a:t>
+              <a:t>The database search identified 1,943 records. After 325 duplicates were removed, 1,618 records were screened by title and abstract; 64 were assessed for eligibility, 20 were excluded, and 44 studies were included (Figure 1). Most (61%) were published in 2022–2025 (Figure 4).</a:t>
             </a:r>
           </a:p>
           <a:p>
@@ -10190,7 +10217,7 @@
                 </a:solidFill>
                 <a:latin typeface="Times New Roman"/>
               </a:rPr>
-              <a:t>Depression was the most documented outcome (n=39); one nationwide cohort found a 2.6-fold higher risk of later depression after a PMDD diagnosis.¹³ Psychological distress (n=24), interpersonal functioning (n=18), suicidal ideation or self-harm (n=14) and quality of life (n=14) followed. Only three studies examined coping mechanisms, such as peer support shared in online PMDD communities¹⁴ (Fig. 2).</a:t>
+              <a:t>Depression was the most documented outcome (n=39); one nationwide cohort found a 2.6-fold higher risk of later depression after a PMDD diagnosis.¹³ Psychological distress (n=24), interpersonal functioning (n=18), suicidal ideation or self-harm (n=14) and quality of life (n=14) followed. Only three studies examined coping mechanisms, such as peer support shared in online PMDD communities¹⁴ (Figure 2).</a:t>
             </a:r>
           </a:p>
           <a:p>
@@ -10206,7 +10233,7 @@
                 </a:solidFill>
                 <a:latin typeface="Times New Roman"/>
               </a:rPr>
-              <a:t>Twenty studies came from high-income countries and seven from upper-middle-income countries (Türkiye, Iran); only three (6.8%) came from low- and lower-middle-income countries—Bangladesh,¹⁵ Lebanon¹⁶ and Nigeria,¹⁷ the only study from sub-Saharan Africa (Fig. 3).</a:t>
+              <a:t>Twenty studies came from high-income countries and seven from upper-middle-income countries (Türkiye, Iran); only three (6.8%) came from low- and lower-middle-income countries—Bangladesh,¹⁵ Lebanon¹⁶ and Nigeria,¹⁷ the only study from sub-Saharan Africa (Figure 3).</a:t>
             </a:r>
           </a:p>
           <a:p>
@@ -10877,7 +10904,16 @@
                 </a:solidFill>
                 <a:latin typeface="Times New Roman"/>
               </a:rPr>
-              <a:t>Fig 4. Included Studies by Publication Period</a:t>
+              <a:t>Figure 4. </a:t>
+            </a:r>
+            <a:r>
+              <a:rPr sz="459" b="1" i="0">
+                <a:solidFill>
+                  <a:srgbClr val="0A254E"/>
+                </a:solidFill>
+                <a:latin typeface="Times New Roman"/>
+              </a:rPr>
+              <a:t>Included Studies by Publication Period</a:t>
             </a:r>
           </a:p>
         </p:txBody>

</xml_diff>

<commit_message>
Place AMA figure legends below figures and update conclusion
Co-Authored-By: Claude Opus 5.5 <noreply@anthropic.com>
Claude-Session: https://claude.ai/code/session_01VkRRDHxfMApHVBQgQibkFd
</commit_message>
<xml_diff>
--- a/PMDD_Scoping_Review/PMDD_APHA_Poster_FINAL.pptx
+++ b/PMDD_Scoping_Review/PMDD_APHA_Poster_FINAL.pptx
@@ -8392,61 +8392,13 @@
       </p:cxnSp>
       <p:sp>
         <p:nvSpPr>
-          <p:cNvPr id="320" name="TextBox 319"/>
-          <p:cNvSpPr txBox="1"/>
+          <p:cNvPr id="320" name="Rounded Rectangle 319"/>
+          <p:cNvSpPr/>
           <p:nvPr/>
         </p:nvSpPr>
         <p:spPr>
           <a:xfrm>
-            <a:off x="2414016" y="1627632"/>
-            <a:ext cx="2240280" cy="146304"/>
-          </a:xfrm>
-          <a:prstGeom prst="rect">
-            <a:avLst/>
-          </a:prstGeom>
-          <a:noFill/>
-        </p:spPr>
-        <p:txBody>
-          <a:bodyPr wrap="square" anchor="t" lIns="27432" rIns="27432" tIns="13716" bIns="13716">
-            <a:spAutoFit/>
-          </a:bodyPr>
-          <a:lstStyle/>
-          <a:p>
-            <a:pPr algn="l">
-              <a:spcAft>
-                <a:spcPts val="120"/>
-              </a:spcAft>
-            </a:pPr>
-            <a:r>
-              <a:rPr sz="520" b="1" i="0">
-                <a:solidFill>
-                  <a:srgbClr val="0A254E"/>
-                </a:solidFill>
-                <a:latin typeface="Times New Roman"/>
-              </a:rPr>
-              <a:t>Figure 1. </a:t>
-            </a:r>
-            <a:r>
-              <a:rPr sz="520" b="1" i="0">
-                <a:solidFill>
-                  <a:srgbClr val="0A254E"/>
-                </a:solidFill>
-                <a:latin typeface="Times New Roman"/>
-              </a:rPr>
-              <a:t>Study Selection Flow Diagram (Adapted From PRISMA-ScR¹¹)</a:t>
-            </a:r>
-          </a:p>
-        </p:txBody>
-      </p:sp>
-      <p:sp>
-        <p:nvSpPr>
-          <p:cNvPr id="321" name="Rounded Rectangle 320"/>
-          <p:cNvSpPr/>
-          <p:nvPr/>
-        </p:nvSpPr>
-        <p:spPr>
-          <a:xfrm>
-            <a:off x="2414016" y="1810512"/>
+            <a:off x="2414016" y="1700784"/>
             <a:ext cx="301752" cy="365760"/>
           </a:xfrm>
           <a:prstGeom prst="roundRect">
@@ -8501,13 +8453,13 @@
       </p:sp>
       <p:sp>
         <p:nvSpPr>
-          <p:cNvPr id="322" name="Rounded Rectangle 321"/>
+          <p:cNvPr id="321" name="Rounded Rectangle 320"/>
           <p:cNvSpPr/>
           <p:nvPr/>
         </p:nvSpPr>
         <p:spPr>
           <a:xfrm>
-            <a:off x="2414016" y="2249424"/>
+            <a:off x="2414016" y="2139696"/>
             <a:ext cx="301752" cy="329184"/>
           </a:xfrm>
           <a:prstGeom prst="roundRect">
@@ -8562,13 +8514,13 @@
       </p:sp>
       <p:sp>
         <p:nvSpPr>
-          <p:cNvPr id="323" name="Rounded Rectangle 322"/>
+          <p:cNvPr id="322" name="Rounded Rectangle 321"/>
           <p:cNvSpPr/>
           <p:nvPr/>
         </p:nvSpPr>
         <p:spPr>
           <a:xfrm>
-            <a:off x="2414016" y="2651760"/>
+            <a:off x="2414016" y="2542032"/>
             <a:ext cx="301752" cy="365760"/>
           </a:xfrm>
           <a:prstGeom prst="roundRect">
@@ -8623,13 +8575,13 @@
       </p:sp>
       <p:sp>
         <p:nvSpPr>
-          <p:cNvPr id="324" name="Rounded Rectangle 323"/>
+          <p:cNvPr id="323" name="Rounded Rectangle 322"/>
           <p:cNvSpPr/>
           <p:nvPr/>
         </p:nvSpPr>
         <p:spPr>
           <a:xfrm>
-            <a:off x="2414016" y="3090672"/>
+            <a:off x="2414016" y="2980944"/>
             <a:ext cx="301752" cy="365760"/>
           </a:xfrm>
           <a:prstGeom prst="roundRect">
@@ -8684,13 +8636,13 @@
       </p:sp>
       <p:sp>
         <p:nvSpPr>
-          <p:cNvPr id="325" name="Rounded Rectangle 324"/>
+          <p:cNvPr id="324" name="Rounded Rectangle 323"/>
           <p:cNvSpPr/>
           <p:nvPr/>
         </p:nvSpPr>
         <p:spPr>
           <a:xfrm>
-            <a:off x="2414016" y="3529584"/>
+            <a:off x="2414016" y="3419856"/>
             <a:ext cx="301752" cy="365760"/>
           </a:xfrm>
           <a:prstGeom prst="roundRect">
@@ -8745,13 +8697,13 @@
       </p:sp>
       <p:sp>
         <p:nvSpPr>
-          <p:cNvPr id="326" name="Rounded Rectangle 325"/>
+          <p:cNvPr id="325" name="Rounded Rectangle 324"/>
           <p:cNvSpPr/>
           <p:nvPr/>
         </p:nvSpPr>
         <p:spPr>
           <a:xfrm>
-            <a:off x="2761488" y="1810512"/>
+            <a:off x="2761488" y="1700784"/>
             <a:ext cx="960120" cy="365760"/>
           </a:xfrm>
           <a:prstGeom prst="roundRect">
@@ -8793,7 +8745,7 @@
               </a:spcAft>
             </a:pPr>
             <a:r>
-              <a:rPr sz="330" b="1" i="0">
+              <a:rPr sz="318" b="1" i="0">
                 <a:solidFill>
                   <a:srgbClr val="111827"/>
                 </a:solidFill>
@@ -8809,7 +8761,7 @@
               </a:spcAft>
             </a:pPr>
             <a:r>
-              <a:rPr sz="330" b="0" i="0">
+              <a:rPr sz="318" b="0" i="0">
                 <a:solidFill>
                   <a:srgbClr val="111827"/>
                 </a:solidFill>
@@ -8825,7 +8777,7 @@
               </a:spcAft>
             </a:pPr>
             <a:r>
-              <a:rPr sz="330" b="0" i="0">
+              <a:rPr sz="318" b="0" i="0">
                 <a:solidFill>
                   <a:srgbClr val="111827"/>
                 </a:solidFill>
@@ -8841,7 +8793,7 @@
               </a:spcAft>
             </a:pPr>
             <a:r>
-              <a:rPr sz="330" b="0" i="0">
+              <a:rPr sz="318" b="0" i="0">
                 <a:solidFill>
                   <a:srgbClr val="111827"/>
                 </a:solidFill>
@@ -8854,14 +8806,14 @@
       </p:sp>
       <p:cxnSp>
         <p:nvCxnSpPr>
-          <p:cNvPr id="327" name="Connector 326"/>
+          <p:cNvPr id="326" name="Connector 325"/>
           <p:cNvCxnSpPr/>
           <p:nvPr/>
         </p:nvCxnSpPr>
         <p:spPr>
           <a:xfrm>
-            <a:off x="3241548" y="2176272"/>
-            <a:ext cx="0" cy="73152"/>
+            <a:off x="3241548" y="2066543"/>
+            <a:ext cx="0" cy="73153"/>
           </a:xfrm>
           <a:prstGeom prst="line">
             <a:avLst/>
@@ -8890,13 +8842,13 @@
       </p:cxnSp>
       <p:sp>
         <p:nvSpPr>
-          <p:cNvPr id="328" name="Rounded Rectangle 327"/>
+          <p:cNvPr id="327" name="Rounded Rectangle 326"/>
           <p:cNvSpPr/>
           <p:nvPr/>
         </p:nvSpPr>
         <p:spPr>
           <a:xfrm>
-            <a:off x="2761488" y="2249424"/>
+            <a:off x="2761488" y="2139696"/>
             <a:ext cx="960120" cy="329184"/>
           </a:xfrm>
           <a:prstGeom prst="roundRect">
@@ -8983,13 +8935,13 @@
       </p:sp>
       <p:cxnSp>
         <p:nvCxnSpPr>
-          <p:cNvPr id="329" name="Connector 328"/>
+          <p:cNvPr id="328" name="Connector 327"/>
           <p:cNvCxnSpPr/>
           <p:nvPr/>
         </p:nvCxnSpPr>
         <p:spPr>
           <a:xfrm>
-            <a:off x="3241548" y="2578608"/>
+            <a:off x="3241548" y="2468880"/>
             <a:ext cx="0" cy="73152"/>
           </a:xfrm>
           <a:prstGeom prst="line">
@@ -9019,13 +8971,13 @@
       </p:cxnSp>
       <p:sp>
         <p:nvSpPr>
-          <p:cNvPr id="330" name="Rounded Rectangle 329"/>
+          <p:cNvPr id="329" name="Rounded Rectangle 328"/>
           <p:cNvSpPr/>
           <p:nvPr/>
         </p:nvSpPr>
         <p:spPr>
           <a:xfrm>
-            <a:off x="2761488" y="2651760"/>
+            <a:off x="2761488" y="2542032"/>
             <a:ext cx="960120" cy="365760"/>
           </a:xfrm>
           <a:prstGeom prst="roundRect">
@@ -9112,13 +9064,13 @@
       </p:sp>
       <p:sp>
         <p:nvSpPr>
-          <p:cNvPr id="331" name="Rounded Rectangle 330"/>
+          <p:cNvPr id="330" name="Rounded Rectangle 329"/>
           <p:cNvSpPr/>
           <p:nvPr/>
         </p:nvSpPr>
         <p:spPr>
           <a:xfrm>
-            <a:off x="3785615" y="2651760"/>
+            <a:off x="3785615" y="2542032"/>
             <a:ext cx="886968" cy="365760"/>
           </a:xfrm>
           <a:prstGeom prst="roundRect">
@@ -9221,13 +9173,13 @@
       </p:sp>
       <p:cxnSp>
         <p:nvCxnSpPr>
-          <p:cNvPr id="332" name="Connector 331"/>
+          <p:cNvPr id="331" name="Connector 330"/>
           <p:cNvCxnSpPr/>
           <p:nvPr/>
         </p:nvCxnSpPr>
         <p:spPr>
           <a:xfrm>
-            <a:off x="3721608" y="2834640"/>
+            <a:off x="3721608" y="2724912"/>
             <a:ext cx="64007" cy="0"/>
           </a:xfrm>
           <a:prstGeom prst="line">
@@ -9257,13 +9209,13 @@
       </p:cxnSp>
       <p:cxnSp>
         <p:nvCxnSpPr>
-          <p:cNvPr id="333" name="Connector 332"/>
+          <p:cNvPr id="332" name="Connector 331"/>
           <p:cNvCxnSpPr/>
           <p:nvPr/>
         </p:nvCxnSpPr>
         <p:spPr>
           <a:xfrm>
-            <a:off x="3241548" y="3017520"/>
+            <a:off x="3241548" y="2907792"/>
             <a:ext cx="0" cy="73152"/>
           </a:xfrm>
           <a:prstGeom prst="line">
@@ -9293,13 +9245,13 @@
       </p:cxnSp>
       <p:sp>
         <p:nvSpPr>
-          <p:cNvPr id="334" name="Rounded Rectangle 333"/>
+          <p:cNvPr id="333" name="Rounded Rectangle 332"/>
           <p:cNvSpPr/>
           <p:nvPr/>
         </p:nvSpPr>
         <p:spPr>
           <a:xfrm>
-            <a:off x="2761488" y="3090672"/>
+            <a:off x="2761488" y="2980944"/>
             <a:ext cx="960120" cy="365760"/>
           </a:xfrm>
           <a:prstGeom prst="roundRect">
@@ -9386,13 +9338,13 @@
       </p:sp>
       <p:sp>
         <p:nvSpPr>
-          <p:cNvPr id="335" name="Rounded Rectangle 334"/>
+          <p:cNvPr id="334" name="Rounded Rectangle 333"/>
           <p:cNvSpPr/>
           <p:nvPr/>
         </p:nvSpPr>
         <p:spPr>
           <a:xfrm>
-            <a:off x="3785615" y="3090672"/>
+            <a:off x="3785615" y="2980944"/>
             <a:ext cx="886968" cy="365760"/>
           </a:xfrm>
           <a:prstGeom prst="roundRect">
@@ -9434,7 +9386,7 @@
               </a:spcAft>
             </a:pPr>
             <a:r>
-              <a:rPr sz="330" b="1" i="0">
+              <a:rPr sz="318" b="1" i="0">
                 <a:solidFill>
                   <a:srgbClr val="111827"/>
                 </a:solidFill>
@@ -9450,7 +9402,7 @@
               </a:spcAft>
             </a:pPr>
             <a:r>
-              <a:rPr sz="330" b="0" i="0">
+              <a:rPr sz="318" b="0" i="0">
                 <a:solidFill>
                   <a:srgbClr val="111827"/>
                 </a:solidFill>
@@ -9466,7 +9418,7 @@
               </a:spcAft>
             </a:pPr>
             <a:r>
-              <a:rPr sz="330" b="0" i="0">
+              <a:rPr sz="318" b="0" i="0">
                 <a:solidFill>
                   <a:srgbClr val="111827"/>
                 </a:solidFill>
@@ -9479,13 +9431,13 @@
       </p:sp>
       <p:cxnSp>
         <p:nvCxnSpPr>
-          <p:cNvPr id="336" name="Connector 335"/>
+          <p:cNvPr id="335" name="Connector 334"/>
           <p:cNvCxnSpPr/>
           <p:nvPr/>
         </p:nvCxnSpPr>
         <p:spPr>
           <a:xfrm>
-            <a:off x="3721608" y="3273552"/>
+            <a:off x="3721608" y="3163824"/>
             <a:ext cx="64007" cy="0"/>
           </a:xfrm>
           <a:prstGeom prst="line">
@@ -9515,13 +9467,13 @@
       </p:cxnSp>
       <p:cxnSp>
         <p:nvCxnSpPr>
-          <p:cNvPr id="337" name="Connector 336"/>
+          <p:cNvPr id="336" name="Connector 335"/>
           <p:cNvCxnSpPr/>
           <p:nvPr/>
         </p:nvCxnSpPr>
         <p:spPr>
           <a:xfrm>
-            <a:off x="3241548" y="3456432"/>
+            <a:off x="3241548" y="3346704"/>
             <a:ext cx="0" cy="73152"/>
           </a:xfrm>
           <a:prstGeom prst="line">
@@ -9551,13 +9503,13 @@
       </p:cxnSp>
       <p:sp>
         <p:nvSpPr>
-          <p:cNvPr id="338" name="Rounded Rectangle 337"/>
+          <p:cNvPr id="337" name="Rounded Rectangle 336"/>
           <p:cNvSpPr/>
           <p:nvPr/>
         </p:nvSpPr>
         <p:spPr>
           <a:xfrm>
-            <a:off x="2761488" y="3529584"/>
+            <a:off x="2761488" y="3419856"/>
             <a:ext cx="960120" cy="365760"/>
           </a:xfrm>
           <a:prstGeom prst="roundRect">
@@ -9644,13 +9596,70 @@
       </p:sp>
       <p:sp>
         <p:nvSpPr>
+          <p:cNvPr id="338" name="TextBox 337"/>
+          <p:cNvSpPr txBox="1"/>
+          <p:nvPr/>
+        </p:nvSpPr>
+        <p:spPr>
+          <a:xfrm>
+            <a:off x="2414016" y="3803904"/>
+            <a:ext cx="2258568" cy="164592"/>
+          </a:xfrm>
+          <a:prstGeom prst="rect">
+            <a:avLst/>
+          </a:prstGeom>
+          <a:noFill/>
+        </p:spPr>
+        <p:txBody>
+          <a:bodyPr wrap="square" anchor="t" lIns="27432" rIns="27432" tIns="13716" bIns="13716">
+            <a:spAutoFit/>
+          </a:bodyPr>
+          <a:lstStyle/>
+          <a:p>
+            <a:pPr algn="l">
+              <a:spcAft>
+                <a:spcPts val="120"/>
+              </a:spcAft>
+            </a:pPr>
+            <a:r>
+              <a:rPr sz="420" b="1" i="0">
+                <a:solidFill>
+                  <a:srgbClr val="0A254E"/>
+                </a:solidFill>
+                <a:latin typeface="Times New Roman"/>
+              </a:rPr>
+              <a:t>Figure 1. </a:t>
+            </a:r>
+            <a:r>
+              <a:rPr sz="420" b="1" i="0">
+                <a:solidFill>
+                  <a:srgbClr val="0A254E"/>
+                </a:solidFill>
+                <a:latin typeface="Times New Roman"/>
+              </a:rPr>
+              <a:t>Study Selection Flow Diagram.</a:t>
+            </a:r>
+            <a:r>
+              <a:rPr sz="420" b="0" i="0">
+                <a:solidFill>
+                  <a:srgbClr val="111827"/>
+                </a:solidFill>
+                <a:latin typeface="Times New Roman"/>
+              </a:rPr>
+              <a:t> Adapted from PRISMA-ScR.¹¹</a:t>
+            </a:r>
+          </a:p>
+        </p:txBody>
+      </p:sp>
+      <p:sp>
+        <p:nvSpPr>
           <p:cNvPr id="339" name="Rounded Rectangle 338"/>
           <p:cNvSpPr/>
           <p:nvPr/>
         </p:nvSpPr>
         <p:spPr>
           <a:xfrm>
-            <a:off x="2414016" y="4005072"/>
+            <a:off x="2414016" y="3986784"/>
             <a:ext cx="2258568" cy="548640"/>
           </a:xfrm>
           <a:prstGeom prst="roundRect">
@@ -9751,65 +9760,17 @@
           </a:p>
         </p:txBody>
       </p:sp>
-      <p:sp>
-        <p:nvSpPr>
-          <p:cNvPr id="340" name="TextBox 339"/>
-          <p:cNvSpPr txBox="1"/>
-          <p:nvPr/>
-        </p:nvSpPr>
-        <p:spPr>
-          <a:xfrm>
-            <a:off x="4754880" y="1627632"/>
-            <a:ext cx="2240280" cy="146304"/>
-          </a:xfrm>
-          <a:prstGeom prst="rect">
-            <a:avLst/>
-          </a:prstGeom>
-          <a:noFill/>
-        </p:spPr>
-        <p:txBody>
-          <a:bodyPr wrap="square" anchor="t" lIns="27432" rIns="27432" tIns="13716" bIns="13716">
-            <a:spAutoFit/>
-          </a:bodyPr>
-          <a:lstStyle/>
-          <a:p>
-            <a:pPr algn="l">
-              <a:spcAft>
-                <a:spcPts val="120"/>
-              </a:spcAft>
-            </a:pPr>
-            <a:r>
-              <a:rPr sz="520" b="1" i="0">
-                <a:solidFill>
-                  <a:srgbClr val="0A254E"/>
-                </a:solidFill>
-                <a:latin typeface="Times New Roman"/>
-              </a:rPr>
-              <a:t>Figure 2. </a:t>
-            </a:r>
-            <a:r>
-              <a:rPr sz="520" b="1" i="0">
-                <a:solidFill>
-                  <a:srgbClr val="0A254E"/>
-                </a:solidFill>
-                <a:latin typeface="Times New Roman"/>
-              </a:rPr>
-              <a:t>Psychosocial Outcomes Reported in the 44 Included Studies</a:t>
-            </a:r>
-          </a:p>
-        </p:txBody>
-      </p:sp>
       <p:graphicFrame>
         <p:nvGraphicFramePr>
-          <p:cNvPr id="341" name="Chart 340"/>
+          <p:cNvPr id="340" name="Chart 339"/>
           <p:cNvGraphicFramePr>
             <a:graphicFrameLocks noGrp="1"/>
           </p:cNvGraphicFramePr>
           <p:nvPr/>
         </p:nvGraphicFramePr>
         <p:xfrm>
-          <a:off x="4754880" y="1810512"/>
-          <a:ext cx="2240280" cy="2606040"/>
+          <a:off x="4754880" y="1682496"/>
+          <a:ext cx="2240280" cy="2596896"/>
         </p:xfrm>
         <a:graphic>
           <a:graphicData uri="http://schemas.openxmlformats.org/drawingml/2006/chart">
@@ -9819,14 +9780,14 @@
       </p:graphicFrame>
       <p:sp>
         <p:nvSpPr>
-          <p:cNvPr id="342" name="TextBox 341"/>
+          <p:cNvPr id="341" name="TextBox 340"/>
           <p:cNvSpPr txBox="1"/>
           <p:nvPr/>
         </p:nvSpPr>
         <p:spPr>
           <a:xfrm>
-            <a:off x="4754880" y="4407408"/>
-            <a:ext cx="2240280" cy="128016"/>
+            <a:off x="4754880" y="4297680"/>
+            <a:ext cx="2240280" cy="237744"/>
           </a:xfrm>
           <a:prstGeom prst="rect">
             <a:avLst/>
@@ -9845,68 +9806,38 @@
               </a:spcAft>
             </a:pPr>
             <a:r>
-              <a:rPr sz="320" b="0" i="1">
-                <a:solidFill>
-                  <a:srgbClr val="4B5563"/>
-                </a:solidFill>
-                <a:latin typeface="Times New Roman"/>
-              </a:rPr>
-              <a:t>A study could report more than one outcome; counts should not be summed.</a:t>
-            </a:r>
-          </a:p>
-        </p:txBody>
-      </p:sp>
-      <p:sp>
-        <p:nvSpPr>
-          <p:cNvPr id="343" name="TextBox 342"/>
-          <p:cNvSpPr txBox="1"/>
-          <p:nvPr/>
-        </p:nvSpPr>
-        <p:spPr>
-          <a:xfrm>
-            <a:off x="2414016" y="4636008"/>
-            <a:ext cx="4572000" cy="146304"/>
-          </a:xfrm>
-          <a:prstGeom prst="rect">
-            <a:avLst/>
-          </a:prstGeom>
-          <a:noFill/>
-        </p:spPr>
-        <p:txBody>
-          <a:bodyPr wrap="square" anchor="t" lIns="27432" rIns="27432" tIns="13716" bIns="13716">
-            <a:spAutoFit/>
-          </a:bodyPr>
-          <a:lstStyle/>
-          <a:p>
-            <a:pPr algn="l">
-              <a:spcAft>
-                <a:spcPts val="120"/>
-              </a:spcAft>
-            </a:pPr>
-            <a:r>
-              <a:rPr sz="520" b="1" i="0">
+              <a:rPr sz="420" b="1" i="0">
                 <a:solidFill>
                   <a:srgbClr val="0A254E"/>
                 </a:solidFill>
                 <a:latin typeface="Times New Roman"/>
               </a:rPr>
-              <a:t>Figure 3. </a:t>
-            </a:r>
-            <a:r>
-              <a:rPr sz="520" b="1" i="0">
+              <a:t>Figure 2. </a:t>
+            </a:r>
+            <a:r>
+              <a:rPr sz="420" b="1" i="0">
                 <a:solidFill>
                   <a:srgbClr val="0A254E"/>
                 </a:solidFill>
                 <a:latin typeface="Times New Roman"/>
               </a:rPr>
-              <a:t>Country Setting and World Bank Income Group of Included Studies¹²</a:t>
+              <a:t>Psychosocial Outcomes Reported in the 44 Included Studies.</a:t>
+            </a:r>
+            <a:r>
+              <a:rPr sz="420" b="0" i="0">
+                <a:solidFill>
+                  <a:srgbClr val="111827"/>
+                </a:solidFill>
+                <a:latin typeface="Times New Roman"/>
+              </a:rPr>
+              <a:t> A study could report more than one outcome, so counts should not be summed.</a:t>
             </a:r>
           </a:p>
         </p:txBody>
       </p:sp>
       <p:pic>
         <p:nvPicPr>
-          <p:cNvPr id="344" name="Picture 343" descr="fig3_map.png"/>
+          <p:cNvPr id="342" name="Picture 341" descr="fig3_map.png"/>
           <p:cNvPicPr>
             <a:picLocks noChangeAspect="1"/>
           </p:cNvPicPr>
@@ -9920,7 +9851,7 @@
         </p:blipFill>
         <p:spPr>
           <a:xfrm>
-            <a:off x="2414016" y="4837176"/>
+            <a:off x="2414016" y="4681728"/>
             <a:ext cx="3108960" cy="1399585"/>
           </a:xfrm>
           <a:prstGeom prst="rect">
@@ -9930,13 +9861,13 @@
       </p:pic>
       <p:sp>
         <p:nvSpPr>
-          <p:cNvPr id="345" name="Rounded Rectangle 344"/>
+          <p:cNvPr id="343" name="Rounded Rectangle 342"/>
           <p:cNvSpPr/>
           <p:nvPr/>
         </p:nvSpPr>
         <p:spPr>
           <a:xfrm>
-            <a:off x="5577840" y="4956048"/>
+            <a:off x="5577840" y="4800600"/>
             <a:ext cx="1371600" cy="1097280"/>
           </a:xfrm>
           <a:prstGeom prst="roundRect">
@@ -10039,14 +9970,14 @@
       </p:sp>
       <p:sp>
         <p:nvSpPr>
-          <p:cNvPr id="346" name="TextBox 345"/>
+          <p:cNvPr id="344" name="TextBox 343"/>
           <p:cNvSpPr txBox="1"/>
           <p:nvPr/>
         </p:nvSpPr>
         <p:spPr>
           <a:xfrm>
-            <a:off x="2414016" y="6236208"/>
-            <a:ext cx="4572000" cy="201168"/>
+            <a:off x="2414016" y="6126480"/>
+            <a:ext cx="4572000" cy="292608"/>
           </a:xfrm>
           <a:prstGeom prst="rect">
             <a:avLst/>
@@ -10059,26 +9990,44 @@
           </a:bodyPr>
           <a:lstStyle/>
           <a:p>
-            <a:pPr algn="ctr">
+            <a:pPr algn="l">
               <a:spcAft>
                 <a:spcPts val="120"/>
               </a:spcAft>
             </a:pPr>
             <a:r>
-              <a:rPr sz="420" b="0" i="1">
-                <a:solidFill>
-                  <a:srgbClr val="4B5563"/>
-                </a:solidFill>
-                <a:latin typeface="Times New Roman"/>
-              </a:rPr>
-              <a:t>Map shows the 30 studies with an identifiable country setting (World Bank income groups). The other 14 used online or multinational samples or had no single mappable setting in the available records. *Includes Hong Kong (1).</a:t>
-            </a:r>
-          </a:p>
-        </p:txBody>
-      </p:sp>
-      <p:sp>
-        <p:nvSpPr>
-          <p:cNvPr id="347" name="Rectangle 346"/>
+              <a:rPr sz="420" b="1" i="0">
+                <a:solidFill>
+                  <a:srgbClr val="0A254E"/>
+                </a:solidFill>
+                <a:latin typeface="Times New Roman"/>
+              </a:rPr>
+              <a:t>Figure 3. </a:t>
+            </a:r>
+            <a:r>
+              <a:rPr sz="420" b="1" i="0">
+                <a:solidFill>
+                  <a:srgbClr val="0A254E"/>
+                </a:solidFill>
+                <a:latin typeface="Times New Roman"/>
+              </a:rPr>
+              <a:t>Country Setting and World Bank Income Group of Included Studies.</a:t>
+            </a:r>
+            <a:r>
+              <a:rPr sz="420" b="0" i="0">
+                <a:solidFill>
+                  <a:srgbClr val="111827"/>
+                </a:solidFill>
+                <a:latin typeface="Times New Roman"/>
+              </a:rPr>
+              <a:t> Map shows the 30 studies with an identifiable country setting; income groups follow the World Bank FY2027 classification.¹² The other 14 used online or multinational samples or had no single mappable setting in the available records. *Includes Hong Kong (1).</a:t>
+            </a:r>
+          </a:p>
+        </p:txBody>
+      </p:sp>
+      <p:sp>
+        <p:nvSpPr>
+          <p:cNvPr id="345" name="Rectangle 344"/>
           <p:cNvSpPr/>
           <p:nvPr/>
         </p:nvSpPr>
@@ -10135,7 +10084,7 @@
       </p:sp>
       <p:sp>
         <p:nvSpPr>
-          <p:cNvPr id="348" name="Rectangle 347"/>
+          <p:cNvPr id="346" name="Rectangle 345"/>
           <p:cNvSpPr/>
           <p:nvPr/>
         </p:nvSpPr>
@@ -10265,7 +10214,7 @@
                 </a:solidFill>
                 <a:latin typeface="Times New Roman"/>
               </a:rPr>
-              <a:t>PMDD research consistently documents depression, distress, relationship difficulties and suicidality.⁴⁻⁷ Patients describe misdiagnosis and uneven provider knowledge,¹⁸˒¹⁹ yet coping remains largely unexamined, and the scarcity of studies from low-income settings and Africa leaves the burden there invisible to health systems.</a:t>
+              <a:t>PMDD research consistently documents depression, distress, relationship difficulties and suicidality.⁴⁻⁷ Patients describe misdiagnosis and uneven provider knowledge,¹⁸˒¹⁹ yet coping remains largely unexamined.</a:t>
             </a:r>
           </a:p>
           <a:p>
@@ -10297,7 +10246,7 @@
                 </a:solidFill>
                 <a:latin typeface="Times New Roman"/>
               </a:rPr>
-              <a:t>Evidence on PMDD’s psychosocial burden is growing but geographically concentrated in high-income countries, calling for culturally responsive screening, integrated mental and reproductive health services, and Africa-centred research investment.</a:t>
+              <a:t>PMDD carries a well-documented psychosocial burden, especially depression, distress and suicidality, yet how women cope has received little attention, and evidence from low-income settings and Africa is nearly absent. Culturally responsive screening, integrated mental and reproductive health services, and Africa-centered research investment are needed to make this burden visible to health systems.</a:t>
             </a:r>
           </a:p>
           <a:p>
@@ -10428,7 +10377,7 @@
       </p:sp>
       <p:sp>
         <p:nvSpPr>
-          <p:cNvPr id="349" name="Rectangle 348"/>
+          <p:cNvPr id="347" name="Rectangle 346"/>
           <p:cNvSpPr/>
           <p:nvPr/>
         </p:nvSpPr>
@@ -10485,7 +10434,7 @@
       </p:sp>
       <p:sp>
         <p:nvSpPr>
-          <p:cNvPr id="350" name="Rectangle 349"/>
+          <p:cNvPr id="348" name="Rectangle 347"/>
           <p:cNvSpPr/>
           <p:nvPr/>
         </p:nvSpPr>
@@ -10747,7 +10696,7 @@
       </p:sp>
       <p:sp>
         <p:nvSpPr>
-          <p:cNvPr id="351" name="Rectangle 350"/>
+          <p:cNvPr id="349" name="Rectangle 348"/>
           <p:cNvSpPr/>
           <p:nvPr/>
         </p:nvSpPr>
@@ -10804,7 +10753,7 @@
       </p:sp>
       <p:sp>
         <p:nvSpPr>
-          <p:cNvPr id="352" name="Rounded Rectangle 351"/>
+          <p:cNvPr id="350" name="Rounded Rectangle 349"/>
           <p:cNvSpPr/>
           <p:nvPr/>
         </p:nvSpPr>
@@ -10870,57 +10819,9 @@
           </a:p>
         </p:txBody>
       </p:sp>
-      <p:sp>
-        <p:nvSpPr>
-          <p:cNvPr id="353" name="TextBox 352"/>
-          <p:cNvSpPr txBox="1"/>
-          <p:nvPr/>
-        </p:nvSpPr>
-        <p:spPr>
-          <a:xfrm>
-            <a:off x="7162495" y="3310128"/>
-            <a:ext cx="1826056" cy="118872"/>
-          </a:xfrm>
-          <a:prstGeom prst="rect">
-            <a:avLst/>
-          </a:prstGeom>
-          <a:noFill/>
-        </p:spPr>
-        <p:txBody>
-          <a:bodyPr wrap="square" anchor="t" lIns="27432" rIns="27432" tIns="13716" bIns="13716">
-            <a:spAutoFit/>
-          </a:bodyPr>
-          <a:lstStyle/>
-          <a:p>
-            <a:pPr algn="l">
-              <a:spcAft>
-                <a:spcPts val="120"/>
-              </a:spcAft>
-            </a:pPr>
-            <a:r>
-              <a:rPr sz="459" b="1" i="0">
-                <a:solidFill>
-                  <a:srgbClr val="0A254E"/>
-                </a:solidFill>
-                <a:latin typeface="Times New Roman"/>
-              </a:rPr>
-              <a:t>Figure 4. </a:t>
-            </a:r>
-            <a:r>
-              <a:rPr sz="459" b="1" i="0">
-                <a:solidFill>
-                  <a:srgbClr val="0A254E"/>
-                </a:solidFill>
-                <a:latin typeface="Times New Roman"/>
-              </a:rPr>
-              <a:t>Included Studies by Publication Period</a:t>
-            </a:r>
-          </a:p>
-        </p:txBody>
-      </p:sp>
       <p:graphicFrame>
         <p:nvGraphicFramePr>
-          <p:cNvPr id="354" name="Chart 353"/>
+          <p:cNvPr id="351" name="Chart 350"/>
           <p:cNvGraphicFramePr>
             <a:graphicFrameLocks noGrp="1"/>
           </p:cNvGraphicFramePr>
@@ -10928,7 +10829,7 @@
         </p:nvGraphicFramePr>
         <p:xfrm>
           <a:off x="7199071" y="3419856"/>
-          <a:ext cx="1752904" cy="530352"/>
+          <a:ext cx="1752904" cy="457200"/>
         </p:xfrm>
         <a:graphic>
           <a:graphicData uri="http://schemas.openxmlformats.org/drawingml/2006/chart">
@@ -10938,14 +10839,14 @@
       </p:graphicFrame>
       <p:sp>
         <p:nvSpPr>
-          <p:cNvPr id="355" name="TextBox 354"/>
+          <p:cNvPr id="352" name="TextBox 351"/>
           <p:cNvSpPr txBox="1"/>
           <p:nvPr/>
         </p:nvSpPr>
         <p:spPr>
           <a:xfrm>
-            <a:off x="7162495" y="3950208"/>
-            <a:ext cx="1826056" cy="91440"/>
+            <a:off x="7162495" y="3877056"/>
+            <a:ext cx="1826056" cy="164592"/>
           </a:xfrm>
           <a:prstGeom prst="rect">
             <a:avLst/>
@@ -10958,19 +10859,37 @@
           </a:bodyPr>
           <a:lstStyle/>
           <a:p>
-            <a:pPr algn="ctr">
+            <a:pPr algn="l">
               <a:spcAft>
                 <a:spcPts val="120"/>
               </a:spcAft>
             </a:pPr>
             <a:r>
-              <a:rPr sz="350" b="0" i="1">
-                <a:solidFill>
-                  <a:srgbClr val="4B5563"/>
-                </a:solidFill>
-                <a:latin typeface="Times New Roman"/>
-              </a:rPr>
-              <a:t>27 of 44 studies (61%) were published in 2022–2025.</a:t>
+              <a:rPr sz="380" b="1" i="0">
+                <a:solidFill>
+                  <a:srgbClr val="0A254E"/>
+                </a:solidFill>
+                <a:latin typeface="Times New Roman"/>
+              </a:rPr>
+              <a:t>Figure 4. </a:t>
+            </a:r>
+            <a:r>
+              <a:rPr sz="380" b="1" i="0">
+                <a:solidFill>
+                  <a:srgbClr val="0A254E"/>
+                </a:solidFill>
+                <a:latin typeface="Times New Roman"/>
+              </a:rPr>
+              <a:t>Included Studies by Publication Period.</a:t>
+            </a:r>
+            <a:r>
+              <a:rPr sz="380" b="0" i="0">
+                <a:solidFill>
+                  <a:srgbClr val="111827"/>
+                </a:solidFill>
+                <a:latin typeface="Times New Roman"/>
+              </a:rPr>
+              <a:t> 27 of 44 studies (61%) were published in 2022–2025.</a:t>
             </a:r>
           </a:p>
         </p:txBody>

</xml_diff>

<commit_message>
Move publication-period figure into center panel and renumber figures
Co-Authored-By: Claude Opus 5.5 <noreply@anthropic.com>
Claude-Session: https://claude.ai/code/session_01VkRRDHxfMApHVBQgQibkFd
</commit_message>
<xml_diff>
--- a/PMDD_Scoping_Review/PMDD_APHA_Poster_FINAL.pptx
+++ b/PMDD_Scoping_Review/PMDD_APHA_Poster_FINAL.pptx
@@ -9651,118 +9651,9 @@
           </a:p>
         </p:txBody>
       </p:sp>
-      <p:sp>
-        <p:nvSpPr>
-          <p:cNvPr id="339" name="Rounded Rectangle 338"/>
-          <p:cNvSpPr/>
-          <p:nvPr/>
-        </p:nvSpPr>
-        <p:spPr>
-          <a:xfrm>
-            <a:off x="2414016" y="3986784"/>
-            <a:ext cx="2258568" cy="548640"/>
-          </a:xfrm>
-          <a:prstGeom prst="roundRect">
-            <a:avLst>
-              <a:gd name="adj" fmla="val 8000"/>
-            </a:avLst>
-          </a:prstGeom>
-          <a:solidFill>
-            <a:srgbClr val="EEF2F8"/>
-          </a:solidFill>
-          <a:ln w="6350">
-            <a:solidFill>
-              <a:srgbClr val="0A254E"/>
-            </a:solidFill>
-          </a:ln>
-          <a:effectLst/>
-        </p:spPr>
-        <p:style>
-          <a:lnRef idx="1">
-            <a:schemeClr val="accent1"/>
-          </a:lnRef>
-          <a:fillRef idx="3">
-            <a:schemeClr val="accent1"/>
-          </a:fillRef>
-          <a:effectRef idx="2">
-            <a:schemeClr val="accent1"/>
-          </a:effectRef>
-          <a:fontRef idx="minor">
-            <a:schemeClr val="lt1"/>
-          </a:fontRef>
-        </p:style>
-        <p:txBody>
-          <a:bodyPr rtlCol="0" anchor="ctr" wrap="square" lIns="27432" rIns="27432" tIns="13716" bIns="13716"/>
-          <a:lstStyle/>
-          <a:p>
-            <a:pPr algn="ctr">
-              <a:spcAft>
-                <a:spcPts val="100"/>
-              </a:spcAft>
-            </a:pPr>
-            <a:r>
-              <a:rPr sz="380" b="1" i="0">
-                <a:solidFill>
-                  <a:srgbClr val="111827"/>
-                </a:solidFill>
-                <a:latin typeface="Times New Roman"/>
-              </a:rPr>
-              <a:t>Inclusion Criteria (Arksey &amp; O’Malley, 2005 — scoping review framework)</a:t>
-            </a:r>
-          </a:p>
-          <a:p>
-            <a:pPr algn="ctr">
-              <a:spcAft>
-                <a:spcPts val="50"/>
-              </a:spcAft>
-            </a:pPr>
-            <a:r>
-              <a:rPr sz="360" b="0" i="0">
-                <a:solidFill>
-                  <a:srgbClr val="111827"/>
-                </a:solidFill>
-                <a:latin typeface="Times New Roman"/>
-              </a:rPr>
-              <a:t>✓  Peer-reviewed empirical or qualitative studies, 2010–2025</a:t>
-            </a:r>
-          </a:p>
-          <a:p>
-            <a:pPr algn="ctr">
-              <a:spcAft>
-                <a:spcPts val="50"/>
-              </a:spcAft>
-            </a:pPr>
-            <a:r>
-              <a:rPr sz="360" b="0" i="0">
-                <a:solidFill>
-                  <a:srgbClr val="111827"/>
-                </a:solidFill>
-                <a:latin typeface="Times New Roman"/>
-              </a:rPr>
-              <a:t>✓  PMDD as the primary population</a:t>
-            </a:r>
-          </a:p>
-          <a:p>
-            <a:pPr algn="ctr">
-              <a:spcAft>
-                <a:spcPts val="0"/>
-              </a:spcAft>
-            </a:pPr>
-            <a:r>
-              <a:rPr sz="360" b="0" i="0">
-                <a:solidFill>
-                  <a:srgbClr val="111827"/>
-                </a:solidFill>
-                <a:latin typeface="Times New Roman"/>
-              </a:rPr>
-              <a:t>✓  At least one psychosocial outcome or coping mechanism as a primary aim</a:t>
-            </a:r>
-          </a:p>
-        </p:txBody>
-      </p:sp>
       <p:graphicFrame>
         <p:nvGraphicFramePr>
-          <p:cNvPr id="340" name="Chart 339"/>
+          <p:cNvPr id="339" name="Chart 338"/>
           <p:cNvGraphicFramePr>
             <a:graphicFrameLocks noGrp="1"/>
           </p:cNvGraphicFramePr>
@@ -9780,13 +9671,13 @@
       </p:graphicFrame>
       <p:sp>
         <p:nvSpPr>
-          <p:cNvPr id="341" name="TextBox 340"/>
+          <p:cNvPr id="340" name="TextBox 339"/>
           <p:cNvSpPr txBox="1"/>
           <p:nvPr/>
         </p:nvSpPr>
         <p:spPr>
           <a:xfrm>
-            <a:off x="4754880" y="4297680"/>
+            <a:off x="4754880" y="4389120"/>
             <a:ext cx="2240280" cy="237744"/>
           </a:xfrm>
           <a:prstGeom prst="rect">
@@ -9837,7 +9728,7 @@
       </p:sp>
       <p:pic>
         <p:nvPicPr>
-          <p:cNvPr id="342" name="Picture 341" descr="fig3_map.png"/>
+          <p:cNvPr id="341" name="Picture 340" descr="fig3_map.png"/>
           <p:cNvPicPr>
             <a:picLocks noChangeAspect="1"/>
           </p:cNvPicPr>
@@ -9861,7 +9752,7 @@
       </p:pic>
       <p:sp>
         <p:nvSpPr>
-          <p:cNvPr id="343" name="Rounded Rectangle 342"/>
+          <p:cNvPr id="342" name="Rounded Rectangle 341"/>
           <p:cNvSpPr/>
           <p:nvPr/>
         </p:nvSpPr>
@@ -9970,7 +9861,7 @@
       </p:sp>
       <p:sp>
         <p:nvSpPr>
-          <p:cNvPr id="344" name="TextBox 343"/>
+          <p:cNvPr id="343" name="TextBox 342"/>
           <p:cNvSpPr txBox="1"/>
           <p:nvPr/>
         </p:nvSpPr>
@@ -10002,7 +9893,7 @@
                 </a:solidFill>
                 <a:latin typeface="Times New Roman"/>
               </a:rPr>
-              <a:t>Figure 3. </a:t>
+              <a:t>Figure 4. </a:t>
             </a:r>
             <a:r>
               <a:rPr sz="420" b="1" i="0">
@@ -10027,7 +9918,7 @@
       </p:sp>
       <p:sp>
         <p:nvSpPr>
-          <p:cNvPr id="345" name="Rectangle 344"/>
+          <p:cNvPr id="344" name="Rectangle 343"/>
           <p:cNvSpPr/>
           <p:nvPr/>
         </p:nvSpPr>
@@ -10084,7 +9975,7 @@
       </p:sp>
       <p:sp>
         <p:nvSpPr>
-          <p:cNvPr id="346" name="Rectangle 345"/>
+          <p:cNvPr id="345" name="Rectangle 344"/>
           <p:cNvSpPr/>
           <p:nvPr/>
         </p:nvSpPr>
@@ -10124,11 +10015,11 @@
           <a:p>
             <a:pPr algn="just">
               <a:spcAft>
-                <a:spcPts val="100"/>
+                <a:spcPts val="160"/>
               </a:spcAft>
             </a:pPr>
             <a:r>
-              <a:rPr sz="409" b="1" i="0">
+              <a:rPr sz="445" b="1" i="0">
                 <a:solidFill>
                   <a:srgbClr val="111827"/>
                 </a:solidFill>
@@ -10140,59 +10031,59 @@
           <a:p>
             <a:pPr algn="just">
               <a:spcAft>
-                <a:spcPts val="100"/>
+                <a:spcPts val="160"/>
               </a:spcAft>
             </a:pPr>
             <a:r>
-              <a:rPr sz="409" b="0" i="0">
+              <a:rPr sz="445" b="0" i="0">
                 <a:solidFill>
                   <a:srgbClr val="111827"/>
                 </a:solidFill>
                 <a:latin typeface="Times New Roman"/>
               </a:rPr>
-              <a:t>The database search identified 1,943 records. After 325 duplicates were removed, 1,618 records were screened by title and abstract; 64 were assessed for eligibility, 20 were excluded, and 44 studies were included (Figure 1). Most (61%) were published in 2022–2025 (Figure 4).</a:t>
+              <a:t>The database search identified 1,943 records. After 325 duplicates were removed, 1,618 records were screened by title and abstract; 64 were assessed for eligibility, 20 were excluded, and 44 studies were included (Figure 1).</a:t>
             </a:r>
           </a:p>
           <a:p>
             <a:pPr algn="just">
               <a:spcAft>
-                <a:spcPts val="100"/>
+                <a:spcPts val="160"/>
               </a:spcAft>
             </a:pPr>
             <a:r>
-              <a:rPr sz="409" b="0" i="0">
+              <a:rPr sz="445" b="0" i="0">
                 <a:solidFill>
                   <a:srgbClr val="111827"/>
                 </a:solidFill>
                 <a:latin typeface="Times New Roman"/>
               </a:rPr>
-              <a:t>Depression was the most documented outcome (n=39); one nationwide cohort found a 2.6-fold higher risk of later depression after a PMDD diagnosis.¹³ Psychological distress (n=24), interpersonal functioning (n=18), suicidal ideation or self-harm (n=14) and quality of life (n=14) followed. Only three studies examined coping mechanisms, such as peer support shared in online PMDD communities¹⁴ (Figure 2).</a:t>
+              <a:t>Depression was the most documented outcome (n=39); one nationwide cohort found a 2.6-fold higher risk of later depression after a PMDD diagnosis.¹³ Psychological distress (n=24), interpersonal functioning (n=18), suicidal ideation or self-harm (n=14) and quality of life (n=14) followed. Only three studies examined coping mechanisms, such as peer support shared in online PMDD communities¹⁴ (Figure 2). Most studies (61%) were published in 2022–2025 (Figure 3).</a:t>
             </a:r>
           </a:p>
           <a:p>
             <a:pPr algn="just">
               <a:spcAft>
-                <a:spcPts val="100"/>
+                <a:spcPts val="160"/>
               </a:spcAft>
             </a:pPr>
             <a:r>
-              <a:rPr sz="409" b="0" i="0">
+              <a:rPr sz="445" b="0" i="0">
                 <a:solidFill>
                   <a:srgbClr val="111827"/>
                 </a:solidFill>
                 <a:latin typeface="Times New Roman"/>
               </a:rPr>
-              <a:t>Twenty studies came from high-income countries and seven from upper-middle-income countries (Türkiye, Iran); only three (6.8%) came from low- and lower-middle-income countries—Bangladesh,¹⁵ Lebanon¹⁶ and Nigeria,¹⁷ the only study from sub-Saharan Africa (Figure 3).</a:t>
+              <a:t>Twenty studies came from high-income countries and seven from upper-middle-income countries (Türkiye, Iran); only three (6.8%) came from low- and lower-middle-income countries—Bangladesh,¹⁵ Lebanon¹⁶ and Nigeria,¹⁷ the only study from sub-Saharan Africa (Figure 4).</a:t>
             </a:r>
           </a:p>
           <a:p>
             <a:pPr algn="just">
               <a:spcAft>
-                <a:spcPts val="100"/>
+                <a:spcPts val="160"/>
               </a:spcAft>
             </a:pPr>
             <a:r>
-              <a:rPr sz="409" b="1" i="0">
+              <a:rPr sz="445" b="1" i="0">
                 <a:solidFill>
                   <a:srgbClr val="111827"/>
                 </a:solidFill>
@@ -10204,11 +10095,11 @@
           <a:p>
             <a:pPr algn="just">
               <a:spcAft>
-                <a:spcPts val="100"/>
+                <a:spcPts val="160"/>
               </a:spcAft>
             </a:pPr>
             <a:r>
-              <a:rPr sz="409" b="0" i="0">
+              <a:rPr sz="445" b="0" i="0">
                 <a:solidFill>
                   <a:srgbClr val="111827"/>
                 </a:solidFill>
@@ -10220,11 +10111,11 @@
           <a:p>
             <a:pPr algn="just">
               <a:spcAft>
-                <a:spcPts val="100"/>
+                <a:spcPts val="160"/>
               </a:spcAft>
             </a:pPr>
             <a:r>
-              <a:rPr sz="409" b="1" i="0">
+              <a:rPr sz="445" b="1" i="0">
                 <a:solidFill>
                   <a:srgbClr val="111827"/>
                 </a:solidFill>
@@ -10236,11 +10127,11 @@
           <a:p>
             <a:pPr algn="just">
               <a:spcAft>
-                <a:spcPts val="100"/>
+                <a:spcPts val="160"/>
               </a:spcAft>
             </a:pPr>
             <a:r>
-              <a:rPr sz="409" b="0" i="0">
+              <a:rPr sz="445" b="0" i="0">
                 <a:solidFill>
                   <a:srgbClr val="111827"/>
                 </a:solidFill>
@@ -10252,11 +10143,11 @@
           <a:p>
             <a:pPr algn="just">
               <a:spcAft>
-                <a:spcPts val="100"/>
+                <a:spcPts val="160"/>
               </a:spcAft>
             </a:pPr>
             <a:r>
-              <a:rPr sz="409" b="1" i="0">
+              <a:rPr sz="445" b="1" i="0">
                 <a:solidFill>
                   <a:srgbClr val="111827"/>
                 </a:solidFill>
@@ -10268,13 +10159,13 @@
           <a:p>
             <a:pPr algn="just" marL="73152" indent="-64008">
               <a:spcAft>
-                <a:spcPts val="100"/>
+                <a:spcPts val="160"/>
               </a:spcAft>
               <a:buFont typeface="Arial"/>
               <a:buChar char="•"/>
             </a:pPr>
             <a:r>
-              <a:rPr sz="409" b="1" i="0">
+              <a:rPr sz="445" b="1" i="0">
                 <a:solidFill>
                   <a:srgbClr val="111827"/>
                 </a:solidFill>
@@ -10283,7 +10174,7 @@
               <a:t>Search scope: </a:t>
             </a:r>
             <a:r>
-              <a:rPr sz="409" b="0" i="0">
+              <a:rPr sz="445" b="0" i="0">
                 <a:solidFill>
                   <a:srgbClr val="111827"/>
                 </a:solidFill>
@@ -10295,13 +10186,13 @@
           <a:p>
             <a:pPr algn="just" marL="73152" indent="-64008">
               <a:spcAft>
-                <a:spcPts val="100"/>
+                <a:spcPts val="160"/>
               </a:spcAft>
               <a:buFont typeface="Arial"/>
               <a:buChar char="•"/>
             </a:pPr>
             <a:r>
-              <a:rPr sz="409" b="1" i="0">
+              <a:rPr sz="445" b="1" i="0">
                 <a:solidFill>
                   <a:srgbClr val="111827"/>
                 </a:solidFill>
@@ -10310,7 +10201,7 @@
               <a:t>Study differences: </a:t>
             </a:r>
             <a:r>
-              <a:rPr sz="409" b="0" i="0">
+              <a:rPr sz="445" b="0" i="0">
                 <a:solidFill>
                   <a:srgbClr val="111827"/>
                 </a:solidFill>
@@ -10322,13 +10213,13 @@
           <a:p>
             <a:pPr algn="just" marL="73152" indent="-64008">
               <a:spcAft>
-                <a:spcPts val="100"/>
+                <a:spcPts val="160"/>
               </a:spcAft>
               <a:buFont typeface="Arial"/>
               <a:buChar char="•"/>
             </a:pPr>
             <a:r>
-              <a:rPr sz="409" b="1" i="0">
+              <a:rPr sz="445" b="1" i="0">
                 <a:solidFill>
                   <a:srgbClr val="111827"/>
                 </a:solidFill>
@@ -10337,7 +10228,7 @@
               <a:t>Coding overlap: </a:t>
             </a:r>
             <a:r>
-              <a:rPr sz="409" b="0" i="0">
+              <a:rPr sz="445" b="0" i="0">
                 <a:solidFill>
                   <a:srgbClr val="111827"/>
                 </a:solidFill>
@@ -10349,13 +10240,13 @@
           <a:p>
             <a:pPr algn="just" marL="73152" indent="-64008">
               <a:spcAft>
-                <a:spcPts val="100"/>
+                <a:spcPts val="160"/>
               </a:spcAft>
               <a:buFont typeface="Arial"/>
               <a:buChar char="•"/>
             </a:pPr>
             <a:r>
-              <a:rPr sz="409" b="1" i="0">
+              <a:rPr sz="445" b="1" i="0">
                 <a:solidFill>
                   <a:srgbClr val="111827"/>
                 </a:solidFill>
@@ -10364,7 +10255,7 @@
               <a:t>Geographic coverage: </a:t>
             </a:r>
             <a:r>
-              <a:rPr sz="409" b="0" i="0">
+              <a:rPr sz="445" b="0" i="0">
                 <a:solidFill>
                   <a:srgbClr val="111827"/>
                 </a:solidFill>
@@ -10377,7 +10268,7 @@
       </p:sp>
       <p:sp>
         <p:nvSpPr>
-          <p:cNvPr id="347" name="Rectangle 346"/>
+          <p:cNvPr id="346" name="Rectangle 345"/>
           <p:cNvSpPr/>
           <p:nvPr/>
         </p:nvSpPr>
@@ -10434,7 +10325,7 @@
       </p:sp>
       <p:sp>
         <p:nvSpPr>
-          <p:cNvPr id="348" name="Rectangle 347"/>
+          <p:cNvPr id="347" name="Rectangle 346"/>
           <p:cNvSpPr/>
           <p:nvPr/>
         </p:nvSpPr>
@@ -10696,7 +10587,7 @@
       </p:sp>
       <p:sp>
         <p:nvSpPr>
-          <p:cNvPr id="349" name="Rectangle 348"/>
+          <p:cNvPr id="348" name="Rectangle 347"/>
           <p:cNvSpPr/>
           <p:nvPr/>
         </p:nvSpPr>
@@ -10753,7 +10644,7 @@
       </p:sp>
       <p:sp>
         <p:nvSpPr>
-          <p:cNvPr id="350" name="Rounded Rectangle 349"/>
+          <p:cNvPr id="349" name="Rounded Rectangle 348"/>
           <p:cNvSpPr/>
           <p:nvPr/>
         </p:nvSpPr>
@@ -10821,15 +10712,15 @@
       </p:sp>
       <p:graphicFrame>
         <p:nvGraphicFramePr>
-          <p:cNvPr id="351" name="Chart 350"/>
+          <p:cNvPr id="350" name="Chart 349"/>
           <p:cNvGraphicFramePr>
             <a:graphicFrameLocks noGrp="1"/>
           </p:cNvGraphicFramePr>
           <p:nvPr/>
         </p:nvGraphicFramePr>
         <p:xfrm>
-          <a:off x="7199071" y="3419856"/>
-          <a:ext cx="1752904" cy="457200"/>
+          <a:off x="2505456" y="3968496"/>
+          <a:ext cx="2103120" cy="420624"/>
         </p:xfrm>
         <a:graphic>
           <a:graphicData uri="http://schemas.openxmlformats.org/drawingml/2006/chart">
@@ -10839,14 +10730,14 @@
       </p:graphicFrame>
       <p:sp>
         <p:nvSpPr>
-          <p:cNvPr id="352" name="TextBox 351"/>
+          <p:cNvPr id="351" name="TextBox 350"/>
           <p:cNvSpPr txBox="1"/>
           <p:nvPr/>
         </p:nvSpPr>
         <p:spPr>
           <a:xfrm>
-            <a:off x="7162495" y="3877056"/>
-            <a:ext cx="1826056" cy="164592"/>
+            <a:off x="2414016" y="4389120"/>
+            <a:ext cx="2258568" cy="164592"/>
           </a:xfrm>
           <a:prstGeom prst="rect">
             <a:avLst/>
@@ -10865,16 +10756,16 @@
               </a:spcAft>
             </a:pPr>
             <a:r>
-              <a:rPr sz="380" b="1" i="0">
+              <a:rPr sz="420" b="1" i="0">
                 <a:solidFill>
                   <a:srgbClr val="0A254E"/>
                 </a:solidFill>
                 <a:latin typeface="Times New Roman"/>
               </a:rPr>
-              <a:t>Figure 4. </a:t>
-            </a:r>
-            <a:r>
-              <a:rPr sz="380" b="1" i="0">
+              <a:t>Figure 3. </a:t>
+            </a:r>
+            <a:r>
+              <a:rPr sz="420" b="1" i="0">
                 <a:solidFill>
                   <a:srgbClr val="0A254E"/>
                 </a:solidFill>
@@ -10883,7 +10774,7 @@
               <a:t>Included Studies by Publication Period.</a:t>
             </a:r>
             <a:r>
-              <a:rPr sz="380" b="0" i="0">
+              <a:rPr sz="420" b="0" i="0">
                 <a:solidFill>
                   <a:srgbClr val="111827"/>
                 </a:solidFill>

</xml_diff>

<commit_message>
Tidy Figure 3 chart proportions and caption
Co-Authored-By: Claude Opus 5.5 <noreply@anthropic.com>
Claude-Session: https://claude.ai/code/session_01VkRRDHxfMApHVBQgQibkFd
</commit_message>
<xml_diff>
--- a/PMDD_Scoping_Review/PMDD_APHA_Poster_FINAL.pptx
+++ b/PMDD_Scoping_Review/PMDD_APHA_Poster_FINAL.pptx
@@ -237,7 +237,7 @@
         </c:scaling>
         <c:delete val="0"/>
         <c:axPos val="l"/>
-        <c:majorTickMark val="out"/>
+        <c:majorTickMark val="none"/>
         <c:minorTickMark val="none"/>
         <c:tickLblPos val="nextTo"/>
         <c:spPr>
@@ -400,7 +400,7 @@
           <c:showBubbleSize val="0"/>
           <c:showLeaderLines val="1"/>
         </c:dLbls>
-        <c:gapWidth val="45"/>
+        <c:gapWidth val="70"/>
         <c:axId val="-2068027336"/>
         <c:axId val="-2113994440"/>
       </c:barChart>
@@ -411,7 +411,7 @@
         </c:scaling>
         <c:delete val="0"/>
         <c:axPos val="b"/>
-        <c:majorTickMark val="out"/>
+        <c:majorTickMark val="none"/>
         <c:minorTickMark val="none"/>
         <c:tickLblPos val="nextTo"/>
         <c:spPr>
@@ -440,7 +440,7 @@
       <c:valAx>
         <c:axId val="-2113994440"/>
         <c:scaling>
-          <c:max val="32.0"/>
+          <c:max val="30.0"/>
           <c:min val="0.0"/>
         </c:scaling>
         <c:delete/>
@@ -10751,8 +10751,8 @@
           <p:nvPr/>
         </p:nvGraphicFramePr>
         <p:xfrm>
-          <a:off x="2505456" y="3968496"/>
-          <a:ext cx="2103120" cy="420624"/>
+          <a:off x="2505456" y="3913632"/>
+          <a:ext cx="2103120" cy="493776"/>
         </p:xfrm>
         <a:graphic>
           <a:graphicData uri="http://schemas.openxmlformats.org/drawingml/2006/chart">
@@ -10812,7 +10812,7 @@
                 </a:solidFill>
                 <a:latin typeface="Times New Roman"/>
               </a:rPr>
-              <a:t> 27 of 44 studies (61%) were published in 2022–2025.</a:t>
+              <a:t> 61% (27 of 44) were published in 2022–2025.</a:t>
             </a:r>
           </a:p>
         </p:txBody>

</xml_diff>

<commit_message>
Plain-language wording pass on poster text
Co-Authored-By: Claude Opus 5.5 <noreply@anthropic.com>
Claude-Session: https://claude.ai/code/session_01VkRRDHxfMApHVBQgQibkFd
</commit_message>
<xml_diff>
--- a/PMDD_Scoping_Review/PMDD_APHA_Poster_FINAL.pptx
+++ b/PMDD_Scoping_Review/PMDD_APHA_Poster_FINAL.pptx
@@ -7495,7 +7495,7 @@
                 </a:solidFill>
                 <a:latin typeface="Times New Roman"/>
               </a:rPr>
-              <a:t>PMDD is a recurring, hormone-linked mood disorder in which irritability, mood swings, depressed mood and anxiety emerge in the late luteal phase and remit after menses begin. It is classified as a depressive disorder in DSM-5² and recognized in ICD-11.³ Using prospectively confirmed diagnoses, community prevalence is about 1.6%, roughly 31 million women and girls worldwide.¹ PMDD has been linked with suicidal ideation and attempts,⁴˒⁵ strained romantic relationships⁶ and reduced quality of life.⁷ Premenstrual symptoms are also common across Africa, where pooled premenstrual syndrome prevalence reaches 47%,⁸ yet it remains unclear how women with PMDD cope or where the evidence has been generated.</a:t>
+              <a:t>PMDD is a recurring, hormone-linked mood disorder in which irritability, mood swings, depressed mood and anxiety emerge in the late luteal phase and remit after menses begin. It is classified as a depressive disorder in DSM-5² and recognized in ICD-11.³ Based on prospectively confirmed diagnoses, community prevalence is about 1.6%, roughly 31 million women and girls worldwide.¹ PMDD has been linked with suicidal ideation and attempts,⁴˒⁵ strained romantic relationships⁶ and reduced quality of life.⁷ Premenstrual symptoms are also common across Africa, where pooled premenstrual syndrome prevalence reaches 47%,⁸ yet it remains unclear how women with PMDD cope or where the evidence has been generated.</a:t>
             </a:r>
           </a:p>
           <a:p>
@@ -10073,7 +10073,7 @@
                 </a:solidFill>
                 <a:latin typeface="Times New Roman"/>
               </a:rPr>
-              <a:t>Twenty studies came from high-income countries and seven from upper-middle-income countries (Türkiye, Iran); only three (6.8%) came from low- and lower-middle-income countries—Bangladesh,¹⁵ Lebanon¹⁶ and Nigeria,¹⁷ the only study from sub-Saharan Africa (Figure 4).</a:t>
+              <a:t>Twenty studies came from high-income countries and seven from upper-middle-income countries (Türkiye, Iran); only three (6.8%) came from low- and lower-middle-income countries: Bangladesh,¹⁵ Lebanon¹⁶ and Nigeria,¹⁷ the only study from sub-Saharan Africa (Figure 4).</a:t>
             </a:r>
           </a:p>
           <a:p>
@@ -10105,7 +10105,7 @@
                 </a:solidFill>
                 <a:latin typeface="Times New Roman"/>
               </a:rPr>
-              <a:t>The focus on depression and distress mirrors population studies linking PMDD to depression, suicidal ideation and suicide attempts.⁴⁻⁷ Coping, by contrast, appeared in only three studies, so little is known about how women manage symptoms day to day or which supports help.</a:t>
+              <a:t>The focus on depression and distress is consistent with population studies linking PMDD to depression, suicidal ideation and suicide attempts.⁴⁻⁷ However, only three studies examined coping, so little is known about how women manage symptoms day to day or which supports help.</a:t>
             </a:r>
           </a:p>
           <a:p>
@@ -10121,7 +10121,7 @@
                 </a:solidFill>
                 <a:latin typeface="Times New Roman"/>
               </a:rPr>
-              <a:t>Evidence is also concentrated in high-income countries. Premenstrual symptoms are common across Africa,⁸ so a single sub-Saharan study likely reflects under-study rather than low burden. Stigma, limited mental health services and local explanations of menstrual distress may shape both burden and coping in these settings.</a:t>
+              <a:t>Evidence is also concentrated in high-income countries. Premenstrual symptoms are common across Africa,⁸ so having only one study from sub-Saharan Africa likely reflects limited research rather than low burden. Stigma, limited mental health services and local explanations of menstrual distress may shape both burden and coping in these settings.</a:t>
             </a:r>
           </a:p>
           <a:p>
@@ -10169,7 +10169,7 @@
                 </a:solidFill>
                 <a:latin typeface="Times New Roman"/>
               </a:rPr>
-              <a:t>PMDD carries a well-documented psychosocial burden, especially depression, distress and suicidality, yet how women cope has received little attention, and evidence from low-income settings and Africa is nearly absent. Culturally responsive screening, integrated mental and reproductive health services, and Africa-centered research investment are needed to make this burden visible to health systems.</a:t>
+              <a:t>PMDD carries a well-documented psychosocial burden, especially depression, distress and suicidality, yet how women cope has received little attention, and evidence from low-income settings and Africa is nearly absent. Culturally responsive screening, integrated mental and reproductive health services, and more research in African settings are needed so health systems can respond.</a:t>
             </a:r>
           </a:p>
           <a:p>
@@ -10240,33 +10240,6 @@
                 <a:latin typeface="Times New Roman"/>
               </a:rPr>
               <a:t>variation in design and outcome definitions limits direct comparison.</a:t>
-            </a:r>
-          </a:p>
-          <a:p>
-            <a:pPr algn="just" marL="73152" indent="-64008">
-              <a:spcAft>
-                <a:spcPts val="120"/>
-              </a:spcAft>
-              <a:buFont typeface="Arial"/>
-              <a:buChar char="•"/>
-            </a:pPr>
-            <a:r>
-              <a:rPr sz="420" b="1" i="0">
-                <a:solidFill>
-                  <a:srgbClr val="111827"/>
-                </a:solidFill>
-                <a:latin typeface="Times New Roman"/>
-              </a:rPr>
-              <a:t>Coding overlap: </a:t>
-            </a:r>
-            <a:r>
-              <a:rPr sz="420" b="0" i="0">
-                <a:solidFill>
-                  <a:srgbClr val="111827"/>
-                </a:solidFill>
-                <a:latin typeface="Times New Roman"/>
-              </a:rPr>
-              <a:t>a study could address more than one outcome, so counts should not be summed.</a:t>
             </a:r>
           </a:p>
           <a:p>
@@ -10737,7 +10710,7 @@
                 </a:solidFill>
                 <a:latin typeface="Times New Roman"/>
               </a:rPr>
-              <a:t>PMDD’s psychosocial burden is well documented in high-income countries, yet nearly invisible in low-income settings and sub-Saharan Africa.</a:t>
+              <a:t>PMDD’s psychosocial burden is well documented in high-income countries, but rarely studied in low-income settings and sub-Saharan Africa.</a:t>
             </a:r>
           </a:p>
         </p:txBody>

</xml_diff>

<commit_message>
Align poster abstract wording with poster body
Co-Authored-By: Claude Opus 5.5 <noreply@anthropic.com>
Claude-Session: https://claude.ai/code/session_01VkRRDHxfMApHVBQgQibkFd
</commit_message>
<xml_diff>
--- a/PMDD_Scoping_Review/PMDD_APHA_Poster_FINAL.pptx
+++ b/PMDD_Scoping_Review/PMDD_APHA_Poster_FINAL.pptx
@@ -7257,7 +7257,7 @@
               </a:spcAft>
             </a:pPr>
             <a:r>
-              <a:rPr sz="430" b="1" i="0">
+              <a:rPr sz="420" b="1" i="0">
                 <a:solidFill>
                   <a:srgbClr val="111827"/>
                 </a:solidFill>
@@ -7266,7 +7266,7 @@
               <a:t>Background: </a:t>
             </a:r>
             <a:r>
-              <a:rPr sz="430" b="0" i="0">
+              <a:rPr sz="420" b="0" i="0">
                 <a:solidFill>
                   <a:srgbClr val="111827"/>
                 </a:solidFill>
@@ -7282,7 +7282,7 @@
               </a:spcAft>
             </a:pPr>
             <a:r>
-              <a:rPr sz="430" b="1" i="0">
+              <a:rPr sz="420" b="1" i="0">
                 <a:solidFill>
                   <a:srgbClr val="111827"/>
                 </a:solidFill>
@@ -7291,7 +7291,7 @@
               <a:t>Methods: </a:t>
             </a:r>
             <a:r>
-              <a:rPr sz="430" b="0" i="0">
+              <a:rPr sz="420" b="0" i="0">
                 <a:solidFill>
                   <a:srgbClr val="111827"/>
                 </a:solidFill>
@@ -7307,7 +7307,7 @@
               </a:spcAft>
             </a:pPr>
             <a:r>
-              <a:rPr sz="430" b="1" i="0">
+              <a:rPr sz="420" b="1" i="0">
                 <a:solidFill>
                   <a:srgbClr val="111827"/>
                 </a:solidFill>
@@ -7316,13 +7316,13 @@
               <a:t>Results: </a:t>
             </a:r>
             <a:r>
-              <a:rPr sz="430" b="0" i="0">
+              <a:rPr sz="420" b="0" i="0">
                 <a:solidFill>
                   <a:srgbClr val="111827"/>
                 </a:solidFill>
                 <a:latin typeface="Times New Roman"/>
               </a:rPr>
-              <a:t>The search identified 1,943 records; 1,618 remained after deduplication and 44 studies met the inclusion criteria. Depression was most documented (n=39), followed by psychological distress (n=24), interpersonal functioning (n=18), suicidal ideation or self-harm (n=14) and quality of life (n=14). Only three studies examined coping mechanisms. Only three studies (6.8%) originated from low- and lower-middle-income countries, including one from Nigeria.</a:t>
+              <a:t>Of 1,943 records, 1,618 were screened after deduplication, 64 were assessed for eligibility and 44 were included. Depression was most documented (n=39), followed by psychological distress (n=24), interpersonal functioning (n=18), suicidal ideation or self-harm (n=14) and quality of life (n=14). Only three studies examined coping mechanisms. Three studies (6.8%) came from low- and lower-middle-income countries (Bangladesh, Lebanon, Nigeria); Nigeria was the only sub-Saharan African setting.</a:t>
             </a:r>
           </a:p>
           <a:p>
@@ -7332,7 +7332,7 @@
               </a:spcAft>
             </a:pPr>
             <a:r>
-              <a:rPr sz="430" b="1" i="0">
+              <a:rPr sz="420" b="1" i="0">
                 <a:solidFill>
                   <a:srgbClr val="111827"/>
                 </a:solidFill>
@@ -7341,13 +7341,13 @@
               <a:t>Conclusions: </a:t>
             </a:r>
             <a:r>
-              <a:rPr sz="430" b="0" i="0">
+              <a:rPr sz="420" b="0" i="0">
                 <a:solidFill>
                   <a:srgbClr val="111827"/>
                 </a:solidFill>
                 <a:latin typeface="Times New Roman"/>
               </a:rPr>
-              <a:t>Evidence on PMDD’s psychosocial burden is growing but geographically concentrated in high-income countries, revealing a critical LMIC evidence gap.</a:t>
+              <a:t>Evidence on PMDD’s psychosocial burden is growing but concentrated in high-income countries; coping and evidence from low-income settings and sub-Saharan Africa remain scarce.</a:t>
             </a:r>
           </a:p>
           <a:p>
@@ -7357,7 +7357,7 @@
               </a:spcAft>
             </a:pPr>
             <a:r>
-              <a:rPr sz="430" b="1" i="0">
+              <a:rPr sz="420" b="1" i="0">
                 <a:solidFill>
                   <a:srgbClr val="111827"/>
                 </a:solidFill>
@@ -7366,13 +7366,13 @@
               <a:t>Keywords: </a:t>
             </a:r>
             <a:r>
-              <a:rPr sz="430" b="0" i="1">
+              <a:rPr sz="420" b="0" i="1">
                 <a:solidFill>
                   <a:srgbClr val="111827"/>
                 </a:solidFill>
                 <a:latin typeface="Times New Roman"/>
               </a:rPr>
-              <a:t>premenstrual dysphoric disorder; psychosocial outcomes; coping mechanisms; LMICs; scoping review</a:t>
+              <a:t>premenstrual dysphoric disorder; psychosocial outcomes; coping mechanisms; global health; scoping review</a:t>
             </a:r>
           </a:p>
         </p:txBody>

</xml_diff>

<commit_message>
Remove abstract citation, renumber references 1-3 in order of first mention, italicize reference titles
Co-Authored-By: Claude Opus 5.5 <noreply@anthropic.com>
Claude-Session: https://claude.ai/code/session_01VkRRDHxfMApHVBQgQibkFd
</commit_message>
<xml_diff>
--- a/PMDD_Scoping_Review/PMDD_APHA_Poster_FINAL.pptx
+++ b/PMDD_Scoping_Review/PMDD_APHA_Poster_FINAL.pptx
@@ -7272,7 +7272,7 @@
                 </a:solidFill>
                 <a:latin typeface="Times New Roman"/>
               </a:rPr>
-              <a:t>Premenstrual dysphoric disorder (PMDD) is a DSM-5 depressive disorder affecting an estimated 31 million women and girls worldwide.¹ This scoping review examined psychosocial outcomes and coping mechanisms among women with PMDD and assessed the geographic distribution of the evidence.</a:t>
+              <a:t>Premenstrual dysphoric disorder (PMDD) is a DSM-5 depressive disorder affecting an estimated 31 million women and girls worldwide. This scoping review examined psychosocial outcomes and coping mechanisms among women with PMDD and assessed the geographic distribution of the evidence.</a:t>
             </a:r>
           </a:p>
           <a:p>
@@ -7495,7 +7495,7 @@
                 </a:solidFill>
                 <a:latin typeface="Times New Roman"/>
               </a:rPr>
-              <a:t>PMDD is a recurring, hormone-linked mood disorder in which irritability, mood swings, depressed mood and anxiety emerge in the late luteal phase and remit after menses begin. It is classified as a depressive disorder in DSM-5² and recognized in ICD-11.³ Based on prospectively confirmed diagnoses, community prevalence is about 1.6%, roughly 31 million women and girls worldwide.¹ PMDD has been linked with suicidal ideation and attempts,⁴˒⁵ strained romantic relationships⁶ and reduced quality of life.⁷ Premenstrual symptoms are also common across Africa, where pooled premenstrual syndrome prevalence reaches 47%,⁸ yet it remains unclear how women with PMDD cope or where the evidence has been generated.</a:t>
+              <a:t>PMDD is a recurring, hormone-linked mood disorder in which irritability, mood swings, depressed mood and anxiety emerge in the late luteal phase and remit after menses begin. It is classified as a depressive disorder in DSM-5¹ and recognized in ICD-11.² Based on prospectively confirmed diagnoses, community prevalence is about 1.6%, roughly 31 million women and girls worldwide.³ PMDD has been linked with suicidal ideation and attempts,⁴˒⁵ strained romantic relationships⁶ and reduced quality of life.⁷ Premenstrual symptoms are also common across Africa, where pooled premenstrual syndrome prevalence reaches 47%,⁸ yet it remains unclear how women with PMDD cope or where the evidence has been generated.</a:t>
             </a:r>
           </a:p>
           <a:p>
@@ -10137,7 +10137,7 @@
                 </a:solidFill>
                 <a:latin typeface="Times New Roman"/>
               </a:rPr>
-              <a:t>Patients describe misdiagnosis and uneven provider knowledge,¹⁸˒¹⁹ and many turn to online peer communities for support.¹⁴ Because much PMDD research relies on provisional rather than prospectively confirmed diagnosis,¹ future studies should pair confirmed diagnosis with measures of coping and help-seeking.</a:t>
+              <a:t>Patients describe misdiagnosis and uneven provider knowledge,¹⁸˒¹⁹ and many turn to online peer communities for support.¹⁴ Because much PMDD research relies on provisional rather than prospectively confirmed diagnosis,³ future studies should pair confirmed diagnosis with measures of coping and help-seeking.</a:t>
             </a:r>
           </a:p>
           <a:p>
@@ -10531,7 +10531,7 @@
                 </a:solidFill>
                 <a:latin typeface="Times New Roman"/>
               </a:rPr>
-              <a:t>using validated daily ratings.¹˒²⁰</a:t>
+              <a:t>using validated daily ratings.³˒²⁰</a:t>
             </a:r>
           </a:p>
           <a:p>

</xml_diff>

<commit_message>
Clarify Figure 4 caption on poster and manuscript
Co-Authored-By: Claude Opus 5.5 <noreply@anthropic.com>
Claude-Session: https://claude.ai/code/session_01VkRRDHxfMApHVBQgQibkFd
</commit_message>
<xml_diff>
--- a/PMDD_Scoping_Review/PMDD_APHA_Poster_FINAL.pptx
+++ b/PMDD_Scoping_Review/PMDD_APHA_Poster_FINAL.pptx
@@ -9902,7 +9902,7 @@
                 </a:solidFill>
                 <a:latin typeface="Times New Roman"/>
               </a:rPr>
-              <a:t>Country Setting and World Bank Income Group of Included Studies.</a:t>
+              <a:t>Where the Included Studies Were Conducted, by Country Income Group.</a:t>
             </a:r>
             <a:r>
               <a:rPr sz="420" b="0" i="0">
@@ -9911,7 +9911,7 @@
                 </a:solidFill>
                 <a:latin typeface="Times New Roman"/>
               </a:rPr>
-              <a:t> Map shows the 30 studies with an identifiable country setting; income groups follow the World Bank FY2027 classification.¹² The other 14 used online or multinational samples or had no single mappable setting in the available records. *Includes Hong Kong (1).</a:t>
+              <a:t> Shows the 30 studies with a known country; the other 14 used online or multinational samples or did not report a location. Colors show each country’s World Bank income group, a standard ranking of countries by average income.¹² *Includes 1 study from Hong Kong.</a:t>
             </a:r>
           </a:p>
         </p:txBody>

</xml_diff>